<commit_message>
feat: add run archiving, cleanup stale files, fix encoding
- New tool: archive_run.py — copies completed run to output/runs/{timestamp}/ and
  updates output/latest/ as stable pointer to most recent run
- Removed stale legacy files: *_draft.md, regional_draft_current.md, test retries
- Fixed audit_logger.py to write UTF-8 explicitly (prevents recurring decode errors)
- Hardened build_dashboard.py trace reader with errors='replace' for Windows encoding
- Updated run-crq.md Phase 5 to archive after manifest assembly
- Updated CLAUDE.md with archive tool docs and new output directory structure
- Added output/runs/ and output/latest/ to .gitignore (generated state)

Co-Authored-By: Claude Opus 4.6 <noreply@anthropic.com>
</commit_message>
<xml_diff>
--- a/output/board_report.pptx
+++ b/output/board_report.pptx
@@ -8,6 +8,7 @@
     <p:sldId id="256" r:id="rId7"/>
     <p:sldId id="257" r:id="rId8"/>
     <p:sldId id="258" r:id="rId9"/>
+    <p:sldId id="259" r:id="rId10"/>
   </p:sldIdLst>
   <p:sldSz cx="9144000" cy="6858000" type="screen4x3"/>
   <p:notesSz cx="6858000" cy="9144000"/>
@@ -3192,7 +3193,7 @@
           <a:lstStyle/>
           <a:p>
             <a:r>
-              <a:t>AeroGrid Wind Solutions faces a total quantified risk exposure of $44,700,000 across three active operational regions, with the gravest concentration in North America where criminal actors are directly targeting wind farm telemetry and remote maintenance infrastructure. Across all active regions, the threat patterns converge on a common business impact: disruption of operational continuity in both the manufacturing and service segments that define AeroGrid's revenue model. The combination of IP exfiltration risk in APAC, service-disrupting encryption in AME, and insider-enabled espionage in MED creates a compound exposure across the 75% manufacturing and 25% service lines of business. The board should treat this as an enterprise-wide risk posture requiring validated recovery capabilities and governance controls proportionate to the $44,700,000 financial exposure ceiling.</a:t>
+              <a:t>AeroGrid Wind Solutions faces $44.7M in aggregate risk exposure across three operational regions, driven by financially motivated disruption campaigns in North America, state-directed supply chain interference in Asia-Pacific, and elevated insider risk in the Mediterranean. Ransomware and system intrusion together represent the two highest-impact scenario types globally, directly threatening turbine manufacturing continuity and remote service delivery. The convergence of production disruption, intellectual property loss, and service revenue erosion across all three regions signals a systemic pattern that could impair both the manufacturing core (75% of revenue) and the global maintenance business simultaneously.</a:t>
             </a:r>
           </a:p>
           <a:p>
@@ -3236,7 +3237,7 @@
           <a:lstStyle/>
           <a:p>
             <a:r>
-              <a:t>Regional Threat Landscape</a:t>
+              <a:t>Escalated Regions</a:t>
             </a:r>
           </a:p>
         </p:txBody>
@@ -3257,32 +3258,32 @@
           <a:lstStyle/>
           <a:p>
             <a:r>
+              <a:t>### AME — $22,000,000 at Risk | Severity: Critical</a:t>
+            </a:r>
+          </a:p>
+          <a:p>
+            <a:r>
+              <a:t>**Primary Scenario:** Ransomware</a:t>
+            </a:r>
+          </a:p>
+          <a:p>
+            <a:r>
+              <a:t>Financially motivated syndicates are targeting energy service providers, placing wind farm telemetry and remote maintenance scheduling at direct risk. Ransomware carries the highest financial impact rank globally at 37.6%, and the $22M exposure reflects recovery costs, service-level agreement breaches, and lost service revenue that would degrade AeroGrid's maintenance business across North American operations.</a:t>
+            </a:r>
+          </a:p>
+          <a:p>
+            <a:r>
               <a:t>### APAC — $18,500,000 at Risk | Severity: High</a:t>
             </a:r>
           </a:p>
           <a:p>
             <a:r>
-              <a:t>**Scenario Types:** System intrusion</a:t>
-            </a:r>
-          </a:p>
-          <a:p>
-            <a:r>
-              <a:t>State-aligned actors operating across the South China Sea corridor are actively pursuing access to AeroGrid's proprietary turbine aerodynamic designs and blade manufacturing environments, representing a direct threat to the company's core intellectual property and production continuity. A successful intrusion could erode AeroGrid's competitive differentiation in a market where turbine efficiency margins determine contract awards, while simultaneous disruption to manufacturing control environments risks cascading delivery failures and contractual penalties with government-backed energy clients. The $18,500,000 VaCR exposure reflects the quantified ceiling of financial impact under current threat conditions and geopolitical posture.</a:t>
-            </a:r>
-          </a:p>
-          <a:p>
-            <a:r>
-              <a:t>### AME — $22,000,000 at Risk | Severity: Critical</a:t>
-            </a:r>
-          </a:p>
-          <a:p>
-            <a:r>
-              <a:t>**Scenario Types:** Ransomware</a:t>
-            </a:r>
-          </a:p>
-          <a:p>
-            <a:r>
-              <a:t>Financially motivated criminal syndicates have confirmed hostile activity directed at the live wind farm telemetry and remote maintenance scheduling systems that underpin AeroGrid's North American service delivery capability, representing the single highest-consequence scenario class in the empirical global baseline at 37.6% of all financial losses. An extended disruption to these systems would impair real-time turbine performance monitoring and field service coordination, directly threatening the 25% of AeroGrid revenue derived from global service and maintenance contracts. The $22,000,000 VaCR exposure demands board-level attention given the confirmed threat activity and the direct dependency of service revenue continuity on these operational systems.</a:t>
+              <a:t>**Primary Scenario:** System intrusion</a:t>
+            </a:r>
+          </a:p>
+          <a:p>
+            <a:r>
+              <a:t>State-sponsored actors exploiting South China Sea supply chain tensions pose a direct threat to proprietary turbine aerodynamic designs and blade manufacturing plants. System intrusion ranks first in event frequency at 43.3%, making this the most probable scenario type AeroGrid faces. The $18.5M exposure encompasses production disruption, intellectual property loss, and contractual penalties across the Asia-Pacific manufacturing footprint.</a:t>
             </a:r>
           </a:p>
           <a:p>
@@ -3292,12 +3293,87 @@
           </a:p>
           <a:p>
             <a:r>
-              <a:t>**Scenario Types:** Insider misuse</a:t>
-            </a:r>
-          </a:p>
-          <a:p>
-            <a:r>
-              <a:t>Economic instability across southern Europe has elevated the risk of insider-enabled exfiltration of the predictive maintenance algorithms and offshore servicing contract relationships that constitute AeroGrid's primary competitive advantage in the Mediterranean market. Should this proprietary knowledge be transferred to competitors, the operational differentiation built on years of field data and algorithmic refinement could be materially and irreversibly compromised, undermining both current contract performance and future award prospects. The $4,200,000 VaCR exposure, while the smallest active regional figure, carries an asymmetric loss profile given the long-term strategic value of the assets at risk.</a:t>
+              <a:t>**Primary Scenario:** Insider misuse</a:t>
+            </a:r>
+          </a:p>
+          <a:p>
+            <a:r>
+              <a:t>Regional economic instability is elevating insider risk, threatening predictive maintenance algorithms and offshore servicing contracts. While insider misuse carries a lower frequency rank of 5, its financial impact rank of 4 reflects meaningful exposure. The $4.2M at risk covers intellectual property loss and service disruption to Mediterranean offshore wind operations.</a:t>
+            </a:r>
+          </a:p>
+        </p:txBody>
+      </p:sp>
+    </p:spTree>
+  </p:cSld>
+  <p:clrMapOvr>
+    <a:masterClrMapping/>
+  </p:clrMapOvr>
+</p:sld>
+</file>
+
+<file path=ppt/slides/slide4.xml><?xml version="1.0" encoding="utf-8"?>
+<p:sld xmlns:a="http://schemas.openxmlformats.org/drawingml/2006/main" xmlns:p="http://schemas.openxmlformats.org/presentationml/2006/main" xmlns:r="http://schemas.openxmlformats.org/officeDocument/2006/relationships">
+  <p:cSld>
+    <p:spTree>
+      <p:nvGrpSpPr>
+        <p:cNvPr id="1" name=""/>
+        <p:cNvGrpSpPr/>
+        <p:nvPr/>
+      </p:nvGrpSpPr>
+      <p:grpSpPr/>
+      <p:sp>
+        <p:nvSpPr>
+          <p:cNvPr id="2" name="Title 1"/>
+          <p:cNvSpPr>
+            <a:spLocks noGrp="1"/>
+          </p:cNvSpPr>
+          <p:nvPr>
+            <p:ph type="title"/>
+          </p:nvPr>
+        </p:nvSpPr>
+        <p:spPr/>
+        <p:txBody>
+          <a:bodyPr/>
+          <a:lstStyle/>
+          <a:p>
+            <a:r>
+              <a:t>Clear Regions</a:t>
+            </a:r>
+          </a:p>
+        </p:txBody>
+      </p:sp>
+      <p:sp>
+        <p:nvSpPr>
+          <p:cNvPr id="3" name="Content Placeholder 2"/>
+          <p:cNvSpPr>
+            <a:spLocks noGrp="1"/>
+          </p:cNvSpPr>
+          <p:nvPr>
+            <p:ph idx="1"/>
+          </p:nvPr>
+        </p:nvSpPr>
+        <p:spPr/>
+        <p:txBody>
+          <a:bodyPr/>
+          <a:lstStyle/>
+          <a:p>
+            <a:r>
+              <a:t>### LATAM — Clear</a:t>
+            </a:r>
+          </a:p>
+          <a:p>
+            <a:r>
+              <a:t>No credible threat identified. Region operating within normal risk parameters.</a:t>
+            </a:r>
+          </a:p>
+          <a:p>
+            <a:r>
+              <a:t>### NCE — Clear</a:t>
+            </a:r>
+          </a:p>
+          <a:p>
+            <a:r>
+              <a:t>No credible threat identified. Region operating within normal risk parameters.</a:t>
             </a:r>
           </a:p>
           <a:p>
@@ -3307,7 +3383,7 @@
           </a:p>
           <a:p>
             <a:r>
-              <a:t>*Regions analyzed: 3 | Regions skipped: 2 | Source: Enterprise CRQ Application*</a:t>
+              <a:t>*Regions escalated: 3 | Regions clear: 2 | Source: Enterprise CRQ Application*</a:t>
             </a:r>
           </a:p>
         </p:txBody>

</xml_diff>

<commit_message>
feat: built Interactive Command Center Web App (FastAPI + Tailwind)
Co-Authored-By: Claude Sonnet 4.6 <noreply@anthropic.com>
</commit_message>
<xml_diff>
--- a/output/board_report.pptx
+++ b/output/board_report.pptx
@@ -3193,7 +3193,7 @@
           <a:lstStyle/>
           <a:p>
             <a:r>
-              <a:t>AeroGrid Wind Solutions faces $44.7M in aggregate risk exposure across three operational regions, driven by financially motivated disruption campaigns in North America, state-directed supply chain interference in Asia-Pacific, and elevated insider risk in the Mediterranean. Ransomware and system intrusion together represent the two highest-impact scenario types globally, directly threatening turbine manufacturing continuity and remote service delivery. The convergence of production disruption, intellectual property loss, and service revenue erosion across all three regions signals a systemic pattern that could impair both the manufacturing core (75% of revenue) and the global maintenance business simultaneously.</a:t>
+              <a:t>AeroGrid Wind Solutions faces a combined Value-at-Cyber-Risk exposure of $44.7M across three active regions, with two regions reporting no credible threats. Ransomware activity in the Americas represents the single largest concentration of financial risk at $22M, directly threatening operational continuity and revenue generation. System intrusion campaigns targeting the Asia-Pacific region carry $18.5M in exposure and pose a material risk to core wind turbine manufacturing operations. Insider misuse in the Mediterranean, while lower in frequency, presents a $4.2M exposure that warrants sustained governance attention given the region's service and maintenance role.</a:t>
             </a:r>
           </a:p>
           <a:p>
@@ -3268,7 +3268,7 @@
           </a:p>
           <a:p>
             <a:r>
-              <a:t>Financially motivated syndicates are targeting energy service providers, placing wind farm telemetry and remote maintenance scheduling at direct risk. Ransomware carries the highest financial impact rank globally at 37.6%, and the $22M exposure reflects recovery costs, service-level agreement breaches, and lost service revenue that would degrade AeroGrid's maintenance business across North American operations.</a:t>
+              <a:t>Ransomware remains the highest-impact scenario globally and poses an acute threat to AeroGrid's Americas operations, where supply chain coordination and customer delivery timelines are most vulnerable to disruption. A successful event could halt order fulfillment and trigger contractual penalties, making this the top priority for executive risk oversight. The $22M exposure reflects both direct recovery costs and downstream revenue loss from extended operational downtime.</a:t>
             </a:r>
           </a:p>
           <a:p>
@@ -3283,7 +3283,7 @@
           </a:p>
           <a:p>
             <a:r>
-              <a:t>State-sponsored actors exploiting South China Sea supply chain tensions pose a direct threat to proprietary turbine aerodynamic designs and blade manufacturing plants. System intrusion ranks first in event frequency at 43.3%, making this the most probable scenario type AeroGrid faces. The $18.5M exposure encompasses production disruption, intellectual property loss, and contractual penalties across the Asia-Pacific manufacturing footprint.</a:t>
+              <a:t>System intrusion activity in APAC directly threatens the manufacturing backbone that accounts for 75% of AeroGrid's revenue, where unauthorized access to industrial control environments could disrupt turbine production schedules. The $18.5M exposure captures potential losses from production stoppages, intellectual property compromise, and reputational damage with regional energy clients. Elevated geopolitical tensions in the region increase the likelihood of state-aligned campaigns targeting critical energy infrastructure suppliers.</a:t>
             </a:r>
           </a:p>
           <a:p>
@@ -3298,7 +3298,7 @@
           </a:p>
           <a:p>
             <a:r>
-              <a:t>Regional economic instability is elevating insider risk, threatening predictive maintenance algorithms and offshore servicing contracts. While insider misuse carries a lower frequency rank of 5, its financial impact rank of 4 reflects meaningful exposure. The $4.2M at risk covers intellectual property loss and service disruption to Mediterranean offshore wind operations.</a:t>
+              <a:t>Insider misuse in the Mediterranean region presents a lower-frequency but high-consequence risk to AeroGrid's global service and maintenance operations, where privileged access to client site data and turbine diagnostics is inherent to daily workflows. The $4.2M exposure reflects potential losses from data exfiltration, sabotage of maintenance records, or unauthorized disclosure of client operational information. While severity is moderate relative to other regions, the trusted-access nature of this threat makes it resistant to purely technical controls and requires sustained governance focus.</a:t>
             </a:r>
           </a:p>
         </p:txBody>

</xml_diff>

<commit_message>
docs: add agent activity console design spec
Floating bottom-right panel showing live SSE events and Claude CLI
stdout during pipeline runs. Approved design — ready for implementation.

Co-Authored-By: Claude Sonnet 4.6 <noreply@anthropic.com>
</commit_message>
<xml_diff>
--- a/output/board_report.pptx
+++ b/output/board_report.pptx
@@ -9,6 +9,8 @@
     <p:sldId id="257" r:id="rId8"/>
     <p:sldId id="258" r:id="rId9"/>
     <p:sldId id="259" r:id="rId10"/>
+    <p:sldId id="260" r:id="rId11"/>
+    <p:sldId id="261" r:id="rId12"/>
   </p:sldIdLst>
   <p:sldSz cx="9144000" cy="6858000" type="screen4x3"/>
   <p:notesSz cx="6858000" cy="9144000"/>
@@ -3093,47 +3095,248 @@
       <p:grpSpPr/>
       <p:sp>
         <p:nvSpPr>
-          <p:cNvPr id="2" name="Title 1"/>
-          <p:cNvSpPr>
-            <a:spLocks noGrp="1"/>
-          </p:cNvSpPr>
-          <p:nvPr>
-            <p:ph type="title"/>
-          </p:nvPr>
-        </p:nvSpPr>
-        <p:spPr/>
-        <p:txBody>
-          <a:bodyPr/>
-          <a:lstStyle/>
-          <a:p>
-            <a:r>
-              <a:t>Global Executive Board Report — Cyber Risk Posture</a:t>
-            </a:r>
-          </a:p>
-        </p:txBody>
-      </p:sp>
-      <p:sp>
-        <p:nvSpPr>
-          <p:cNvPr id="3" name="Content Placeholder 2"/>
-          <p:cNvSpPr>
-            <a:spLocks noGrp="1"/>
-          </p:cNvSpPr>
-          <p:nvPr>
-            <p:ph idx="1"/>
-          </p:nvPr>
-        </p:nvSpPr>
-        <p:spPr/>
-        <p:txBody>
-          <a:bodyPr/>
-          <a:lstStyle/>
-          <a:p>
-            <a:r>
-              <a:t>**Date:** 2026-03-09 | **Classification:** Board Confidential | **Total Global Value at Cyber Risk (VaCR):** $44,700,000</a:t>
-            </a:r>
-          </a:p>
-          <a:p>
-            <a:r>
-              <a:t>---</a:t>
+          <p:cNvPr id="2" name="Rectangle 1"/>
+          <p:cNvSpPr/>
+          <p:nvPr/>
+        </p:nvSpPr>
+        <p:spPr>
+          <a:xfrm>
+            <a:off x="0" y="0"/>
+            <a:ext cx="9144000" cy="3108960"/>
+          </a:xfrm>
+          <a:prstGeom prst="rect">
+            <a:avLst/>
+          </a:prstGeom>
+          <a:solidFill>
+            <a:srgbClr val="104277"/>
+          </a:solidFill>
+          <a:ln>
+            <a:noFill/>
+          </a:ln>
+        </p:spPr>
+        <p:style>
+          <a:lnRef idx="1">
+            <a:schemeClr val="accent1"/>
+          </a:lnRef>
+          <a:fillRef idx="3">
+            <a:schemeClr val="accent1"/>
+          </a:fillRef>
+          <a:effectRef idx="2">
+            <a:schemeClr val="accent1"/>
+          </a:effectRef>
+          <a:fontRef idx="minor">
+            <a:schemeClr val="lt1"/>
+          </a:fontRef>
+        </p:style>
+        <p:txBody>
+          <a:bodyPr rtlCol="0" anchor="ctr"/>
+          <a:lstStyle/>
+          <a:p>
+            <a:pPr algn="ctr"/>
+          </a:p>
+        </p:txBody>
+      </p:sp>
+      <p:sp>
+        <p:nvSpPr>
+          <p:cNvPr id="3" name="TextBox 2"/>
+          <p:cNvSpPr txBox="1"/>
+          <p:nvPr/>
+        </p:nvSpPr>
+        <p:spPr>
+          <a:xfrm>
+            <a:off x="548640" y="457200"/>
+            <a:ext cx="8046720" cy="457200"/>
+          </a:xfrm>
+          <a:prstGeom prst="rect">
+            <a:avLst/>
+          </a:prstGeom>
+          <a:noFill/>
+        </p:spPr>
+        <p:txBody>
+          <a:bodyPr wrap="square">
+            <a:spAutoFit/>
+          </a:bodyPr>
+          <a:lstStyle/>
+          <a:p>
+            <a:pPr algn="l"/>
+            <a:r>
+              <a:rPr sz="1300" b="0">
+                <a:solidFill>
+                  <a:srgbClr val="BFDBFF"/>
+                </a:solidFill>
+              </a:rPr>
+              <a:t>AeroGrid Wind Solutions</a:t>
+            </a:r>
+          </a:p>
+        </p:txBody>
+      </p:sp>
+      <p:sp>
+        <p:nvSpPr>
+          <p:cNvPr id="4" name="TextBox 3"/>
+          <p:cNvSpPr txBox="1"/>
+          <p:nvPr/>
+        </p:nvSpPr>
+        <p:spPr>
+          <a:xfrm>
+            <a:off x="548640" y="1005840"/>
+            <a:ext cx="8046720" cy="1828800"/>
+          </a:xfrm>
+          <a:prstGeom prst="rect">
+            <a:avLst/>
+          </a:prstGeom>
+          <a:noFill/>
+        </p:spPr>
+        <p:txBody>
+          <a:bodyPr wrap="square">
+            <a:spAutoFit/>
+          </a:bodyPr>
+          <a:lstStyle/>
+          <a:p>
+            <a:pPr algn="l"/>
+            <a:r>
+              <a:rPr sz="2800" b="1">
+                <a:solidFill>
+                  <a:srgbClr val="FFFFFF"/>
+                </a:solidFill>
+              </a:rPr>
+              <a:t>Global Cyber Risk
+Intelligence Brief</a:t>
+            </a:r>
+          </a:p>
+        </p:txBody>
+      </p:sp>
+      <p:sp>
+        <p:nvSpPr>
+          <p:cNvPr id="5" name="TextBox 4"/>
+          <p:cNvSpPr txBox="1"/>
+          <p:nvPr/>
+        </p:nvSpPr>
+        <p:spPr>
+          <a:xfrm>
+            <a:off x="548640" y="3383280"/>
+            <a:ext cx="4572000" cy="320040"/>
+          </a:xfrm>
+          <a:prstGeom prst="rect">
+            <a:avLst/>
+          </a:prstGeom>
+          <a:noFill/>
+        </p:spPr>
+        <p:txBody>
+          <a:bodyPr wrap="square">
+            <a:spAutoFit/>
+          </a:bodyPr>
+          <a:lstStyle/>
+          <a:p>
+            <a:pPr algn="l"/>
+            <a:r>
+              <a:rPr sz="900" b="0">
+                <a:solidFill>
+                  <a:srgbClr val="64748B"/>
+                </a:solidFill>
+              </a:rPr>
+              <a:t>TOTAL VALUE AT CYBER RISK</a:t>
+            </a:r>
+          </a:p>
+        </p:txBody>
+      </p:sp>
+      <p:sp>
+        <p:nvSpPr>
+          <p:cNvPr id="6" name="TextBox 5"/>
+          <p:cNvSpPr txBox="1"/>
+          <p:nvPr/>
+        </p:nvSpPr>
+        <p:spPr>
+          <a:xfrm>
+            <a:off x="548640" y="3657600"/>
+            <a:ext cx="4572000" cy="822960"/>
+          </a:xfrm>
+          <a:prstGeom prst="rect">
+            <a:avLst/>
+          </a:prstGeom>
+          <a:noFill/>
+        </p:spPr>
+        <p:txBody>
+          <a:bodyPr wrap="square">
+            <a:spAutoFit/>
+          </a:bodyPr>
+          <a:lstStyle/>
+          <a:p>
+            <a:pPr algn="l"/>
+            <a:r>
+              <a:rPr sz="3600" b="1">
+                <a:solidFill>
+                  <a:srgbClr val="104277"/>
+                </a:solidFill>
+              </a:rPr>
+              <a:t>$44.7M</a:t>
+            </a:r>
+          </a:p>
+        </p:txBody>
+      </p:sp>
+      <p:sp>
+        <p:nvSpPr>
+          <p:cNvPr id="7" name="TextBox 6"/>
+          <p:cNvSpPr txBox="1"/>
+          <p:nvPr/>
+        </p:nvSpPr>
+        <p:spPr>
+          <a:xfrm>
+            <a:off x="548640" y="4572000"/>
+            <a:ext cx="7315200" cy="365760"/>
+          </a:xfrm>
+          <a:prstGeom prst="rect">
+            <a:avLst/>
+          </a:prstGeom>
+          <a:noFill/>
+        </p:spPr>
+        <p:txBody>
+          <a:bodyPr wrap="square">
+            <a:spAutoFit/>
+          </a:bodyPr>
+          <a:lstStyle/>
+          <a:p>
+            <a:pPr algn="l"/>
+            <a:r>
+              <a:rPr sz="900" b="0">
+                <a:solidFill>
+                  <a:srgbClr val="64748B"/>
+                </a:solidFill>
+              </a:rPr>
+              <a:t>Pipeline ID: crq-2026-03-12T190254Z   |   2026-03-12T19:02:54Z</a:t>
+            </a:r>
+          </a:p>
+        </p:txBody>
+      </p:sp>
+      <p:sp>
+        <p:nvSpPr>
+          <p:cNvPr id="8" name="TextBox 7"/>
+          <p:cNvSpPr txBox="1"/>
+          <p:nvPr/>
+        </p:nvSpPr>
+        <p:spPr>
+          <a:xfrm>
+            <a:off x="6858000" y="6309360"/>
+            <a:ext cx="2103120" cy="365760"/>
+          </a:xfrm>
+          <a:prstGeom prst="rect">
+            <a:avLst/>
+          </a:prstGeom>
+          <a:noFill/>
+        </p:spPr>
+        <p:txBody>
+          <a:bodyPr wrap="square">
+            <a:spAutoFit/>
+          </a:bodyPr>
+          <a:lstStyle/>
+          <a:p>
+            <a:pPr algn="r"/>
+            <a:r>
+              <a:rPr sz="800" b="1">
+                <a:solidFill>
+                  <a:srgbClr val="DC2626"/>
+                </a:solidFill>
+              </a:rPr>
+              <a:t>CONFIDENTIAL</a:t>
             </a:r>
           </a:p>
         </p:txBody>
@@ -3158,20 +3361,76 @@
       <p:grpSpPr/>
       <p:sp>
         <p:nvSpPr>
-          <p:cNvPr id="2" name="Title 1"/>
-          <p:cNvSpPr>
-            <a:spLocks noGrp="1"/>
-          </p:cNvSpPr>
-          <p:nvPr>
-            <p:ph type="title"/>
-          </p:nvPr>
-        </p:nvSpPr>
-        <p:spPr/>
-        <p:txBody>
-          <a:bodyPr/>
-          <a:lstStyle/>
-          <a:p>
-            <a:r>
+          <p:cNvPr id="2" name="Rectangle 1"/>
+          <p:cNvSpPr/>
+          <p:nvPr/>
+        </p:nvSpPr>
+        <p:spPr>
+          <a:xfrm>
+            <a:off x="0" y="0"/>
+            <a:ext cx="9144000" cy="594360"/>
+          </a:xfrm>
+          <a:prstGeom prst="rect">
+            <a:avLst/>
+          </a:prstGeom>
+          <a:solidFill>
+            <a:srgbClr val="104277"/>
+          </a:solidFill>
+          <a:ln>
+            <a:noFill/>
+          </a:ln>
+        </p:spPr>
+        <p:style>
+          <a:lnRef idx="1">
+            <a:schemeClr val="accent1"/>
+          </a:lnRef>
+          <a:fillRef idx="3">
+            <a:schemeClr val="accent1"/>
+          </a:fillRef>
+          <a:effectRef idx="2">
+            <a:schemeClr val="accent1"/>
+          </a:effectRef>
+          <a:fontRef idx="minor">
+            <a:schemeClr val="lt1"/>
+          </a:fontRef>
+        </p:style>
+        <p:txBody>
+          <a:bodyPr rtlCol="0" anchor="ctr"/>
+          <a:lstStyle/>
+          <a:p>
+            <a:pPr algn="ctr"/>
+          </a:p>
+        </p:txBody>
+      </p:sp>
+      <p:sp>
+        <p:nvSpPr>
+          <p:cNvPr id="3" name="TextBox 2"/>
+          <p:cNvSpPr txBox="1"/>
+          <p:nvPr/>
+        </p:nvSpPr>
+        <p:spPr>
+          <a:xfrm>
+            <a:off x="274320" y="91440"/>
+            <a:ext cx="6400800" cy="411480"/>
+          </a:xfrm>
+          <a:prstGeom prst="rect">
+            <a:avLst/>
+          </a:prstGeom>
+          <a:noFill/>
+        </p:spPr>
+        <p:txBody>
+          <a:bodyPr wrap="square">
+            <a:spAutoFit/>
+          </a:bodyPr>
+          <a:lstStyle/>
+          <a:p>
+            <a:pPr algn="l"/>
+            <a:r>
+              <a:rPr sz="1600" b="1">
+                <a:solidFill>
+                  <a:srgbClr val="FFFFFF"/>
+                </a:solidFill>
+              </a:rPr>
               <a:t>Executive Summary</a:t>
             </a:r>
           </a:p>
@@ -3179,26 +3438,1294 @@
       </p:sp>
       <p:sp>
         <p:nvSpPr>
-          <p:cNvPr id="3" name="Content Placeholder 2"/>
-          <p:cNvSpPr>
-            <a:spLocks noGrp="1"/>
-          </p:cNvSpPr>
-          <p:nvPr>
-            <p:ph idx="1"/>
-          </p:nvPr>
-        </p:nvSpPr>
-        <p:spPr/>
-        <p:txBody>
-          <a:bodyPr/>
-          <a:lstStyle/>
-          <a:p>
-            <a:r>
-              <a:t>AeroGrid Wind Solutions faces a combined Value-at-Cyber-Risk exposure of $44.7M across three active regions, with two regions reporting no credible threats. Ransomware activity in the Americas represents the single largest concentration of financial risk at $22M, directly threatening operational continuity and revenue generation. System intrusion campaigns targeting the Asia-Pacific region carry $18.5M in exposure and pose a material risk to core wind turbine manufacturing operations. Insider misuse in the Mediterranean, while lower in frequency, presents a $4.2M exposure that warrants sustained governance attention given the region's service and maintenance role.</a:t>
-            </a:r>
-          </a:p>
-          <a:p>
-            <a:r>
-              <a:t>---</a:t>
+          <p:cNvPr id="4" name="Rectangle 3"/>
+          <p:cNvSpPr/>
+          <p:nvPr/>
+        </p:nvSpPr>
+        <p:spPr>
+          <a:xfrm>
+            <a:off x="365760" y="777240"/>
+            <a:ext cx="1005840" cy="685800"/>
+          </a:xfrm>
+          <a:prstGeom prst="rect">
+            <a:avLst/>
+          </a:prstGeom>
+          <a:solidFill>
+            <a:srgbClr val="DC2626"/>
+          </a:solidFill>
+          <a:ln>
+            <a:noFill/>
+          </a:ln>
+        </p:spPr>
+        <p:style>
+          <a:lnRef idx="1">
+            <a:schemeClr val="accent1"/>
+          </a:lnRef>
+          <a:fillRef idx="3">
+            <a:schemeClr val="accent1"/>
+          </a:fillRef>
+          <a:effectRef idx="2">
+            <a:schemeClr val="accent1"/>
+          </a:effectRef>
+          <a:fontRef idx="minor">
+            <a:schemeClr val="lt1"/>
+          </a:fontRef>
+        </p:style>
+        <p:txBody>
+          <a:bodyPr rtlCol="0" anchor="ctr"/>
+          <a:lstStyle/>
+          <a:p>
+            <a:pPr algn="ctr"/>
+          </a:p>
+        </p:txBody>
+      </p:sp>
+      <p:sp>
+        <p:nvSpPr>
+          <p:cNvPr id="5" name="TextBox 4"/>
+          <p:cNvSpPr txBox="1"/>
+          <p:nvPr/>
+        </p:nvSpPr>
+        <p:spPr>
+          <a:xfrm>
+            <a:off x="365760" y="804672"/>
+            <a:ext cx="1005840" cy="365760"/>
+          </a:xfrm>
+          <a:prstGeom prst="rect">
+            <a:avLst/>
+          </a:prstGeom>
+          <a:noFill/>
+        </p:spPr>
+        <p:txBody>
+          <a:bodyPr wrap="square">
+            <a:spAutoFit/>
+          </a:bodyPr>
+          <a:lstStyle/>
+          <a:p>
+            <a:pPr algn="ctr"/>
+            <a:r>
+              <a:rPr sz="2000" b="1">
+                <a:solidFill>
+                  <a:srgbClr val="FFFFFF"/>
+                </a:solidFill>
+              </a:rPr>
+              <a:t>3</a:t>
+            </a:r>
+          </a:p>
+        </p:txBody>
+      </p:sp>
+      <p:sp>
+        <p:nvSpPr>
+          <p:cNvPr id="6" name="TextBox 5"/>
+          <p:cNvSpPr txBox="1"/>
+          <p:nvPr/>
+        </p:nvSpPr>
+        <p:spPr>
+          <a:xfrm>
+            <a:off x="365760" y="1143000"/>
+            <a:ext cx="1005840" cy="274320"/>
+          </a:xfrm>
+          <a:prstGeom prst="rect">
+            <a:avLst/>
+          </a:prstGeom>
+          <a:noFill/>
+        </p:spPr>
+        <p:txBody>
+          <a:bodyPr wrap="square">
+            <a:spAutoFit/>
+          </a:bodyPr>
+          <a:lstStyle/>
+          <a:p>
+            <a:pPr algn="ctr"/>
+            <a:r>
+              <a:rPr sz="700" b="0">
+                <a:solidFill>
+                  <a:srgbClr val="FFFFFF"/>
+                </a:solidFill>
+              </a:rPr>
+              <a:t>ESCALATED</a:t>
+            </a:r>
+          </a:p>
+        </p:txBody>
+      </p:sp>
+      <p:sp>
+        <p:nvSpPr>
+          <p:cNvPr id="7" name="Rectangle 6"/>
+          <p:cNvSpPr/>
+          <p:nvPr/>
+        </p:nvSpPr>
+        <p:spPr>
+          <a:xfrm>
+            <a:off x="1554480" y="777240"/>
+            <a:ext cx="1005840" cy="685800"/>
+          </a:xfrm>
+          <a:prstGeom prst="rect">
+            <a:avLst/>
+          </a:prstGeom>
+          <a:solidFill>
+            <a:srgbClr val="D97706"/>
+          </a:solidFill>
+          <a:ln>
+            <a:noFill/>
+          </a:ln>
+        </p:spPr>
+        <p:style>
+          <a:lnRef idx="1">
+            <a:schemeClr val="accent1"/>
+          </a:lnRef>
+          <a:fillRef idx="3">
+            <a:schemeClr val="accent1"/>
+          </a:fillRef>
+          <a:effectRef idx="2">
+            <a:schemeClr val="accent1"/>
+          </a:effectRef>
+          <a:fontRef idx="minor">
+            <a:schemeClr val="lt1"/>
+          </a:fontRef>
+        </p:style>
+        <p:txBody>
+          <a:bodyPr rtlCol="0" anchor="ctr"/>
+          <a:lstStyle/>
+          <a:p>
+            <a:pPr algn="ctr"/>
+          </a:p>
+        </p:txBody>
+      </p:sp>
+      <p:sp>
+        <p:nvSpPr>
+          <p:cNvPr id="8" name="TextBox 7"/>
+          <p:cNvSpPr txBox="1"/>
+          <p:nvPr/>
+        </p:nvSpPr>
+        <p:spPr>
+          <a:xfrm>
+            <a:off x="1554480" y="804672"/>
+            <a:ext cx="1005840" cy="365760"/>
+          </a:xfrm>
+          <a:prstGeom prst="rect">
+            <a:avLst/>
+          </a:prstGeom>
+          <a:noFill/>
+        </p:spPr>
+        <p:txBody>
+          <a:bodyPr wrap="square">
+            <a:spAutoFit/>
+          </a:bodyPr>
+          <a:lstStyle/>
+          <a:p>
+            <a:pPr algn="ctr"/>
+            <a:r>
+              <a:rPr sz="2000" b="1">
+                <a:solidFill>
+                  <a:srgbClr val="FFFFFF"/>
+                </a:solidFill>
+              </a:rPr>
+              <a:t>0</a:t>
+            </a:r>
+          </a:p>
+        </p:txBody>
+      </p:sp>
+      <p:sp>
+        <p:nvSpPr>
+          <p:cNvPr id="9" name="TextBox 8"/>
+          <p:cNvSpPr txBox="1"/>
+          <p:nvPr/>
+        </p:nvSpPr>
+        <p:spPr>
+          <a:xfrm>
+            <a:off x="1554480" y="1143000"/>
+            <a:ext cx="1005840" cy="274320"/>
+          </a:xfrm>
+          <a:prstGeom prst="rect">
+            <a:avLst/>
+          </a:prstGeom>
+          <a:noFill/>
+        </p:spPr>
+        <p:txBody>
+          <a:bodyPr wrap="square">
+            <a:spAutoFit/>
+          </a:bodyPr>
+          <a:lstStyle/>
+          <a:p>
+            <a:pPr algn="ctr"/>
+            <a:r>
+              <a:rPr sz="700" b="0">
+                <a:solidFill>
+                  <a:srgbClr val="FFFFFF"/>
+                </a:solidFill>
+              </a:rPr>
+              <a:t>MONITOR</a:t>
+            </a:r>
+          </a:p>
+        </p:txBody>
+      </p:sp>
+      <p:sp>
+        <p:nvSpPr>
+          <p:cNvPr id="10" name="Rectangle 9"/>
+          <p:cNvSpPr/>
+          <p:nvPr/>
+        </p:nvSpPr>
+        <p:spPr>
+          <a:xfrm>
+            <a:off x="2743200" y="777240"/>
+            <a:ext cx="1005840" cy="685800"/>
+          </a:xfrm>
+          <a:prstGeom prst="rect">
+            <a:avLst/>
+          </a:prstGeom>
+          <a:solidFill>
+            <a:srgbClr val="16A34A"/>
+          </a:solidFill>
+          <a:ln>
+            <a:noFill/>
+          </a:ln>
+        </p:spPr>
+        <p:style>
+          <a:lnRef idx="1">
+            <a:schemeClr val="accent1"/>
+          </a:lnRef>
+          <a:fillRef idx="3">
+            <a:schemeClr val="accent1"/>
+          </a:fillRef>
+          <a:effectRef idx="2">
+            <a:schemeClr val="accent1"/>
+          </a:effectRef>
+          <a:fontRef idx="minor">
+            <a:schemeClr val="lt1"/>
+          </a:fontRef>
+        </p:style>
+        <p:txBody>
+          <a:bodyPr rtlCol="0" anchor="ctr"/>
+          <a:lstStyle/>
+          <a:p>
+            <a:pPr algn="ctr"/>
+          </a:p>
+        </p:txBody>
+      </p:sp>
+      <p:sp>
+        <p:nvSpPr>
+          <p:cNvPr id="11" name="TextBox 10"/>
+          <p:cNvSpPr txBox="1"/>
+          <p:nvPr/>
+        </p:nvSpPr>
+        <p:spPr>
+          <a:xfrm>
+            <a:off x="2743200" y="804672"/>
+            <a:ext cx="1005840" cy="365760"/>
+          </a:xfrm>
+          <a:prstGeom prst="rect">
+            <a:avLst/>
+          </a:prstGeom>
+          <a:noFill/>
+        </p:spPr>
+        <p:txBody>
+          <a:bodyPr wrap="square">
+            <a:spAutoFit/>
+          </a:bodyPr>
+          <a:lstStyle/>
+          <a:p>
+            <a:pPr algn="ctr"/>
+            <a:r>
+              <a:rPr sz="2000" b="1">
+                <a:solidFill>
+                  <a:srgbClr val="FFFFFF"/>
+                </a:solidFill>
+              </a:rPr>
+              <a:t>2</a:t>
+            </a:r>
+          </a:p>
+        </p:txBody>
+      </p:sp>
+      <p:sp>
+        <p:nvSpPr>
+          <p:cNvPr id="12" name="TextBox 11"/>
+          <p:cNvSpPr txBox="1"/>
+          <p:nvPr/>
+        </p:nvSpPr>
+        <p:spPr>
+          <a:xfrm>
+            <a:off x="2743200" y="1143000"/>
+            <a:ext cx="1005840" cy="274320"/>
+          </a:xfrm>
+          <a:prstGeom prst="rect">
+            <a:avLst/>
+          </a:prstGeom>
+          <a:noFill/>
+        </p:spPr>
+        <p:txBody>
+          <a:bodyPr wrap="square">
+            <a:spAutoFit/>
+          </a:bodyPr>
+          <a:lstStyle/>
+          <a:p>
+            <a:pPr algn="ctr"/>
+            <a:r>
+              <a:rPr sz="700" b="0">
+                <a:solidFill>
+                  <a:srgbClr val="FFFFFF"/>
+                </a:solidFill>
+              </a:rPr>
+              <a:t>CLEAR</a:t>
+            </a:r>
+          </a:p>
+        </p:txBody>
+      </p:sp>
+      <p:sp>
+        <p:nvSpPr>
+          <p:cNvPr id="13" name="Rectangle 12"/>
+          <p:cNvSpPr/>
+          <p:nvPr/>
+        </p:nvSpPr>
+        <p:spPr>
+          <a:xfrm>
+            <a:off x="7315200" y="777240"/>
+            <a:ext cx="1554480" cy="685800"/>
+          </a:xfrm>
+          <a:prstGeom prst="rect">
+            <a:avLst/>
+          </a:prstGeom>
+          <a:solidFill>
+            <a:srgbClr val="104277"/>
+          </a:solidFill>
+          <a:ln>
+            <a:noFill/>
+          </a:ln>
+        </p:spPr>
+        <p:style>
+          <a:lnRef idx="1">
+            <a:schemeClr val="accent1"/>
+          </a:lnRef>
+          <a:fillRef idx="3">
+            <a:schemeClr val="accent1"/>
+          </a:fillRef>
+          <a:effectRef idx="2">
+            <a:schemeClr val="accent1"/>
+          </a:effectRef>
+          <a:fontRef idx="minor">
+            <a:schemeClr val="lt1"/>
+          </a:fontRef>
+        </p:style>
+        <p:txBody>
+          <a:bodyPr rtlCol="0" anchor="ctr"/>
+          <a:lstStyle/>
+          <a:p>
+            <a:pPr algn="ctr"/>
+          </a:p>
+        </p:txBody>
+      </p:sp>
+      <p:sp>
+        <p:nvSpPr>
+          <p:cNvPr id="14" name="TextBox 13"/>
+          <p:cNvSpPr txBox="1"/>
+          <p:nvPr/>
+        </p:nvSpPr>
+        <p:spPr>
+          <a:xfrm>
+            <a:off x="7315200" y="804672"/>
+            <a:ext cx="1554480" cy="365760"/>
+          </a:xfrm>
+          <a:prstGeom prst="rect">
+            <a:avLst/>
+          </a:prstGeom>
+          <a:noFill/>
+        </p:spPr>
+        <p:txBody>
+          <a:bodyPr wrap="square">
+            <a:spAutoFit/>
+          </a:bodyPr>
+          <a:lstStyle/>
+          <a:p>
+            <a:pPr algn="ctr"/>
+            <a:r>
+              <a:rPr sz="1600" b="1">
+                <a:solidFill>
+                  <a:srgbClr val="FFFFFF"/>
+                </a:solidFill>
+              </a:rPr>
+              <a:t>$44.7M</a:t>
+            </a:r>
+          </a:p>
+        </p:txBody>
+      </p:sp>
+      <p:sp>
+        <p:nvSpPr>
+          <p:cNvPr id="15" name="TextBox 14"/>
+          <p:cNvSpPr txBox="1"/>
+          <p:nvPr/>
+        </p:nvSpPr>
+        <p:spPr>
+          <a:xfrm>
+            <a:off x="7315200" y="1143000"/>
+            <a:ext cx="1554480" cy="274320"/>
+          </a:xfrm>
+          <a:prstGeom prst="rect">
+            <a:avLst/>
+          </a:prstGeom>
+          <a:noFill/>
+        </p:spPr>
+        <p:txBody>
+          <a:bodyPr wrap="square">
+            <a:spAutoFit/>
+          </a:bodyPr>
+          <a:lstStyle/>
+          <a:p>
+            <a:pPr algn="ctr"/>
+            <a:r>
+              <a:rPr sz="700" b="0">
+                <a:solidFill>
+                  <a:srgbClr val="FFFFFF"/>
+                </a:solidFill>
+              </a:rPr>
+              <a:t>TOTAL VaCR</a:t>
+            </a:r>
+          </a:p>
+        </p:txBody>
+      </p:sp>
+      <p:sp>
+        <p:nvSpPr>
+          <p:cNvPr id="16" name="TextBox 15"/>
+          <p:cNvSpPr txBox="1"/>
+          <p:nvPr/>
+        </p:nvSpPr>
+        <p:spPr>
+          <a:xfrm>
+            <a:off x="365760" y="1645920"/>
+            <a:ext cx="8412480" cy="914400"/>
+          </a:xfrm>
+          <a:prstGeom prst="rect">
+            <a:avLst/>
+          </a:prstGeom>
+          <a:noFill/>
+        </p:spPr>
+        <p:txBody>
+          <a:bodyPr wrap="square">
+            <a:spAutoFit/>
+          </a:bodyPr>
+          <a:lstStyle/>
+          <a:p>
+            <a:pPr algn="l"/>
+            <a:r>
+              <a:rPr sz="1000" b="0">
+                <a:solidFill>
+                  <a:srgbClr val="1E293B"/>
+                </a:solidFill>
+              </a:rPr>
+              <a:t>AeroGrid faces a combined Value at Cyber Risk exposure of $44,700,000 across three of five global regions, with threats concentrated in the scenarios carrying the highest and third-highest financial impact rankings worldwide. The dominant pattern is geopolitically driven: state-sponsored targeting of manufacturing intellectual property in APAC, financially motivated criminal disruption of service delivery in AME, and insider exploitation of workforce financial stress in the Mediterranean all converge on AeroGrid's crown jewels — proprietary turbine designs, OT manufacturing networks, and live predictive maintenance platforms. Velocity signals across all five regions are stable with no region accelerating or improving over the current observation window, indicating the threat landscape is entrenched rather than in flux. If any one of the three active exposures materializes, the direct consequences range from turbine production throughput losses and IP exfiltration in manufacturing to full service delivery disruption and regulatory penalties across the wind farm operations portfolio.</a:t>
+            </a:r>
+          </a:p>
+        </p:txBody>
+      </p:sp>
+      <p:sp>
+        <p:nvSpPr>
+          <p:cNvPr id="17" name="TextBox 16"/>
+          <p:cNvSpPr txBox="1"/>
+          <p:nvPr/>
+        </p:nvSpPr>
+        <p:spPr>
+          <a:xfrm>
+            <a:off x="365760" y="2743200"/>
+            <a:ext cx="1097280" cy="274320"/>
+          </a:xfrm>
+          <a:prstGeom prst="rect">
+            <a:avLst/>
+          </a:prstGeom>
+          <a:noFill/>
+        </p:spPr>
+        <p:txBody>
+          <a:bodyPr wrap="square">
+            <a:spAutoFit/>
+          </a:bodyPr>
+          <a:lstStyle/>
+          <a:p>
+            <a:pPr algn="l"/>
+            <a:r>
+              <a:rPr sz="800" b="1">
+                <a:solidFill>
+                  <a:srgbClr val="64748B"/>
+                </a:solidFill>
+              </a:rPr>
+              <a:t>Region</a:t>
+            </a:r>
+          </a:p>
+        </p:txBody>
+      </p:sp>
+      <p:sp>
+        <p:nvSpPr>
+          <p:cNvPr id="18" name="TextBox 17"/>
+          <p:cNvSpPr txBox="1"/>
+          <p:nvPr/>
+        </p:nvSpPr>
+        <p:spPr>
+          <a:xfrm>
+            <a:off x="1463040" y="2743200"/>
+            <a:ext cx="2011680" cy="274320"/>
+          </a:xfrm>
+          <a:prstGeom prst="rect">
+            <a:avLst/>
+          </a:prstGeom>
+          <a:noFill/>
+        </p:spPr>
+        <p:txBody>
+          <a:bodyPr wrap="square">
+            <a:spAutoFit/>
+          </a:bodyPr>
+          <a:lstStyle/>
+          <a:p>
+            <a:pPr algn="l"/>
+            <a:r>
+              <a:rPr sz="800" b="1">
+                <a:solidFill>
+                  <a:srgbClr val="64748B"/>
+                </a:solidFill>
+              </a:rPr>
+              <a:t>Scenario</a:t>
+            </a:r>
+          </a:p>
+        </p:txBody>
+      </p:sp>
+      <p:sp>
+        <p:nvSpPr>
+          <p:cNvPr id="19" name="TextBox 18"/>
+          <p:cNvSpPr txBox="1"/>
+          <p:nvPr/>
+        </p:nvSpPr>
+        <p:spPr>
+          <a:xfrm>
+            <a:off x="3474720" y="2743200"/>
+            <a:ext cx="1097280" cy="274320"/>
+          </a:xfrm>
+          <a:prstGeom prst="rect">
+            <a:avLst/>
+          </a:prstGeom>
+          <a:noFill/>
+        </p:spPr>
+        <p:txBody>
+          <a:bodyPr wrap="square">
+            <a:spAutoFit/>
+          </a:bodyPr>
+          <a:lstStyle/>
+          <a:p>
+            <a:pPr algn="l"/>
+            <a:r>
+              <a:rPr sz="800" b="1">
+                <a:solidFill>
+                  <a:srgbClr val="64748B"/>
+                </a:solidFill>
+              </a:rPr>
+              <a:t>VaCR</a:t>
+            </a:r>
+          </a:p>
+        </p:txBody>
+      </p:sp>
+      <p:sp>
+        <p:nvSpPr>
+          <p:cNvPr id="20" name="TextBox 19"/>
+          <p:cNvSpPr txBox="1"/>
+          <p:nvPr/>
+        </p:nvSpPr>
+        <p:spPr>
+          <a:xfrm>
+            <a:off x="4572000" y="2743200"/>
+            <a:ext cx="1005840" cy="274320"/>
+          </a:xfrm>
+          <a:prstGeom prst="rect">
+            <a:avLst/>
+          </a:prstGeom>
+          <a:noFill/>
+        </p:spPr>
+        <p:txBody>
+          <a:bodyPr wrap="square">
+            <a:spAutoFit/>
+          </a:bodyPr>
+          <a:lstStyle/>
+          <a:p>
+            <a:pPr algn="l"/>
+            <a:r>
+              <a:rPr sz="800" b="1">
+                <a:solidFill>
+                  <a:srgbClr val="64748B"/>
+                </a:solidFill>
+              </a:rPr>
+              <a:t>Admiralty</a:t>
+            </a:r>
+          </a:p>
+        </p:txBody>
+      </p:sp>
+      <p:sp>
+        <p:nvSpPr>
+          <p:cNvPr id="21" name="TextBox 20"/>
+          <p:cNvSpPr txBox="1"/>
+          <p:nvPr/>
+        </p:nvSpPr>
+        <p:spPr>
+          <a:xfrm>
+            <a:off x="5577840" y="2743200"/>
+            <a:ext cx="1645920" cy="274320"/>
+          </a:xfrm>
+          <a:prstGeom prst="rect">
+            <a:avLst/>
+          </a:prstGeom>
+          <a:noFill/>
+        </p:spPr>
+        <p:txBody>
+          <a:bodyPr wrap="square">
+            <a:spAutoFit/>
+          </a:bodyPr>
+          <a:lstStyle/>
+          <a:p>
+            <a:pPr algn="l"/>
+            <a:r>
+              <a:rPr sz="800" b="1">
+                <a:solidFill>
+                  <a:srgbClr val="64748B"/>
+                </a:solidFill>
+              </a:rPr>
+              <a:t>Velocity</a:t>
+            </a:r>
+          </a:p>
+        </p:txBody>
+      </p:sp>
+      <p:sp>
+        <p:nvSpPr>
+          <p:cNvPr id="22" name="TextBox 21"/>
+          <p:cNvSpPr txBox="1"/>
+          <p:nvPr/>
+        </p:nvSpPr>
+        <p:spPr>
+          <a:xfrm>
+            <a:off x="7223760" y="2743200"/>
+            <a:ext cx="1097280" cy="274320"/>
+          </a:xfrm>
+          <a:prstGeom prst="rect">
+            <a:avLst/>
+          </a:prstGeom>
+          <a:noFill/>
+        </p:spPr>
+        <p:txBody>
+          <a:bodyPr wrap="square">
+            <a:spAutoFit/>
+          </a:bodyPr>
+          <a:lstStyle/>
+          <a:p>
+            <a:pPr algn="l"/>
+            <a:r>
+              <a:rPr sz="800" b="1">
+                <a:solidFill>
+                  <a:srgbClr val="64748B"/>
+                </a:solidFill>
+              </a:rPr>
+              <a:t>Severity</a:t>
+            </a:r>
+          </a:p>
+        </p:txBody>
+      </p:sp>
+      <p:sp>
+        <p:nvSpPr>
+          <p:cNvPr id="23" name="TextBox 22"/>
+          <p:cNvSpPr txBox="1"/>
+          <p:nvPr/>
+        </p:nvSpPr>
+        <p:spPr>
+          <a:xfrm>
+            <a:off x="365760" y="3063240"/>
+            <a:ext cx="1097280" cy="320040"/>
+          </a:xfrm>
+          <a:prstGeom prst="rect">
+            <a:avLst/>
+          </a:prstGeom>
+          <a:noFill/>
+        </p:spPr>
+        <p:txBody>
+          <a:bodyPr wrap="square">
+            <a:spAutoFit/>
+          </a:bodyPr>
+          <a:lstStyle/>
+          <a:p>
+            <a:pPr algn="l"/>
+            <a:r>
+              <a:rPr sz="900" b="0">
+                <a:solidFill>
+                  <a:srgbClr val="1E293B"/>
+                </a:solidFill>
+              </a:rPr>
+              <a:t>APAC</a:t>
+            </a:r>
+          </a:p>
+        </p:txBody>
+      </p:sp>
+      <p:sp>
+        <p:nvSpPr>
+          <p:cNvPr id="24" name="TextBox 23"/>
+          <p:cNvSpPr txBox="1"/>
+          <p:nvPr/>
+        </p:nvSpPr>
+        <p:spPr>
+          <a:xfrm>
+            <a:off x="1463040" y="3063240"/>
+            <a:ext cx="2011680" cy="320040"/>
+          </a:xfrm>
+          <a:prstGeom prst="rect">
+            <a:avLst/>
+          </a:prstGeom>
+          <a:noFill/>
+        </p:spPr>
+        <p:txBody>
+          <a:bodyPr wrap="square">
+            <a:spAutoFit/>
+          </a:bodyPr>
+          <a:lstStyle/>
+          <a:p>
+            <a:pPr algn="l"/>
+            <a:r>
+              <a:rPr sz="900" b="0">
+                <a:solidFill>
+                  <a:srgbClr val="1E293B"/>
+                </a:solidFill>
+              </a:rPr>
+              <a:t>System intrusion</a:t>
+            </a:r>
+          </a:p>
+        </p:txBody>
+      </p:sp>
+      <p:sp>
+        <p:nvSpPr>
+          <p:cNvPr id="25" name="TextBox 24"/>
+          <p:cNvSpPr txBox="1"/>
+          <p:nvPr/>
+        </p:nvSpPr>
+        <p:spPr>
+          <a:xfrm>
+            <a:off x="3474720" y="3063240"/>
+            <a:ext cx="1097280" cy="320040"/>
+          </a:xfrm>
+          <a:prstGeom prst="rect">
+            <a:avLst/>
+          </a:prstGeom>
+          <a:noFill/>
+        </p:spPr>
+        <p:txBody>
+          <a:bodyPr wrap="square">
+            <a:spAutoFit/>
+          </a:bodyPr>
+          <a:lstStyle/>
+          <a:p>
+            <a:pPr algn="l"/>
+            <a:r>
+              <a:rPr sz="900" b="0">
+                <a:solidFill>
+                  <a:srgbClr val="1E293B"/>
+                </a:solidFill>
+              </a:rPr>
+              <a:t>$18.5M</a:t>
+            </a:r>
+          </a:p>
+        </p:txBody>
+      </p:sp>
+      <p:sp>
+        <p:nvSpPr>
+          <p:cNvPr id="26" name="TextBox 25"/>
+          <p:cNvSpPr txBox="1"/>
+          <p:nvPr/>
+        </p:nvSpPr>
+        <p:spPr>
+          <a:xfrm>
+            <a:off x="4572000" y="3063240"/>
+            <a:ext cx="1005840" cy="320040"/>
+          </a:xfrm>
+          <a:prstGeom prst="rect">
+            <a:avLst/>
+          </a:prstGeom>
+          <a:noFill/>
+        </p:spPr>
+        <p:txBody>
+          <a:bodyPr wrap="square">
+            <a:spAutoFit/>
+          </a:bodyPr>
+          <a:lstStyle/>
+          <a:p>
+            <a:pPr algn="l"/>
+            <a:r>
+              <a:rPr sz="900" b="0">
+                <a:solidFill>
+                  <a:srgbClr val="1E293B"/>
+                </a:solidFill>
+              </a:rPr>
+              <a:t>B2</a:t>
+            </a:r>
+          </a:p>
+        </p:txBody>
+      </p:sp>
+      <p:sp>
+        <p:nvSpPr>
+          <p:cNvPr id="27" name="TextBox 26"/>
+          <p:cNvSpPr txBox="1"/>
+          <p:nvPr/>
+        </p:nvSpPr>
+        <p:spPr>
+          <a:xfrm>
+            <a:off x="5577840" y="3063240"/>
+            <a:ext cx="1645920" cy="320040"/>
+          </a:xfrm>
+          <a:prstGeom prst="rect">
+            <a:avLst/>
+          </a:prstGeom>
+          <a:noFill/>
+        </p:spPr>
+        <p:txBody>
+          <a:bodyPr wrap="square">
+            <a:spAutoFit/>
+          </a:bodyPr>
+          <a:lstStyle/>
+          <a:p>
+            <a:pPr algn="l"/>
+            <a:r>
+              <a:rPr sz="900" b="0">
+                <a:solidFill>
+                  <a:srgbClr val="1E293B"/>
+                </a:solidFill>
+              </a:rPr>
+              <a:t>→ Stable</a:t>
+            </a:r>
+          </a:p>
+        </p:txBody>
+      </p:sp>
+      <p:sp>
+        <p:nvSpPr>
+          <p:cNvPr id="28" name="TextBox 27"/>
+          <p:cNvSpPr txBox="1"/>
+          <p:nvPr/>
+        </p:nvSpPr>
+        <p:spPr>
+          <a:xfrm>
+            <a:off x="7223760" y="3063240"/>
+            <a:ext cx="1097280" cy="320040"/>
+          </a:xfrm>
+          <a:prstGeom prst="rect">
+            <a:avLst/>
+          </a:prstGeom>
+          <a:noFill/>
+        </p:spPr>
+        <p:txBody>
+          <a:bodyPr wrap="square">
+            <a:spAutoFit/>
+          </a:bodyPr>
+          <a:lstStyle/>
+          <a:p>
+            <a:pPr algn="l"/>
+            <a:r>
+              <a:rPr sz="900" b="0">
+                <a:solidFill>
+                  <a:srgbClr val="1E293B"/>
+                </a:solidFill>
+              </a:rPr>
+              <a:t>HIGH</a:t>
+            </a:r>
+          </a:p>
+        </p:txBody>
+      </p:sp>
+      <p:sp>
+        <p:nvSpPr>
+          <p:cNvPr id="29" name="TextBox 28"/>
+          <p:cNvSpPr txBox="1"/>
+          <p:nvPr/>
+        </p:nvSpPr>
+        <p:spPr>
+          <a:xfrm>
+            <a:off x="365760" y="3474720"/>
+            <a:ext cx="1097280" cy="320040"/>
+          </a:xfrm>
+          <a:prstGeom prst="rect">
+            <a:avLst/>
+          </a:prstGeom>
+          <a:noFill/>
+        </p:spPr>
+        <p:txBody>
+          <a:bodyPr wrap="square">
+            <a:spAutoFit/>
+          </a:bodyPr>
+          <a:lstStyle/>
+          <a:p>
+            <a:pPr algn="l"/>
+            <a:r>
+              <a:rPr sz="900" b="0">
+                <a:solidFill>
+                  <a:srgbClr val="1E293B"/>
+                </a:solidFill>
+              </a:rPr>
+              <a:t>AME</a:t>
+            </a:r>
+          </a:p>
+        </p:txBody>
+      </p:sp>
+      <p:sp>
+        <p:nvSpPr>
+          <p:cNvPr id="30" name="TextBox 29"/>
+          <p:cNvSpPr txBox="1"/>
+          <p:nvPr/>
+        </p:nvSpPr>
+        <p:spPr>
+          <a:xfrm>
+            <a:off x="1463040" y="3474720"/>
+            <a:ext cx="2011680" cy="320040"/>
+          </a:xfrm>
+          <a:prstGeom prst="rect">
+            <a:avLst/>
+          </a:prstGeom>
+          <a:noFill/>
+        </p:spPr>
+        <p:txBody>
+          <a:bodyPr wrap="square">
+            <a:spAutoFit/>
+          </a:bodyPr>
+          <a:lstStyle/>
+          <a:p>
+            <a:pPr algn="l"/>
+            <a:r>
+              <a:rPr sz="900" b="0">
+                <a:solidFill>
+                  <a:srgbClr val="1E293B"/>
+                </a:solidFill>
+              </a:rPr>
+              <a:t>Ransomware</a:t>
+            </a:r>
+          </a:p>
+        </p:txBody>
+      </p:sp>
+      <p:sp>
+        <p:nvSpPr>
+          <p:cNvPr id="31" name="TextBox 30"/>
+          <p:cNvSpPr txBox="1"/>
+          <p:nvPr/>
+        </p:nvSpPr>
+        <p:spPr>
+          <a:xfrm>
+            <a:off x="3474720" y="3474720"/>
+            <a:ext cx="1097280" cy="320040"/>
+          </a:xfrm>
+          <a:prstGeom prst="rect">
+            <a:avLst/>
+          </a:prstGeom>
+          <a:noFill/>
+        </p:spPr>
+        <p:txBody>
+          <a:bodyPr wrap="square">
+            <a:spAutoFit/>
+          </a:bodyPr>
+          <a:lstStyle/>
+          <a:p>
+            <a:pPr algn="l"/>
+            <a:r>
+              <a:rPr sz="900" b="0">
+                <a:solidFill>
+                  <a:srgbClr val="1E293B"/>
+                </a:solidFill>
+              </a:rPr>
+              <a:t>$22.0M</a:t>
+            </a:r>
+          </a:p>
+        </p:txBody>
+      </p:sp>
+      <p:sp>
+        <p:nvSpPr>
+          <p:cNvPr id="32" name="TextBox 31"/>
+          <p:cNvSpPr txBox="1"/>
+          <p:nvPr/>
+        </p:nvSpPr>
+        <p:spPr>
+          <a:xfrm>
+            <a:off x="4572000" y="3474720"/>
+            <a:ext cx="1005840" cy="320040"/>
+          </a:xfrm>
+          <a:prstGeom prst="rect">
+            <a:avLst/>
+          </a:prstGeom>
+          <a:noFill/>
+        </p:spPr>
+        <p:txBody>
+          <a:bodyPr wrap="square">
+            <a:spAutoFit/>
+          </a:bodyPr>
+          <a:lstStyle/>
+          <a:p>
+            <a:pPr algn="l"/>
+            <a:r>
+              <a:rPr sz="900" b="0">
+                <a:solidFill>
+                  <a:srgbClr val="1E293B"/>
+                </a:solidFill>
+              </a:rPr>
+              <a:t>B2</a:t>
+            </a:r>
+          </a:p>
+        </p:txBody>
+      </p:sp>
+      <p:sp>
+        <p:nvSpPr>
+          <p:cNvPr id="33" name="TextBox 32"/>
+          <p:cNvSpPr txBox="1"/>
+          <p:nvPr/>
+        </p:nvSpPr>
+        <p:spPr>
+          <a:xfrm>
+            <a:off x="5577840" y="3474720"/>
+            <a:ext cx="1645920" cy="320040"/>
+          </a:xfrm>
+          <a:prstGeom prst="rect">
+            <a:avLst/>
+          </a:prstGeom>
+          <a:noFill/>
+        </p:spPr>
+        <p:txBody>
+          <a:bodyPr wrap="square">
+            <a:spAutoFit/>
+          </a:bodyPr>
+          <a:lstStyle/>
+          <a:p>
+            <a:pPr algn="l"/>
+            <a:r>
+              <a:rPr sz="900" b="0">
+                <a:solidFill>
+                  <a:srgbClr val="1E293B"/>
+                </a:solidFill>
+              </a:rPr>
+              <a:t>→ Stable</a:t>
+            </a:r>
+          </a:p>
+        </p:txBody>
+      </p:sp>
+      <p:sp>
+        <p:nvSpPr>
+          <p:cNvPr id="34" name="TextBox 33"/>
+          <p:cNvSpPr txBox="1"/>
+          <p:nvPr/>
+        </p:nvSpPr>
+        <p:spPr>
+          <a:xfrm>
+            <a:off x="7223760" y="3474720"/>
+            <a:ext cx="1097280" cy="320040"/>
+          </a:xfrm>
+          <a:prstGeom prst="rect">
+            <a:avLst/>
+          </a:prstGeom>
+          <a:noFill/>
+        </p:spPr>
+        <p:txBody>
+          <a:bodyPr wrap="square">
+            <a:spAutoFit/>
+          </a:bodyPr>
+          <a:lstStyle/>
+          <a:p>
+            <a:pPr algn="l"/>
+            <a:r>
+              <a:rPr sz="900" b="0">
+                <a:solidFill>
+                  <a:srgbClr val="1E293B"/>
+                </a:solidFill>
+              </a:rPr>
+              <a:t>CRITICAL</a:t>
+            </a:r>
+          </a:p>
+        </p:txBody>
+      </p:sp>
+      <p:sp>
+        <p:nvSpPr>
+          <p:cNvPr id="35" name="TextBox 34"/>
+          <p:cNvSpPr txBox="1"/>
+          <p:nvPr/>
+        </p:nvSpPr>
+        <p:spPr>
+          <a:xfrm>
+            <a:off x="365760" y="3886200"/>
+            <a:ext cx="1097280" cy="320040"/>
+          </a:xfrm>
+          <a:prstGeom prst="rect">
+            <a:avLst/>
+          </a:prstGeom>
+          <a:noFill/>
+        </p:spPr>
+        <p:txBody>
+          <a:bodyPr wrap="square">
+            <a:spAutoFit/>
+          </a:bodyPr>
+          <a:lstStyle/>
+          <a:p>
+            <a:pPr algn="l"/>
+            <a:r>
+              <a:rPr sz="900" b="0">
+                <a:solidFill>
+                  <a:srgbClr val="1E293B"/>
+                </a:solidFill>
+              </a:rPr>
+              <a:t>MED</a:t>
+            </a:r>
+          </a:p>
+        </p:txBody>
+      </p:sp>
+      <p:sp>
+        <p:nvSpPr>
+          <p:cNvPr id="36" name="TextBox 35"/>
+          <p:cNvSpPr txBox="1"/>
+          <p:nvPr/>
+        </p:nvSpPr>
+        <p:spPr>
+          <a:xfrm>
+            <a:off x="1463040" y="3886200"/>
+            <a:ext cx="2011680" cy="320040"/>
+          </a:xfrm>
+          <a:prstGeom prst="rect">
+            <a:avLst/>
+          </a:prstGeom>
+          <a:noFill/>
+        </p:spPr>
+        <p:txBody>
+          <a:bodyPr wrap="square">
+            <a:spAutoFit/>
+          </a:bodyPr>
+          <a:lstStyle/>
+          <a:p>
+            <a:pPr algn="l"/>
+            <a:r>
+              <a:rPr sz="900" b="0">
+                <a:solidFill>
+                  <a:srgbClr val="1E293B"/>
+                </a:solidFill>
+              </a:rPr>
+              <a:t>Insider misuse</a:t>
+            </a:r>
+          </a:p>
+        </p:txBody>
+      </p:sp>
+      <p:sp>
+        <p:nvSpPr>
+          <p:cNvPr id="37" name="TextBox 36"/>
+          <p:cNvSpPr txBox="1"/>
+          <p:nvPr/>
+        </p:nvSpPr>
+        <p:spPr>
+          <a:xfrm>
+            <a:off x="3474720" y="3886200"/>
+            <a:ext cx="1097280" cy="320040"/>
+          </a:xfrm>
+          <a:prstGeom prst="rect">
+            <a:avLst/>
+          </a:prstGeom>
+          <a:noFill/>
+        </p:spPr>
+        <p:txBody>
+          <a:bodyPr wrap="square">
+            <a:spAutoFit/>
+          </a:bodyPr>
+          <a:lstStyle/>
+          <a:p>
+            <a:pPr algn="l"/>
+            <a:r>
+              <a:rPr sz="900" b="0">
+                <a:solidFill>
+                  <a:srgbClr val="1E293B"/>
+                </a:solidFill>
+              </a:rPr>
+              <a:t>$4.2M</a:t>
+            </a:r>
+          </a:p>
+        </p:txBody>
+      </p:sp>
+      <p:sp>
+        <p:nvSpPr>
+          <p:cNvPr id="38" name="TextBox 37"/>
+          <p:cNvSpPr txBox="1"/>
+          <p:nvPr/>
+        </p:nvSpPr>
+        <p:spPr>
+          <a:xfrm>
+            <a:off x="4572000" y="3886200"/>
+            <a:ext cx="1005840" cy="320040"/>
+          </a:xfrm>
+          <a:prstGeom prst="rect">
+            <a:avLst/>
+          </a:prstGeom>
+          <a:noFill/>
+        </p:spPr>
+        <p:txBody>
+          <a:bodyPr wrap="square">
+            <a:spAutoFit/>
+          </a:bodyPr>
+          <a:lstStyle/>
+          <a:p>
+            <a:pPr algn="l"/>
+            <a:r>
+              <a:rPr sz="900" b="0">
+                <a:solidFill>
+                  <a:srgbClr val="1E293B"/>
+                </a:solidFill>
+              </a:rPr>
+              <a:t>B2</a:t>
+            </a:r>
+          </a:p>
+        </p:txBody>
+      </p:sp>
+      <p:sp>
+        <p:nvSpPr>
+          <p:cNvPr id="39" name="TextBox 38"/>
+          <p:cNvSpPr txBox="1"/>
+          <p:nvPr/>
+        </p:nvSpPr>
+        <p:spPr>
+          <a:xfrm>
+            <a:off x="5577840" y="3886200"/>
+            <a:ext cx="1645920" cy="320040"/>
+          </a:xfrm>
+          <a:prstGeom prst="rect">
+            <a:avLst/>
+          </a:prstGeom>
+          <a:noFill/>
+        </p:spPr>
+        <p:txBody>
+          <a:bodyPr wrap="square">
+            <a:spAutoFit/>
+          </a:bodyPr>
+          <a:lstStyle/>
+          <a:p>
+            <a:pPr algn="l"/>
+            <a:r>
+              <a:rPr sz="900" b="0">
+                <a:solidFill>
+                  <a:srgbClr val="1E293B"/>
+                </a:solidFill>
+              </a:rPr>
+              <a:t>→ Stable</a:t>
+            </a:r>
+          </a:p>
+        </p:txBody>
+      </p:sp>
+      <p:sp>
+        <p:nvSpPr>
+          <p:cNvPr id="40" name="TextBox 39"/>
+          <p:cNvSpPr txBox="1"/>
+          <p:nvPr/>
+        </p:nvSpPr>
+        <p:spPr>
+          <a:xfrm>
+            <a:off x="7223760" y="3886200"/>
+            <a:ext cx="1097280" cy="320040"/>
+          </a:xfrm>
+          <a:prstGeom prst="rect">
+            <a:avLst/>
+          </a:prstGeom>
+          <a:noFill/>
+        </p:spPr>
+        <p:txBody>
+          <a:bodyPr wrap="square">
+            <a:spAutoFit/>
+          </a:bodyPr>
+          <a:lstStyle/>
+          <a:p>
+            <a:pPr algn="l"/>
+            <a:r>
+              <a:rPr sz="900" b="0">
+                <a:solidFill>
+                  <a:srgbClr val="1E293B"/>
+                </a:solidFill>
+              </a:rPr>
+              <a:t>MEDIUM</a:t>
             </a:r>
           </a:p>
         </p:txBody>
@@ -3223,82 +4750,664 @@
       <p:grpSpPr/>
       <p:sp>
         <p:nvSpPr>
-          <p:cNvPr id="2" name="Title 1"/>
-          <p:cNvSpPr>
-            <a:spLocks noGrp="1"/>
-          </p:cNvSpPr>
-          <p:nvPr>
-            <p:ph type="title"/>
-          </p:nvPr>
-        </p:nvSpPr>
-        <p:spPr/>
-        <p:txBody>
-          <a:bodyPr/>
-          <a:lstStyle/>
-          <a:p>
-            <a:r>
-              <a:t>Escalated Regions</a:t>
-            </a:r>
-          </a:p>
-        </p:txBody>
-      </p:sp>
-      <p:sp>
-        <p:nvSpPr>
-          <p:cNvPr id="3" name="Content Placeholder 2"/>
-          <p:cNvSpPr>
-            <a:spLocks noGrp="1"/>
-          </p:cNvSpPr>
-          <p:nvPr>
-            <p:ph idx="1"/>
-          </p:nvPr>
-        </p:nvSpPr>
-        <p:spPr/>
-        <p:txBody>
-          <a:bodyPr/>
-          <a:lstStyle/>
-          <a:p>
-            <a:r>
-              <a:t>### AME — $22,000,000 at Risk | Severity: Critical</a:t>
-            </a:r>
-          </a:p>
-          <a:p>
-            <a:r>
-              <a:t>**Primary Scenario:** Ransomware</a:t>
-            </a:r>
-          </a:p>
-          <a:p>
-            <a:r>
-              <a:t>Ransomware remains the highest-impact scenario globally and poses an acute threat to AeroGrid's Americas operations, where supply chain coordination and customer delivery timelines are most vulnerable to disruption. A successful event could halt order fulfillment and trigger contractual penalties, making this the top priority for executive risk oversight. The $22M exposure reflects both direct recovery costs and downstream revenue loss from extended operational downtime.</a:t>
-            </a:r>
-          </a:p>
-          <a:p>
-            <a:r>
-              <a:t>### APAC — $18,500,000 at Risk | Severity: High</a:t>
-            </a:r>
-          </a:p>
-          <a:p>
-            <a:r>
-              <a:t>**Primary Scenario:** System intrusion</a:t>
-            </a:r>
-          </a:p>
-          <a:p>
-            <a:r>
-              <a:t>System intrusion activity in APAC directly threatens the manufacturing backbone that accounts for 75% of AeroGrid's revenue, where unauthorized access to industrial control environments could disrupt turbine production schedules. The $18.5M exposure captures potential losses from production stoppages, intellectual property compromise, and reputational damage with regional energy clients. Elevated geopolitical tensions in the region increase the likelihood of state-aligned campaigns targeting critical energy infrastructure suppliers.</a:t>
-            </a:r>
-          </a:p>
-          <a:p>
-            <a:r>
-              <a:t>### MED — $4,200,000 at Risk | Severity: Medium</a:t>
-            </a:r>
-          </a:p>
-          <a:p>
-            <a:r>
-              <a:t>**Primary Scenario:** Insider misuse</a:t>
-            </a:r>
-          </a:p>
-          <a:p>
-            <a:r>
-              <a:t>Insider misuse in the Mediterranean region presents a lower-frequency but high-consequence risk to AeroGrid's global service and maintenance operations, where privileged access to client site data and turbine diagnostics is inherent to daily workflows. The $4.2M exposure reflects potential losses from data exfiltration, sabotage of maintenance records, or unauthorized disclosure of client operational information. While severity is moderate relative to other regions, the trusted-access nature of this threat makes it resistant to purely technical controls and requires sustained governance focus.</a:t>
+          <p:cNvPr id="2" name="Rectangle 1"/>
+          <p:cNvSpPr/>
+          <p:nvPr/>
+        </p:nvSpPr>
+        <p:spPr>
+          <a:xfrm>
+            <a:off x="0" y="0"/>
+            <a:ext cx="9144000" cy="594360"/>
+          </a:xfrm>
+          <a:prstGeom prst="rect">
+            <a:avLst/>
+          </a:prstGeom>
+          <a:solidFill>
+            <a:srgbClr val="104277"/>
+          </a:solidFill>
+          <a:ln>
+            <a:noFill/>
+          </a:ln>
+        </p:spPr>
+        <p:style>
+          <a:lnRef idx="1">
+            <a:schemeClr val="accent1"/>
+          </a:lnRef>
+          <a:fillRef idx="3">
+            <a:schemeClr val="accent1"/>
+          </a:fillRef>
+          <a:effectRef idx="2">
+            <a:schemeClr val="accent1"/>
+          </a:effectRef>
+          <a:fontRef idx="minor">
+            <a:schemeClr val="lt1"/>
+          </a:fontRef>
+        </p:style>
+        <p:txBody>
+          <a:bodyPr rtlCol="0" anchor="ctr"/>
+          <a:lstStyle/>
+          <a:p>
+            <a:pPr algn="ctr"/>
+          </a:p>
+        </p:txBody>
+      </p:sp>
+      <p:sp>
+        <p:nvSpPr>
+          <p:cNvPr id="3" name="TextBox 2"/>
+          <p:cNvSpPr txBox="1"/>
+          <p:nvPr/>
+        </p:nvSpPr>
+        <p:spPr>
+          <a:xfrm>
+            <a:off x="274320" y="91440"/>
+            <a:ext cx="5486400" cy="411480"/>
+          </a:xfrm>
+          <a:prstGeom prst="rect">
+            <a:avLst/>
+          </a:prstGeom>
+          <a:noFill/>
+        </p:spPr>
+        <p:txBody>
+          <a:bodyPr wrap="square">
+            <a:spAutoFit/>
+          </a:bodyPr>
+          <a:lstStyle/>
+          <a:p>
+            <a:pPr algn="l"/>
+            <a:r>
+              <a:rPr sz="1600" b="1">
+                <a:solidFill>
+                  <a:srgbClr val="FFFFFF"/>
+                </a:solidFill>
+              </a:rPr>
+              <a:t>APAC</a:t>
+            </a:r>
+          </a:p>
+        </p:txBody>
+      </p:sp>
+      <p:sp>
+        <p:nvSpPr>
+          <p:cNvPr id="4" name="TextBox 3"/>
+          <p:cNvSpPr txBox="1"/>
+          <p:nvPr/>
+        </p:nvSpPr>
+        <p:spPr>
+          <a:xfrm>
+            <a:off x="274320" y="347472"/>
+            <a:ext cx="5486400" cy="228600"/>
+          </a:xfrm>
+          <a:prstGeom prst="rect">
+            <a:avLst/>
+          </a:prstGeom>
+          <a:noFill/>
+        </p:spPr>
+        <p:txBody>
+          <a:bodyPr wrap="square">
+            <a:spAutoFit/>
+          </a:bodyPr>
+          <a:lstStyle/>
+          <a:p>
+            <a:pPr algn="l"/>
+            <a:r>
+              <a:rPr sz="900" b="0">
+                <a:solidFill>
+                  <a:srgbClr val="BFDBFF"/>
+                </a:solidFill>
+              </a:rPr>
+              <a:t>System intrusion</a:t>
+            </a:r>
+          </a:p>
+        </p:txBody>
+      </p:sp>
+      <p:sp>
+        <p:nvSpPr>
+          <p:cNvPr id="5" name="Rectangle 4"/>
+          <p:cNvSpPr/>
+          <p:nvPr/>
+        </p:nvSpPr>
+        <p:spPr>
+          <a:xfrm>
+            <a:off x="7680960" y="109728"/>
+            <a:ext cx="1188720" cy="347472"/>
+          </a:xfrm>
+          <a:prstGeom prst="rect">
+            <a:avLst/>
+          </a:prstGeom>
+          <a:solidFill>
+            <a:srgbClr val="DC2626"/>
+          </a:solidFill>
+          <a:ln>
+            <a:noFill/>
+          </a:ln>
+        </p:spPr>
+        <p:style>
+          <a:lnRef idx="1">
+            <a:schemeClr val="accent1"/>
+          </a:lnRef>
+          <a:fillRef idx="3">
+            <a:schemeClr val="accent1"/>
+          </a:fillRef>
+          <a:effectRef idx="2">
+            <a:schemeClr val="accent1"/>
+          </a:effectRef>
+          <a:fontRef idx="minor">
+            <a:schemeClr val="lt1"/>
+          </a:fontRef>
+        </p:style>
+        <p:txBody>
+          <a:bodyPr rtlCol="0" anchor="ctr"/>
+          <a:lstStyle/>
+          <a:p>
+            <a:pPr algn="ctr"/>
+          </a:p>
+        </p:txBody>
+      </p:sp>
+      <p:sp>
+        <p:nvSpPr>
+          <p:cNvPr id="6" name="TextBox 5"/>
+          <p:cNvSpPr txBox="1"/>
+          <p:nvPr/>
+        </p:nvSpPr>
+        <p:spPr>
+          <a:xfrm>
+            <a:off x="7680960" y="146304"/>
+            <a:ext cx="1188720" cy="274320"/>
+          </a:xfrm>
+          <a:prstGeom prst="rect">
+            <a:avLst/>
+          </a:prstGeom>
+          <a:noFill/>
+        </p:spPr>
+        <p:txBody>
+          <a:bodyPr wrap="square">
+            <a:spAutoFit/>
+          </a:bodyPr>
+          <a:lstStyle/>
+          <a:p>
+            <a:pPr algn="ctr"/>
+            <a:r>
+              <a:rPr sz="800" b="1">
+                <a:solidFill>
+                  <a:srgbClr val="FFFFFF"/>
+                </a:solidFill>
+              </a:rPr>
+              <a:t>ESCALATED</a:t>
+            </a:r>
+          </a:p>
+        </p:txBody>
+      </p:sp>
+      <p:sp>
+        <p:nvSpPr>
+          <p:cNvPr id="7" name="TextBox 6"/>
+          <p:cNvSpPr txBox="1"/>
+          <p:nvPr/>
+        </p:nvSpPr>
+        <p:spPr>
+          <a:xfrm>
+            <a:off x="274320" y="777240"/>
+            <a:ext cx="1280160" cy="274320"/>
+          </a:xfrm>
+          <a:prstGeom prst="rect">
+            <a:avLst/>
+          </a:prstGeom>
+          <a:noFill/>
+        </p:spPr>
+        <p:txBody>
+          <a:bodyPr wrap="square">
+            <a:spAutoFit/>
+          </a:bodyPr>
+          <a:lstStyle/>
+          <a:p>
+            <a:pPr algn="l"/>
+            <a:r>
+              <a:rPr sz="700" b="0">
+                <a:solidFill>
+                  <a:srgbClr val="64748B"/>
+                </a:solidFill>
+              </a:rPr>
+              <a:t>VaCR Exposure</a:t>
+            </a:r>
+          </a:p>
+        </p:txBody>
+      </p:sp>
+      <p:sp>
+        <p:nvSpPr>
+          <p:cNvPr id="8" name="TextBox 7"/>
+          <p:cNvSpPr txBox="1"/>
+          <p:nvPr/>
+        </p:nvSpPr>
+        <p:spPr>
+          <a:xfrm>
+            <a:off x="274320" y="1069848"/>
+            <a:ext cx="1280160" cy="640080"/>
+          </a:xfrm>
+          <a:prstGeom prst="rect">
+            <a:avLst/>
+          </a:prstGeom>
+          <a:noFill/>
+        </p:spPr>
+        <p:txBody>
+          <a:bodyPr wrap="square">
+            <a:spAutoFit/>
+          </a:bodyPr>
+          <a:lstStyle/>
+          <a:p>
+            <a:pPr algn="l"/>
+            <a:r>
+              <a:rPr sz="1600" b="1">
+                <a:solidFill>
+                  <a:srgbClr val="104277"/>
+                </a:solidFill>
+              </a:rPr>
+              <a:t>$18.5M</a:t>
+            </a:r>
+          </a:p>
+        </p:txBody>
+      </p:sp>
+      <p:sp>
+        <p:nvSpPr>
+          <p:cNvPr id="9" name="TextBox 8"/>
+          <p:cNvSpPr txBox="1"/>
+          <p:nvPr/>
+        </p:nvSpPr>
+        <p:spPr>
+          <a:xfrm>
+            <a:off x="274320" y="2194560"/>
+            <a:ext cx="1280160" cy="274320"/>
+          </a:xfrm>
+          <a:prstGeom prst="rect">
+            <a:avLst/>
+          </a:prstGeom>
+          <a:noFill/>
+        </p:spPr>
+        <p:txBody>
+          <a:bodyPr wrap="square">
+            <a:spAutoFit/>
+          </a:bodyPr>
+          <a:lstStyle/>
+          <a:p>
+            <a:pPr algn="l"/>
+            <a:r>
+              <a:rPr sz="700" b="0">
+                <a:solidFill>
+                  <a:srgbClr val="64748B"/>
+                </a:solidFill>
+              </a:rPr>
+              <a:t>Admiralty</a:t>
+            </a:r>
+          </a:p>
+        </p:txBody>
+      </p:sp>
+      <p:sp>
+        <p:nvSpPr>
+          <p:cNvPr id="10" name="TextBox 9"/>
+          <p:cNvSpPr txBox="1"/>
+          <p:nvPr/>
+        </p:nvSpPr>
+        <p:spPr>
+          <a:xfrm>
+            <a:off x="274320" y="2487168"/>
+            <a:ext cx="1280160" cy="640080"/>
+          </a:xfrm>
+          <a:prstGeom prst="rect">
+            <a:avLst/>
+          </a:prstGeom>
+          <a:noFill/>
+        </p:spPr>
+        <p:txBody>
+          <a:bodyPr wrap="square">
+            <a:spAutoFit/>
+          </a:bodyPr>
+          <a:lstStyle/>
+          <a:p>
+            <a:pPr algn="l"/>
+            <a:r>
+              <a:rPr sz="1600" b="1">
+                <a:solidFill>
+                  <a:srgbClr val="104277"/>
+                </a:solidFill>
+              </a:rPr>
+              <a:t>B2</a:t>
+            </a:r>
+          </a:p>
+        </p:txBody>
+      </p:sp>
+      <p:sp>
+        <p:nvSpPr>
+          <p:cNvPr id="11" name="TextBox 10"/>
+          <p:cNvSpPr txBox="1"/>
+          <p:nvPr/>
+        </p:nvSpPr>
+        <p:spPr>
+          <a:xfrm>
+            <a:off x="274320" y="3611880"/>
+            <a:ext cx="1280160" cy="274320"/>
+          </a:xfrm>
+          <a:prstGeom prst="rect">
+            <a:avLst/>
+          </a:prstGeom>
+          <a:noFill/>
+        </p:spPr>
+        <p:txBody>
+          <a:bodyPr wrap="square">
+            <a:spAutoFit/>
+          </a:bodyPr>
+          <a:lstStyle/>
+          <a:p>
+            <a:pPr algn="l"/>
+            <a:r>
+              <a:rPr sz="700" b="0">
+                <a:solidFill>
+                  <a:srgbClr val="64748B"/>
+                </a:solidFill>
+              </a:rPr>
+              <a:t>Velocity</a:t>
+            </a:r>
+          </a:p>
+        </p:txBody>
+      </p:sp>
+      <p:sp>
+        <p:nvSpPr>
+          <p:cNvPr id="12" name="TextBox 11"/>
+          <p:cNvSpPr txBox="1"/>
+          <p:nvPr/>
+        </p:nvSpPr>
+        <p:spPr>
+          <a:xfrm>
+            <a:off x="274320" y="3904488"/>
+            <a:ext cx="1280160" cy="640080"/>
+          </a:xfrm>
+          <a:prstGeom prst="rect">
+            <a:avLst/>
+          </a:prstGeom>
+          <a:noFill/>
+        </p:spPr>
+        <p:txBody>
+          <a:bodyPr wrap="square">
+            <a:spAutoFit/>
+          </a:bodyPr>
+          <a:lstStyle/>
+          <a:p>
+            <a:pPr algn="l"/>
+            <a:r>
+              <a:rPr sz="1600" b="1">
+                <a:solidFill>
+                  <a:srgbClr val="64748B"/>
+                </a:solidFill>
+              </a:rPr>
+              <a:t>→ Stable</a:t>
+            </a:r>
+          </a:p>
+        </p:txBody>
+      </p:sp>
+      <p:sp>
+        <p:nvSpPr>
+          <p:cNvPr id="13" name="TextBox 12"/>
+          <p:cNvSpPr txBox="1"/>
+          <p:nvPr/>
+        </p:nvSpPr>
+        <p:spPr>
+          <a:xfrm>
+            <a:off x="274320" y="5029200"/>
+            <a:ext cx="1280160" cy="274320"/>
+          </a:xfrm>
+          <a:prstGeom prst="rect">
+            <a:avLst/>
+          </a:prstGeom>
+          <a:noFill/>
+        </p:spPr>
+        <p:txBody>
+          <a:bodyPr wrap="square">
+            <a:spAutoFit/>
+          </a:bodyPr>
+          <a:lstStyle/>
+          <a:p>
+            <a:pPr algn="l"/>
+            <a:r>
+              <a:rPr sz="700" b="0">
+                <a:solidFill>
+                  <a:srgbClr val="64748B"/>
+                </a:solidFill>
+              </a:rPr>
+              <a:t>Severity</a:t>
+            </a:r>
+          </a:p>
+        </p:txBody>
+      </p:sp>
+      <p:sp>
+        <p:nvSpPr>
+          <p:cNvPr id="14" name="TextBox 13"/>
+          <p:cNvSpPr txBox="1"/>
+          <p:nvPr/>
+        </p:nvSpPr>
+        <p:spPr>
+          <a:xfrm>
+            <a:off x="274320" y="5321808"/>
+            <a:ext cx="1280160" cy="640080"/>
+          </a:xfrm>
+          <a:prstGeom prst="rect">
+            <a:avLst/>
+          </a:prstGeom>
+          <a:noFill/>
+        </p:spPr>
+        <p:txBody>
+          <a:bodyPr wrap="square">
+            <a:spAutoFit/>
+          </a:bodyPr>
+          <a:lstStyle/>
+          <a:p>
+            <a:pPr algn="l"/>
+            <a:r>
+              <a:rPr sz="1600" b="1">
+                <a:solidFill>
+                  <a:srgbClr val="DC2626"/>
+                </a:solidFill>
+              </a:rPr>
+              <a:t>HIGH</a:t>
+            </a:r>
+          </a:p>
+        </p:txBody>
+      </p:sp>
+      <p:sp>
+        <p:nvSpPr>
+          <p:cNvPr id="15" name="TextBox 14"/>
+          <p:cNvSpPr txBox="1"/>
+          <p:nvPr/>
+        </p:nvSpPr>
+        <p:spPr>
+          <a:xfrm>
+            <a:off x="1737360" y="777240"/>
+            <a:ext cx="7132320" cy="256032"/>
+          </a:xfrm>
+          <a:prstGeom prst="rect">
+            <a:avLst/>
+          </a:prstGeom>
+          <a:noFill/>
+        </p:spPr>
+        <p:txBody>
+          <a:bodyPr wrap="square">
+            <a:spAutoFit/>
+          </a:bodyPr>
+          <a:lstStyle/>
+          <a:p>
+            <a:pPr algn="l"/>
+            <a:r>
+              <a:rPr sz="800" b="1">
+                <a:solidFill>
+                  <a:srgbClr val="104277"/>
+                </a:solidFill>
+              </a:rPr>
+              <a:t>WHY — GEOPOLITICAL DRIVER</a:t>
+            </a:r>
+          </a:p>
+        </p:txBody>
+      </p:sp>
+      <p:sp>
+        <p:nvSpPr>
+          <p:cNvPr id="16" name="TextBox 15"/>
+          <p:cNvSpPr txBox="1"/>
+          <p:nvPr/>
+        </p:nvSpPr>
+        <p:spPr>
+          <a:xfrm>
+            <a:off x="1737360" y="1051560"/>
+            <a:ext cx="7132320" cy="1371600"/>
+          </a:xfrm>
+          <a:prstGeom prst="rect">
+            <a:avLst/>
+          </a:prstGeom>
+          <a:noFill/>
+        </p:spPr>
+        <p:txBody>
+          <a:bodyPr wrap="square">
+            <a:spAutoFit/>
+          </a:bodyPr>
+          <a:lstStyle/>
+          <a:p>
+            <a:pPr algn="l"/>
+            <a:r>
+              <a:rPr sz="900" b="0">
+                <a:solidFill>
+                  <a:srgbClr val="1E293B"/>
+                </a:solidFill>
+              </a:rPr>
+              <a:t>AeroGrid's ability to maintain uninterrupted blade manufacturing output across its APAC facilities faces growing pressure from escalating territorial disputes in the South China Sea. State-sponsored industrial espionage campaigns have intensified as multinational manufacturers accelerate supply chain diversification away from single-region dependencies. The convergence of China-Taiwan strait tensi</a:t>
+            </a:r>
+          </a:p>
+        </p:txBody>
+      </p:sp>
+      <p:sp>
+        <p:nvSpPr>
+          <p:cNvPr id="17" name="TextBox 16"/>
+          <p:cNvSpPr txBox="1"/>
+          <p:nvPr/>
+        </p:nvSpPr>
+        <p:spPr>
+          <a:xfrm>
+            <a:off x="1737360" y="2697480"/>
+            <a:ext cx="7132320" cy="256032"/>
+          </a:xfrm>
+          <a:prstGeom prst="rect">
+            <a:avLst/>
+          </a:prstGeom>
+          <a:noFill/>
+        </p:spPr>
+        <p:txBody>
+          <a:bodyPr wrap="square">
+            <a:spAutoFit/>
+          </a:bodyPr>
+          <a:lstStyle/>
+          <a:p>
+            <a:pPr algn="l"/>
+            <a:r>
+              <a:rPr sz="800" b="1">
+                <a:solidFill>
+                  <a:srgbClr val="104277"/>
+                </a:solidFill>
+              </a:rPr>
+              <a:t>HOW — CYBER VECTOR</a:t>
+            </a:r>
+          </a:p>
+        </p:txBody>
+      </p:sp>
+      <p:sp>
+        <p:nvSpPr>
+          <p:cNvPr id="18" name="TextBox 17"/>
+          <p:cNvSpPr txBox="1"/>
+          <p:nvPr/>
+        </p:nvSpPr>
+        <p:spPr>
+          <a:xfrm>
+            <a:off x="1737360" y="2971800"/>
+            <a:ext cx="7132320" cy="1371600"/>
+          </a:xfrm>
+          <a:prstGeom prst="rect">
+            <a:avLst/>
+          </a:prstGeom>
+          <a:noFill/>
+        </p:spPr>
+        <p:txBody>
+          <a:bodyPr wrap="square">
+            <a:spAutoFit/>
+          </a:bodyPr>
+          <a:lstStyle/>
+          <a:p>
+            <a:pPr algn="l"/>
+            <a:r>
+              <a:rPr sz="900" b="0">
+                <a:solidFill>
+                  <a:srgbClr val="1E293B"/>
+                </a:solidFill>
+              </a:rPr>
+              <a:t>This geopolitical pressure is manifesting as documented intrusion campaigns targeting operational technology networks in the Asia-Pacific manufacturing sector. Security researchers have identified a supply chain compromise through third-party industrial automation software updates — a vector that provides persistent access to blade production line control systems. AeroGrid's proprietary turbine ae</a:t>
+            </a:r>
+          </a:p>
+        </p:txBody>
+      </p:sp>
+      <p:sp>
+        <p:nvSpPr>
+          <p:cNvPr id="19" name="TextBox 18"/>
+          <p:cNvSpPr txBox="1"/>
+          <p:nvPr/>
+        </p:nvSpPr>
+        <p:spPr>
+          <a:xfrm>
+            <a:off x="1737360" y="4617720"/>
+            <a:ext cx="7132320" cy="256032"/>
+          </a:xfrm>
+          <a:prstGeom prst="rect">
+            <a:avLst/>
+          </a:prstGeom>
+          <a:noFill/>
+        </p:spPr>
+        <p:txBody>
+          <a:bodyPr wrap="square">
+            <a:spAutoFit/>
+          </a:bodyPr>
+          <a:lstStyle/>
+          <a:p>
+            <a:pPr algn="l"/>
+            <a:r>
+              <a:rPr sz="800" b="1">
+                <a:solidFill>
+                  <a:srgbClr val="104277"/>
+                </a:solidFill>
+              </a:rPr>
+              <a:t>SO WHAT — BUSINESS IMPACT</a:t>
+            </a:r>
+          </a:p>
+        </p:txBody>
+      </p:sp>
+      <p:sp>
+        <p:nvSpPr>
+          <p:cNvPr id="20" name="TextBox 19"/>
+          <p:cNvSpPr txBox="1"/>
+          <p:nvPr/>
+        </p:nvSpPr>
+        <p:spPr>
+          <a:xfrm>
+            <a:off x="1737360" y="4892040"/>
+            <a:ext cx="7132320" cy="1371600"/>
+          </a:xfrm>
+          <a:prstGeom prst="rect">
+            <a:avLst/>
+          </a:prstGeom>
+          <a:noFill/>
+        </p:spPr>
+        <p:txBody>
+          <a:bodyPr wrap="square">
+            <a:spAutoFit/>
+          </a:bodyPr>
+          <a:lstStyle/>
+          <a:p>
+            <a:pPr algn="l"/>
+            <a:r>
+              <a:rPr sz="900" b="0">
+                <a:solidFill>
+                  <a:srgbClr val="1E293B"/>
+                </a:solidFill>
+              </a:rPr>
+              <a:t>The Value at Cyber Risk exposure for APAC stands at $18,500,000. This pattern is consistent with the System intrusion scenario, ranked #3 globally by financial impact (21.4% of all losses) and #1 by event frequency (43.3% of all incidents). The trend trajectory indicates increasing state-sponsored targeting of wind energy manufacturing IP, with no near-term de-escalation signals from the underlyin</a:t>
             </a:r>
           </a:p>
         </p:txBody>
@@ -3323,67 +5432,1747 @@
       <p:grpSpPr/>
       <p:sp>
         <p:nvSpPr>
-          <p:cNvPr id="2" name="Title 1"/>
-          <p:cNvSpPr>
-            <a:spLocks noGrp="1"/>
-          </p:cNvSpPr>
-          <p:nvPr>
-            <p:ph type="title"/>
-          </p:nvPr>
-        </p:nvSpPr>
-        <p:spPr/>
-        <p:txBody>
-          <a:bodyPr/>
-          <a:lstStyle/>
-          <a:p>
-            <a:r>
-              <a:t>Clear Regions</a:t>
-            </a:r>
-          </a:p>
-        </p:txBody>
-      </p:sp>
-      <p:sp>
-        <p:nvSpPr>
-          <p:cNvPr id="3" name="Content Placeholder 2"/>
-          <p:cNvSpPr>
-            <a:spLocks noGrp="1"/>
-          </p:cNvSpPr>
-          <p:nvPr>
-            <p:ph idx="1"/>
-          </p:nvPr>
-        </p:nvSpPr>
-        <p:spPr/>
-        <p:txBody>
-          <a:bodyPr/>
-          <a:lstStyle/>
-          <a:p>
-            <a:r>
-              <a:t>### LATAM — Clear</a:t>
-            </a:r>
-          </a:p>
-          <a:p>
-            <a:r>
-              <a:t>No credible threat identified. Region operating within normal risk parameters.</a:t>
-            </a:r>
-          </a:p>
-          <a:p>
-            <a:r>
-              <a:t>### NCE — Clear</a:t>
-            </a:r>
-          </a:p>
-          <a:p>
-            <a:r>
-              <a:t>No credible threat identified. Region operating within normal risk parameters.</a:t>
-            </a:r>
-          </a:p>
-          <a:p>
-            <a:r>
-              <a:t>---</a:t>
-            </a:r>
-          </a:p>
-          <a:p>
-            <a:r>
-              <a:t>*Regions escalated: 3 | Regions clear: 2 | Source: Enterprise CRQ Application*</a:t>
+          <p:cNvPr id="2" name="Rectangle 1"/>
+          <p:cNvSpPr/>
+          <p:nvPr/>
+        </p:nvSpPr>
+        <p:spPr>
+          <a:xfrm>
+            <a:off x="0" y="0"/>
+            <a:ext cx="9144000" cy="594360"/>
+          </a:xfrm>
+          <a:prstGeom prst="rect">
+            <a:avLst/>
+          </a:prstGeom>
+          <a:solidFill>
+            <a:srgbClr val="104277"/>
+          </a:solidFill>
+          <a:ln>
+            <a:noFill/>
+          </a:ln>
+        </p:spPr>
+        <p:style>
+          <a:lnRef idx="1">
+            <a:schemeClr val="accent1"/>
+          </a:lnRef>
+          <a:fillRef idx="3">
+            <a:schemeClr val="accent1"/>
+          </a:fillRef>
+          <a:effectRef idx="2">
+            <a:schemeClr val="accent1"/>
+          </a:effectRef>
+          <a:fontRef idx="minor">
+            <a:schemeClr val="lt1"/>
+          </a:fontRef>
+        </p:style>
+        <p:txBody>
+          <a:bodyPr rtlCol="0" anchor="ctr"/>
+          <a:lstStyle/>
+          <a:p>
+            <a:pPr algn="ctr"/>
+          </a:p>
+        </p:txBody>
+      </p:sp>
+      <p:sp>
+        <p:nvSpPr>
+          <p:cNvPr id="3" name="TextBox 2"/>
+          <p:cNvSpPr txBox="1"/>
+          <p:nvPr/>
+        </p:nvSpPr>
+        <p:spPr>
+          <a:xfrm>
+            <a:off x="274320" y="91440"/>
+            <a:ext cx="5486400" cy="411480"/>
+          </a:xfrm>
+          <a:prstGeom prst="rect">
+            <a:avLst/>
+          </a:prstGeom>
+          <a:noFill/>
+        </p:spPr>
+        <p:txBody>
+          <a:bodyPr wrap="square">
+            <a:spAutoFit/>
+          </a:bodyPr>
+          <a:lstStyle/>
+          <a:p>
+            <a:pPr algn="l"/>
+            <a:r>
+              <a:rPr sz="1600" b="1">
+                <a:solidFill>
+                  <a:srgbClr val="FFFFFF"/>
+                </a:solidFill>
+              </a:rPr>
+              <a:t>AME</a:t>
+            </a:r>
+          </a:p>
+        </p:txBody>
+      </p:sp>
+      <p:sp>
+        <p:nvSpPr>
+          <p:cNvPr id="4" name="TextBox 3"/>
+          <p:cNvSpPr txBox="1"/>
+          <p:nvPr/>
+        </p:nvSpPr>
+        <p:spPr>
+          <a:xfrm>
+            <a:off x="274320" y="347472"/>
+            <a:ext cx="5486400" cy="228600"/>
+          </a:xfrm>
+          <a:prstGeom prst="rect">
+            <a:avLst/>
+          </a:prstGeom>
+          <a:noFill/>
+        </p:spPr>
+        <p:txBody>
+          <a:bodyPr wrap="square">
+            <a:spAutoFit/>
+          </a:bodyPr>
+          <a:lstStyle/>
+          <a:p>
+            <a:pPr algn="l"/>
+            <a:r>
+              <a:rPr sz="900" b="0">
+                <a:solidFill>
+                  <a:srgbClr val="BFDBFF"/>
+                </a:solidFill>
+              </a:rPr>
+              <a:t>Ransomware</a:t>
+            </a:r>
+          </a:p>
+        </p:txBody>
+      </p:sp>
+      <p:sp>
+        <p:nvSpPr>
+          <p:cNvPr id="5" name="Rectangle 4"/>
+          <p:cNvSpPr/>
+          <p:nvPr/>
+        </p:nvSpPr>
+        <p:spPr>
+          <a:xfrm>
+            <a:off x="7680960" y="109728"/>
+            <a:ext cx="1188720" cy="347472"/>
+          </a:xfrm>
+          <a:prstGeom prst="rect">
+            <a:avLst/>
+          </a:prstGeom>
+          <a:solidFill>
+            <a:srgbClr val="DC2626"/>
+          </a:solidFill>
+          <a:ln>
+            <a:noFill/>
+          </a:ln>
+        </p:spPr>
+        <p:style>
+          <a:lnRef idx="1">
+            <a:schemeClr val="accent1"/>
+          </a:lnRef>
+          <a:fillRef idx="3">
+            <a:schemeClr val="accent1"/>
+          </a:fillRef>
+          <a:effectRef idx="2">
+            <a:schemeClr val="accent1"/>
+          </a:effectRef>
+          <a:fontRef idx="minor">
+            <a:schemeClr val="lt1"/>
+          </a:fontRef>
+        </p:style>
+        <p:txBody>
+          <a:bodyPr rtlCol="0" anchor="ctr"/>
+          <a:lstStyle/>
+          <a:p>
+            <a:pPr algn="ctr"/>
+          </a:p>
+        </p:txBody>
+      </p:sp>
+      <p:sp>
+        <p:nvSpPr>
+          <p:cNvPr id="6" name="TextBox 5"/>
+          <p:cNvSpPr txBox="1"/>
+          <p:nvPr/>
+        </p:nvSpPr>
+        <p:spPr>
+          <a:xfrm>
+            <a:off x="7680960" y="146304"/>
+            <a:ext cx="1188720" cy="274320"/>
+          </a:xfrm>
+          <a:prstGeom prst="rect">
+            <a:avLst/>
+          </a:prstGeom>
+          <a:noFill/>
+        </p:spPr>
+        <p:txBody>
+          <a:bodyPr wrap="square">
+            <a:spAutoFit/>
+          </a:bodyPr>
+          <a:lstStyle/>
+          <a:p>
+            <a:pPr algn="ctr"/>
+            <a:r>
+              <a:rPr sz="800" b="1">
+                <a:solidFill>
+                  <a:srgbClr val="FFFFFF"/>
+                </a:solidFill>
+              </a:rPr>
+              <a:t>ESCALATED</a:t>
+            </a:r>
+          </a:p>
+        </p:txBody>
+      </p:sp>
+      <p:sp>
+        <p:nvSpPr>
+          <p:cNvPr id="7" name="TextBox 6"/>
+          <p:cNvSpPr txBox="1"/>
+          <p:nvPr/>
+        </p:nvSpPr>
+        <p:spPr>
+          <a:xfrm>
+            <a:off x="274320" y="777240"/>
+            <a:ext cx="1280160" cy="274320"/>
+          </a:xfrm>
+          <a:prstGeom prst="rect">
+            <a:avLst/>
+          </a:prstGeom>
+          <a:noFill/>
+        </p:spPr>
+        <p:txBody>
+          <a:bodyPr wrap="square">
+            <a:spAutoFit/>
+          </a:bodyPr>
+          <a:lstStyle/>
+          <a:p>
+            <a:pPr algn="l"/>
+            <a:r>
+              <a:rPr sz="700" b="0">
+                <a:solidFill>
+                  <a:srgbClr val="64748B"/>
+                </a:solidFill>
+              </a:rPr>
+              <a:t>VaCR Exposure</a:t>
+            </a:r>
+          </a:p>
+        </p:txBody>
+      </p:sp>
+      <p:sp>
+        <p:nvSpPr>
+          <p:cNvPr id="8" name="TextBox 7"/>
+          <p:cNvSpPr txBox="1"/>
+          <p:nvPr/>
+        </p:nvSpPr>
+        <p:spPr>
+          <a:xfrm>
+            <a:off x="274320" y="1069848"/>
+            <a:ext cx="1280160" cy="640080"/>
+          </a:xfrm>
+          <a:prstGeom prst="rect">
+            <a:avLst/>
+          </a:prstGeom>
+          <a:noFill/>
+        </p:spPr>
+        <p:txBody>
+          <a:bodyPr wrap="square">
+            <a:spAutoFit/>
+          </a:bodyPr>
+          <a:lstStyle/>
+          <a:p>
+            <a:pPr algn="l"/>
+            <a:r>
+              <a:rPr sz="1600" b="1">
+                <a:solidFill>
+                  <a:srgbClr val="104277"/>
+                </a:solidFill>
+              </a:rPr>
+              <a:t>$22.0M</a:t>
+            </a:r>
+          </a:p>
+        </p:txBody>
+      </p:sp>
+      <p:sp>
+        <p:nvSpPr>
+          <p:cNvPr id="9" name="TextBox 8"/>
+          <p:cNvSpPr txBox="1"/>
+          <p:nvPr/>
+        </p:nvSpPr>
+        <p:spPr>
+          <a:xfrm>
+            <a:off x="274320" y="2194560"/>
+            <a:ext cx="1280160" cy="274320"/>
+          </a:xfrm>
+          <a:prstGeom prst="rect">
+            <a:avLst/>
+          </a:prstGeom>
+          <a:noFill/>
+        </p:spPr>
+        <p:txBody>
+          <a:bodyPr wrap="square">
+            <a:spAutoFit/>
+          </a:bodyPr>
+          <a:lstStyle/>
+          <a:p>
+            <a:pPr algn="l"/>
+            <a:r>
+              <a:rPr sz="700" b="0">
+                <a:solidFill>
+                  <a:srgbClr val="64748B"/>
+                </a:solidFill>
+              </a:rPr>
+              <a:t>Admiralty</a:t>
+            </a:r>
+          </a:p>
+        </p:txBody>
+      </p:sp>
+      <p:sp>
+        <p:nvSpPr>
+          <p:cNvPr id="10" name="TextBox 9"/>
+          <p:cNvSpPr txBox="1"/>
+          <p:nvPr/>
+        </p:nvSpPr>
+        <p:spPr>
+          <a:xfrm>
+            <a:off x="274320" y="2487168"/>
+            <a:ext cx="1280160" cy="640080"/>
+          </a:xfrm>
+          <a:prstGeom prst="rect">
+            <a:avLst/>
+          </a:prstGeom>
+          <a:noFill/>
+        </p:spPr>
+        <p:txBody>
+          <a:bodyPr wrap="square">
+            <a:spAutoFit/>
+          </a:bodyPr>
+          <a:lstStyle/>
+          <a:p>
+            <a:pPr algn="l"/>
+            <a:r>
+              <a:rPr sz="1600" b="1">
+                <a:solidFill>
+                  <a:srgbClr val="104277"/>
+                </a:solidFill>
+              </a:rPr>
+              <a:t>B2</a:t>
+            </a:r>
+          </a:p>
+        </p:txBody>
+      </p:sp>
+      <p:sp>
+        <p:nvSpPr>
+          <p:cNvPr id="11" name="TextBox 10"/>
+          <p:cNvSpPr txBox="1"/>
+          <p:nvPr/>
+        </p:nvSpPr>
+        <p:spPr>
+          <a:xfrm>
+            <a:off x="274320" y="3611880"/>
+            <a:ext cx="1280160" cy="274320"/>
+          </a:xfrm>
+          <a:prstGeom prst="rect">
+            <a:avLst/>
+          </a:prstGeom>
+          <a:noFill/>
+        </p:spPr>
+        <p:txBody>
+          <a:bodyPr wrap="square">
+            <a:spAutoFit/>
+          </a:bodyPr>
+          <a:lstStyle/>
+          <a:p>
+            <a:pPr algn="l"/>
+            <a:r>
+              <a:rPr sz="700" b="0">
+                <a:solidFill>
+                  <a:srgbClr val="64748B"/>
+                </a:solidFill>
+              </a:rPr>
+              <a:t>Velocity</a:t>
+            </a:r>
+          </a:p>
+        </p:txBody>
+      </p:sp>
+      <p:sp>
+        <p:nvSpPr>
+          <p:cNvPr id="12" name="TextBox 11"/>
+          <p:cNvSpPr txBox="1"/>
+          <p:nvPr/>
+        </p:nvSpPr>
+        <p:spPr>
+          <a:xfrm>
+            <a:off x="274320" y="3904488"/>
+            <a:ext cx="1280160" cy="640080"/>
+          </a:xfrm>
+          <a:prstGeom prst="rect">
+            <a:avLst/>
+          </a:prstGeom>
+          <a:noFill/>
+        </p:spPr>
+        <p:txBody>
+          <a:bodyPr wrap="square">
+            <a:spAutoFit/>
+          </a:bodyPr>
+          <a:lstStyle/>
+          <a:p>
+            <a:pPr algn="l"/>
+            <a:r>
+              <a:rPr sz="1600" b="1">
+                <a:solidFill>
+                  <a:srgbClr val="64748B"/>
+                </a:solidFill>
+              </a:rPr>
+              <a:t>→ Stable</a:t>
+            </a:r>
+          </a:p>
+        </p:txBody>
+      </p:sp>
+      <p:sp>
+        <p:nvSpPr>
+          <p:cNvPr id="13" name="TextBox 12"/>
+          <p:cNvSpPr txBox="1"/>
+          <p:nvPr/>
+        </p:nvSpPr>
+        <p:spPr>
+          <a:xfrm>
+            <a:off x="274320" y="5029200"/>
+            <a:ext cx="1280160" cy="274320"/>
+          </a:xfrm>
+          <a:prstGeom prst="rect">
+            <a:avLst/>
+          </a:prstGeom>
+          <a:noFill/>
+        </p:spPr>
+        <p:txBody>
+          <a:bodyPr wrap="square">
+            <a:spAutoFit/>
+          </a:bodyPr>
+          <a:lstStyle/>
+          <a:p>
+            <a:pPr algn="l"/>
+            <a:r>
+              <a:rPr sz="700" b="0">
+                <a:solidFill>
+                  <a:srgbClr val="64748B"/>
+                </a:solidFill>
+              </a:rPr>
+              <a:t>Severity</a:t>
+            </a:r>
+          </a:p>
+        </p:txBody>
+      </p:sp>
+      <p:sp>
+        <p:nvSpPr>
+          <p:cNvPr id="14" name="TextBox 13"/>
+          <p:cNvSpPr txBox="1"/>
+          <p:nvPr/>
+        </p:nvSpPr>
+        <p:spPr>
+          <a:xfrm>
+            <a:off x="274320" y="5321808"/>
+            <a:ext cx="1280160" cy="640080"/>
+          </a:xfrm>
+          <a:prstGeom prst="rect">
+            <a:avLst/>
+          </a:prstGeom>
+          <a:noFill/>
+        </p:spPr>
+        <p:txBody>
+          <a:bodyPr wrap="square">
+            <a:spAutoFit/>
+          </a:bodyPr>
+          <a:lstStyle/>
+          <a:p>
+            <a:pPr algn="l"/>
+            <a:r>
+              <a:rPr sz="1600" b="1">
+                <a:solidFill>
+                  <a:srgbClr val="DC2626"/>
+                </a:solidFill>
+              </a:rPr>
+              <a:t>CRITICAL</a:t>
+            </a:r>
+          </a:p>
+        </p:txBody>
+      </p:sp>
+      <p:sp>
+        <p:nvSpPr>
+          <p:cNvPr id="15" name="TextBox 14"/>
+          <p:cNvSpPr txBox="1"/>
+          <p:nvPr/>
+        </p:nvSpPr>
+        <p:spPr>
+          <a:xfrm>
+            <a:off x="1737360" y="777240"/>
+            <a:ext cx="7132320" cy="256032"/>
+          </a:xfrm>
+          <a:prstGeom prst="rect">
+            <a:avLst/>
+          </a:prstGeom>
+          <a:noFill/>
+        </p:spPr>
+        <p:txBody>
+          <a:bodyPr wrap="square">
+            <a:spAutoFit/>
+          </a:bodyPr>
+          <a:lstStyle/>
+          <a:p>
+            <a:pPr algn="l"/>
+            <a:r>
+              <a:rPr sz="800" b="1">
+                <a:solidFill>
+                  <a:srgbClr val="104277"/>
+                </a:solidFill>
+              </a:rPr>
+              <a:t>WHY — GEOPOLITICAL DRIVER</a:t>
+            </a:r>
+          </a:p>
+        </p:txBody>
+      </p:sp>
+      <p:sp>
+        <p:nvSpPr>
+          <p:cNvPr id="16" name="TextBox 15"/>
+          <p:cNvSpPr txBox="1"/>
+          <p:nvPr/>
+        </p:nvSpPr>
+        <p:spPr>
+          <a:xfrm>
+            <a:off x="1737360" y="1051560"/>
+            <a:ext cx="7132320" cy="1371600"/>
+          </a:xfrm>
+          <a:prstGeom prst="rect">
+            <a:avLst/>
+          </a:prstGeom>
+          <a:noFill/>
+        </p:spPr>
+        <p:txBody>
+          <a:bodyPr wrap="square">
+            <a:spAutoFit/>
+          </a:bodyPr>
+          <a:lstStyle/>
+          <a:p>
+            <a:pPr algn="l"/>
+            <a:r>
+              <a:rPr sz="900" b="0">
+                <a:solidFill>
+                  <a:srgbClr val="1E293B"/>
+                </a:solidFill>
+              </a:rPr>
+              <a:t>AeroGrid's ability to deliver uninterrupted wind farm service operations across North America faces heightened risk as the regulatory environment undergoes structural change. A US executive order has designated offshore wind farm operations as critical national infrastructure, placing AeroGrid's telemetry and maintenance systems under mandatory cybersecurity reporting obligations. Simultaneously, </a:t>
+            </a:r>
+          </a:p>
+        </p:txBody>
+      </p:sp>
+      <p:sp>
+        <p:nvSpPr>
+          <p:cNvPr id="17" name="TextBox 16"/>
+          <p:cNvSpPr txBox="1"/>
+          <p:nvPr/>
+        </p:nvSpPr>
+        <p:spPr>
+          <a:xfrm>
+            <a:off x="1737360" y="2697480"/>
+            <a:ext cx="7132320" cy="256032"/>
+          </a:xfrm>
+          <a:prstGeom prst="rect">
+            <a:avLst/>
+          </a:prstGeom>
+          <a:noFill/>
+        </p:spPr>
+        <p:txBody>
+          <a:bodyPr wrap="square">
+            <a:spAutoFit/>
+          </a:bodyPr>
+          <a:lstStyle/>
+          <a:p>
+            <a:pPr algn="l"/>
+            <a:r>
+              <a:rPr sz="800" b="1">
+                <a:solidFill>
+                  <a:srgbClr val="104277"/>
+                </a:solidFill>
+              </a:rPr>
+              <a:t>HOW — CYBER VECTOR</a:t>
+            </a:r>
+          </a:p>
+        </p:txBody>
+      </p:sp>
+      <p:sp>
+        <p:nvSpPr>
+          <p:cNvPr id="18" name="TextBox 17"/>
+          <p:cNvSpPr txBox="1"/>
+          <p:nvPr/>
+        </p:nvSpPr>
+        <p:spPr>
+          <a:xfrm>
+            <a:off x="1737360" y="2971800"/>
+            <a:ext cx="7132320" cy="1371600"/>
+          </a:xfrm>
+          <a:prstGeom prst="rect">
+            <a:avLst/>
+          </a:prstGeom>
+          <a:noFill/>
+        </p:spPr>
+        <p:txBody>
+          <a:bodyPr wrap="square">
+            <a:spAutoFit/>
+          </a:bodyPr>
+          <a:lstStyle/>
+          <a:p>
+            <a:pPr algn="l"/>
+            <a:r>
+              <a:rPr sz="900" b="0">
+                <a:solidFill>
+                  <a:srgbClr val="1E293B"/>
+                </a:solidFill>
+              </a:rPr>
+              <a:t>This geopolitical backdrop has materialized into a confirmed operational threat. A financially motivated criminal group has successfully encrypted business systems at a North American energy operator, demanding $22 million and threatening release of proprietary turbine efficiency data. A separate double-extortion campaign targeted a wind energy predictive maintenance platform, resulting in 18 days</a:t>
+            </a:r>
+          </a:p>
+        </p:txBody>
+      </p:sp>
+      <p:sp>
+        <p:nvSpPr>
+          <p:cNvPr id="19" name="TextBox 18"/>
+          <p:cNvSpPr txBox="1"/>
+          <p:nvPr/>
+        </p:nvSpPr>
+        <p:spPr>
+          <a:xfrm>
+            <a:off x="1737360" y="4617720"/>
+            <a:ext cx="7132320" cy="256032"/>
+          </a:xfrm>
+          <a:prstGeom prst="rect">
+            <a:avLst/>
+          </a:prstGeom>
+          <a:noFill/>
+        </p:spPr>
+        <p:txBody>
+          <a:bodyPr wrap="square">
+            <a:spAutoFit/>
+          </a:bodyPr>
+          <a:lstStyle/>
+          <a:p>
+            <a:pPr algn="l"/>
+            <a:r>
+              <a:rPr sz="800" b="1">
+                <a:solidFill>
+                  <a:srgbClr val="104277"/>
+                </a:solidFill>
+              </a:rPr>
+              <a:t>SO WHAT — BUSINESS IMPACT</a:t>
+            </a:r>
+          </a:p>
+        </p:txBody>
+      </p:sp>
+      <p:sp>
+        <p:nvSpPr>
+          <p:cNvPr id="20" name="TextBox 19"/>
+          <p:cNvSpPr txBox="1"/>
+          <p:nvPr/>
+        </p:nvSpPr>
+        <p:spPr>
+          <a:xfrm>
+            <a:off x="1737360" y="4892040"/>
+            <a:ext cx="7132320" cy="1371600"/>
+          </a:xfrm>
+          <a:prstGeom prst="rect">
+            <a:avLst/>
+          </a:prstGeom>
+          <a:noFill/>
+        </p:spPr>
+        <p:txBody>
+          <a:bodyPr wrap="square">
+            <a:spAutoFit/>
+          </a:bodyPr>
+          <a:lstStyle/>
+          <a:p>
+            <a:pPr algn="l"/>
+            <a:r>
+              <a:rPr sz="900" b="0">
+                <a:solidFill>
+                  <a:srgbClr val="1E293B"/>
+                </a:solidFill>
+              </a:rPr>
+              <a:t>The Value at Cyber Risk exposure for AME stands at $22,000,000. This pattern is consistent with the Ransomware scenario, ranked #1 globally by financial impact (37.6% of all cyber losses) and #2 by event frequency (31.7% of all events). The signals reflect a mixed pattern: a sustained trend of financially motivated groups targeting energy sector operational technology has now produced specific inc</a:t>
+            </a:r>
+          </a:p>
+        </p:txBody>
+      </p:sp>
+    </p:spTree>
+  </p:cSld>
+  <p:clrMapOvr>
+    <a:masterClrMapping/>
+  </p:clrMapOvr>
+</p:sld>
+</file>
+
+<file path=ppt/slides/slide5.xml><?xml version="1.0" encoding="utf-8"?>
+<p:sld xmlns:a="http://schemas.openxmlformats.org/drawingml/2006/main" xmlns:p="http://schemas.openxmlformats.org/presentationml/2006/main" xmlns:r="http://schemas.openxmlformats.org/officeDocument/2006/relationships">
+  <p:cSld>
+    <p:spTree>
+      <p:nvGrpSpPr>
+        <p:cNvPr id="1" name=""/>
+        <p:cNvGrpSpPr/>
+        <p:nvPr/>
+      </p:nvGrpSpPr>
+      <p:grpSpPr/>
+      <p:sp>
+        <p:nvSpPr>
+          <p:cNvPr id="2" name="Rectangle 1"/>
+          <p:cNvSpPr/>
+          <p:nvPr/>
+        </p:nvSpPr>
+        <p:spPr>
+          <a:xfrm>
+            <a:off x="0" y="0"/>
+            <a:ext cx="9144000" cy="594360"/>
+          </a:xfrm>
+          <a:prstGeom prst="rect">
+            <a:avLst/>
+          </a:prstGeom>
+          <a:solidFill>
+            <a:srgbClr val="104277"/>
+          </a:solidFill>
+          <a:ln>
+            <a:noFill/>
+          </a:ln>
+        </p:spPr>
+        <p:style>
+          <a:lnRef idx="1">
+            <a:schemeClr val="accent1"/>
+          </a:lnRef>
+          <a:fillRef idx="3">
+            <a:schemeClr val="accent1"/>
+          </a:fillRef>
+          <a:effectRef idx="2">
+            <a:schemeClr val="accent1"/>
+          </a:effectRef>
+          <a:fontRef idx="minor">
+            <a:schemeClr val="lt1"/>
+          </a:fontRef>
+        </p:style>
+        <p:txBody>
+          <a:bodyPr rtlCol="0" anchor="ctr"/>
+          <a:lstStyle/>
+          <a:p>
+            <a:pPr algn="ctr"/>
+          </a:p>
+        </p:txBody>
+      </p:sp>
+      <p:sp>
+        <p:nvSpPr>
+          <p:cNvPr id="3" name="TextBox 2"/>
+          <p:cNvSpPr txBox="1"/>
+          <p:nvPr/>
+        </p:nvSpPr>
+        <p:spPr>
+          <a:xfrm>
+            <a:off x="274320" y="91440"/>
+            <a:ext cx="5486400" cy="411480"/>
+          </a:xfrm>
+          <a:prstGeom prst="rect">
+            <a:avLst/>
+          </a:prstGeom>
+          <a:noFill/>
+        </p:spPr>
+        <p:txBody>
+          <a:bodyPr wrap="square">
+            <a:spAutoFit/>
+          </a:bodyPr>
+          <a:lstStyle/>
+          <a:p>
+            <a:pPr algn="l"/>
+            <a:r>
+              <a:rPr sz="1600" b="1">
+                <a:solidFill>
+                  <a:srgbClr val="FFFFFF"/>
+                </a:solidFill>
+              </a:rPr>
+              <a:t>MED</a:t>
+            </a:r>
+          </a:p>
+        </p:txBody>
+      </p:sp>
+      <p:sp>
+        <p:nvSpPr>
+          <p:cNvPr id="4" name="TextBox 3"/>
+          <p:cNvSpPr txBox="1"/>
+          <p:nvPr/>
+        </p:nvSpPr>
+        <p:spPr>
+          <a:xfrm>
+            <a:off x="274320" y="347472"/>
+            <a:ext cx="5486400" cy="228600"/>
+          </a:xfrm>
+          <a:prstGeom prst="rect">
+            <a:avLst/>
+          </a:prstGeom>
+          <a:noFill/>
+        </p:spPr>
+        <p:txBody>
+          <a:bodyPr wrap="square">
+            <a:spAutoFit/>
+          </a:bodyPr>
+          <a:lstStyle/>
+          <a:p>
+            <a:pPr algn="l"/>
+            <a:r>
+              <a:rPr sz="900" b="0">
+                <a:solidFill>
+                  <a:srgbClr val="BFDBFF"/>
+                </a:solidFill>
+              </a:rPr>
+              <a:t>Insider misuse</a:t>
+            </a:r>
+          </a:p>
+        </p:txBody>
+      </p:sp>
+      <p:sp>
+        <p:nvSpPr>
+          <p:cNvPr id="5" name="Rectangle 4"/>
+          <p:cNvSpPr/>
+          <p:nvPr/>
+        </p:nvSpPr>
+        <p:spPr>
+          <a:xfrm>
+            <a:off x="7680960" y="109728"/>
+            <a:ext cx="1188720" cy="347472"/>
+          </a:xfrm>
+          <a:prstGeom prst="rect">
+            <a:avLst/>
+          </a:prstGeom>
+          <a:solidFill>
+            <a:srgbClr val="DC2626"/>
+          </a:solidFill>
+          <a:ln>
+            <a:noFill/>
+          </a:ln>
+        </p:spPr>
+        <p:style>
+          <a:lnRef idx="1">
+            <a:schemeClr val="accent1"/>
+          </a:lnRef>
+          <a:fillRef idx="3">
+            <a:schemeClr val="accent1"/>
+          </a:fillRef>
+          <a:effectRef idx="2">
+            <a:schemeClr val="accent1"/>
+          </a:effectRef>
+          <a:fontRef idx="minor">
+            <a:schemeClr val="lt1"/>
+          </a:fontRef>
+        </p:style>
+        <p:txBody>
+          <a:bodyPr rtlCol="0" anchor="ctr"/>
+          <a:lstStyle/>
+          <a:p>
+            <a:pPr algn="ctr"/>
+          </a:p>
+        </p:txBody>
+      </p:sp>
+      <p:sp>
+        <p:nvSpPr>
+          <p:cNvPr id="6" name="TextBox 5"/>
+          <p:cNvSpPr txBox="1"/>
+          <p:nvPr/>
+        </p:nvSpPr>
+        <p:spPr>
+          <a:xfrm>
+            <a:off x="7680960" y="146304"/>
+            <a:ext cx="1188720" cy="274320"/>
+          </a:xfrm>
+          <a:prstGeom prst="rect">
+            <a:avLst/>
+          </a:prstGeom>
+          <a:noFill/>
+        </p:spPr>
+        <p:txBody>
+          <a:bodyPr wrap="square">
+            <a:spAutoFit/>
+          </a:bodyPr>
+          <a:lstStyle/>
+          <a:p>
+            <a:pPr algn="ctr"/>
+            <a:r>
+              <a:rPr sz="800" b="1">
+                <a:solidFill>
+                  <a:srgbClr val="FFFFFF"/>
+                </a:solidFill>
+              </a:rPr>
+              <a:t>ESCALATED</a:t>
+            </a:r>
+          </a:p>
+        </p:txBody>
+      </p:sp>
+      <p:sp>
+        <p:nvSpPr>
+          <p:cNvPr id="7" name="TextBox 6"/>
+          <p:cNvSpPr txBox="1"/>
+          <p:nvPr/>
+        </p:nvSpPr>
+        <p:spPr>
+          <a:xfrm>
+            <a:off x="274320" y="777240"/>
+            <a:ext cx="1280160" cy="274320"/>
+          </a:xfrm>
+          <a:prstGeom prst="rect">
+            <a:avLst/>
+          </a:prstGeom>
+          <a:noFill/>
+        </p:spPr>
+        <p:txBody>
+          <a:bodyPr wrap="square">
+            <a:spAutoFit/>
+          </a:bodyPr>
+          <a:lstStyle/>
+          <a:p>
+            <a:pPr algn="l"/>
+            <a:r>
+              <a:rPr sz="700" b="0">
+                <a:solidFill>
+                  <a:srgbClr val="64748B"/>
+                </a:solidFill>
+              </a:rPr>
+              <a:t>VaCR Exposure</a:t>
+            </a:r>
+          </a:p>
+        </p:txBody>
+      </p:sp>
+      <p:sp>
+        <p:nvSpPr>
+          <p:cNvPr id="8" name="TextBox 7"/>
+          <p:cNvSpPr txBox="1"/>
+          <p:nvPr/>
+        </p:nvSpPr>
+        <p:spPr>
+          <a:xfrm>
+            <a:off x="274320" y="1069848"/>
+            <a:ext cx="1280160" cy="640080"/>
+          </a:xfrm>
+          <a:prstGeom prst="rect">
+            <a:avLst/>
+          </a:prstGeom>
+          <a:noFill/>
+        </p:spPr>
+        <p:txBody>
+          <a:bodyPr wrap="square">
+            <a:spAutoFit/>
+          </a:bodyPr>
+          <a:lstStyle/>
+          <a:p>
+            <a:pPr algn="l"/>
+            <a:r>
+              <a:rPr sz="1600" b="1">
+                <a:solidFill>
+                  <a:srgbClr val="104277"/>
+                </a:solidFill>
+              </a:rPr>
+              <a:t>$4.2M</a:t>
+            </a:r>
+          </a:p>
+        </p:txBody>
+      </p:sp>
+      <p:sp>
+        <p:nvSpPr>
+          <p:cNvPr id="9" name="TextBox 8"/>
+          <p:cNvSpPr txBox="1"/>
+          <p:nvPr/>
+        </p:nvSpPr>
+        <p:spPr>
+          <a:xfrm>
+            <a:off x="274320" y="2194560"/>
+            <a:ext cx="1280160" cy="274320"/>
+          </a:xfrm>
+          <a:prstGeom prst="rect">
+            <a:avLst/>
+          </a:prstGeom>
+          <a:noFill/>
+        </p:spPr>
+        <p:txBody>
+          <a:bodyPr wrap="square">
+            <a:spAutoFit/>
+          </a:bodyPr>
+          <a:lstStyle/>
+          <a:p>
+            <a:pPr algn="l"/>
+            <a:r>
+              <a:rPr sz="700" b="0">
+                <a:solidFill>
+                  <a:srgbClr val="64748B"/>
+                </a:solidFill>
+              </a:rPr>
+              <a:t>Admiralty</a:t>
+            </a:r>
+          </a:p>
+        </p:txBody>
+      </p:sp>
+      <p:sp>
+        <p:nvSpPr>
+          <p:cNvPr id="10" name="TextBox 9"/>
+          <p:cNvSpPr txBox="1"/>
+          <p:nvPr/>
+        </p:nvSpPr>
+        <p:spPr>
+          <a:xfrm>
+            <a:off x="274320" y="2487168"/>
+            <a:ext cx="1280160" cy="640080"/>
+          </a:xfrm>
+          <a:prstGeom prst="rect">
+            <a:avLst/>
+          </a:prstGeom>
+          <a:noFill/>
+        </p:spPr>
+        <p:txBody>
+          <a:bodyPr wrap="square">
+            <a:spAutoFit/>
+          </a:bodyPr>
+          <a:lstStyle/>
+          <a:p>
+            <a:pPr algn="l"/>
+            <a:r>
+              <a:rPr sz="1600" b="1">
+                <a:solidFill>
+                  <a:srgbClr val="104277"/>
+                </a:solidFill>
+              </a:rPr>
+              <a:t>B2</a:t>
+            </a:r>
+          </a:p>
+        </p:txBody>
+      </p:sp>
+      <p:sp>
+        <p:nvSpPr>
+          <p:cNvPr id="11" name="TextBox 10"/>
+          <p:cNvSpPr txBox="1"/>
+          <p:nvPr/>
+        </p:nvSpPr>
+        <p:spPr>
+          <a:xfrm>
+            <a:off x="274320" y="3611880"/>
+            <a:ext cx="1280160" cy="274320"/>
+          </a:xfrm>
+          <a:prstGeom prst="rect">
+            <a:avLst/>
+          </a:prstGeom>
+          <a:noFill/>
+        </p:spPr>
+        <p:txBody>
+          <a:bodyPr wrap="square">
+            <a:spAutoFit/>
+          </a:bodyPr>
+          <a:lstStyle/>
+          <a:p>
+            <a:pPr algn="l"/>
+            <a:r>
+              <a:rPr sz="700" b="0">
+                <a:solidFill>
+                  <a:srgbClr val="64748B"/>
+                </a:solidFill>
+              </a:rPr>
+              <a:t>Velocity</a:t>
+            </a:r>
+          </a:p>
+        </p:txBody>
+      </p:sp>
+      <p:sp>
+        <p:nvSpPr>
+          <p:cNvPr id="12" name="TextBox 11"/>
+          <p:cNvSpPr txBox="1"/>
+          <p:nvPr/>
+        </p:nvSpPr>
+        <p:spPr>
+          <a:xfrm>
+            <a:off x="274320" y="3904488"/>
+            <a:ext cx="1280160" cy="640080"/>
+          </a:xfrm>
+          <a:prstGeom prst="rect">
+            <a:avLst/>
+          </a:prstGeom>
+          <a:noFill/>
+        </p:spPr>
+        <p:txBody>
+          <a:bodyPr wrap="square">
+            <a:spAutoFit/>
+          </a:bodyPr>
+          <a:lstStyle/>
+          <a:p>
+            <a:pPr algn="l"/>
+            <a:r>
+              <a:rPr sz="1600" b="1">
+                <a:solidFill>
+                  <a:srgbClr val="64748B"/>
+                </a:solidFill>
+              </a:rPr>
+              <a:t>→ Stable</a:t>
+            </a:r>
+          </a:p>
+        </p:txBody>
+      </p:sp>
+      <p:sp>
+        <p:nvSpPr>
+          <p:cNvPr id="13" name="TextBox 12"/>
+          <p:cNvSpPr txBox="1"/>
+          <p:nvPr/>
+        </p:nvSpPr>
+        <p:spPr>
+          <a:xfrm>
+            <a:off x="274320" y="5029200"/>
+            <a:ext cx="1280160" cy="274320"/>
+          </a:xfrm>
+          <a:prstGeom prst="rect">
+            <a:avLst/>
+          </a:prstGeom>
+          <a:noFill/>
+        </p:spPr>
+        <p:txBody>
+          <a:bodyPr wrap="square">
+            <a:spAutoFit/>
+          </a:bodyPr>
+          <a:lstStyle/>
+          <a:p>
+            <a:pPr algn="l"/>
+            <a:r>
+              <a:rPr sz="700" b="0">
+                <a:solidFill>
+                  <a:srgbClr val="64748B"/>
+                </a:solidFill>
+              </a:rPr>
+              <a:t>Severity</a:t>
+            </a:r>
+          </a:p>
+        </p:txBody>
+      </p:sp>
+      <p:sp>
+        <p:nvSpPr>
+          <p:cNvPr id="14" name="TextBox 13"/>
+          <p:cNvSpPr txBox="1"/>
+          <p:nvPr/>
+        </p:nvSpPr>
+        <p:spPr>
+          <a:xfrm>
+            <a:off x="274320" y="5321808"/>
+            <a:ext cx="1280160" cy="640080"/>
+          </a:xfrm>
+          <a:prstGeom prst="rect">
+            <a:avLst/>
+          </a:prstGeom>
+          <a:noFill/>
+        </p:spPr>
+        <p:txBody>
+          <a:bodyPr wrap="square">
+            <a:spAutoFit/>
+          </a:bodyPr>
+          <a:lstStyle/>
+          <a:p>
+            <a:pPr algn="l"/>
+            <a:r>
+              <a:rPr sz="1600" b="1">
+                <a:solidFill>
+                  <a:srgbClr val="D97706"/>
+                </a:solidFill>
+              </a:rPr>
+              <a:t>MEDIUM</a:t>
+            </a:r>
+          </a:p>
+        </p:txBody>
+      </p:sp>
+      <p:sp>
+        <p:nvSpPr>
+          <p:cNvPr id="15" name="TextBox 14"/>
+          <p:cNvSpPr txBox="1"/>
+          <p:nvPr/>
+        </p:nvSpPr>
+        <p:spPr>
+          <a:xfrm>
+            <a:off x="1737360" y="777240"/>
+            <a:ext cx="7132320" cy="256032"/>
+          </a:xfrm>
+          <a:prstGeom prst="rect">
+            <a:avLst/>
+          </a:prstGeom>
+          <a:noFill/>
+        </p:spPr>
+        <p:txBody>
+          <a:bodyPr wrap="square">
+            <a:spAutoFit/>
+          </a:bodyPr>
+          <a:lstStyle/>
+          <a:p>
+            <a:pPr algn="l"/>
+            <a:r>
+              <a:rPr sz="800" b="1">
+                <a:solidFill>
+                  <a:srgbClr val="104277"/>
+                </a:solidFill>
+              </a:rPr>
+              <a:t>WHY — GEOPOLITICAL DRIVER</a:t>
+            </a:r>
+          </a:p>
+        </p:txBody>
+      </p:sp>
+      <p:sp>
+        <p:nvSpPr>
+          <p:cNvPr id="16" name="TextBox 15"/>
+          <p:cNvSpPr txBox="1"/>
+          <p:nvPr/>
+        </p:nvSpPr>
+        <p:spPr>
+          <a:xfrm>
+            <a:off x="1737360" y="1051560"/>
+            <a:ext cx="7132320" cy="1371600"/>
+          </a:xfrm>
+          <a:prstGeom prst="rect">
+            <a:avLst/>
+          </a:prstGeom>
+          <a:noFill/>
+        </p:spPr>
+        <p:txBody>
+          <a:bodyPr wrap="square">
+            <a:spAutoFit/>
+          </a:bodyPr>
+          <a:lstStyle/>
+          <a:p>
+            <a:pPr algn="l"/>
+            <a:r>
+              <a:rPr sz="900" b="0">
+                <a:solidFill>
+                  <a:srgbClr val="1E293B"/>
+                </a:solidFill>
+              </a:rPr>
+              <a:t>Prolonged economic instability across southern Europe is undermining the reliability of AeroGrid's service and maintenance workforce in the Mediterranean region. Austerity measures and persistently high unemployment in key operating markets are creating financial stress conditions that elevate the risk of personnel seeking unauthorized income from proprietary company data. Simultaneously, the Euro</a:t>
+            </a:r>
+          </a:p>
+        </p:txBody>
+      </p:sp>
+      <p:sp>
+        <p:nvSpPr>
+          <p:cNvPr id="17" name="TextBox 16"/>
+          <p:cNvSpPr txBox="1"/>
+          <p:nvPr/>
+        </p:nvSpPr>
+        <p:spPr>
+          <a:xfrm>
+            <a:off x="1737360" y="2697480"/>
+            <a:ext cx="7132320" cy="256032"/>
+          </a:xfrm>
+          <a:prstGeom prst="rect">
+            <a:avLst/>
+          </a:prstGeom>
+          <a:noFill/>
+        </p:spPr>
+        <p:txBody>
+          <a:bodyPr wrap="square">
+            <a:spAutoFit/>
+          </a:bodyPr>
+          <a:lstStyle/>
+          <a:p>
+            <a:pPr algn="l"/>
+            <a:r>
+              <a:rPr sz="800" b="1">
+                <a:solidFill>
+                  <a:srgbClr val="104277"/>
+                </a:solidFill>
+              </a:rPr>
+              <a:t>HOW — CYBER VECTOR</a:t>
+            </a:r>
+          </a:p>
+        </p:txBody>
+      </p:sp>
+      <p:sp>
+        <p:nvSpPr>
+          <p:cNvPr id="18" name="TextBox 17"/>
+          <p:cNvSpPr txBox="1"/>
+          <p:nvPr/>
+        </p:nvSpPr>
+        <p:spPr>
+          <a:xfrm>
+            <a:off x="1737360" y="2971800"/>
+            <a:ext cx="7132320" cy="1371600"/>
+          </a:xfrm>
+          <a:prstGeom prst="rect">
+            <a:avLst/>
+          </a:prstGeom>
+          <a:noFill/>
+        </p:spPr>
+        <p:txBody>
+          <a:bodyPr wrap="square">
+            <a:spAutoFit/>
+          </a:bodyPr>
+          <a:lstStyle/>
+          <a:p>
+            <a:pPr algn="l"/>
+            <a:r>
+              <a:rPr sz="900" b="0">
+                <a:solidFill>
+                  <a:srgbClr val="1E293B"/>
+                </a:solidFill>
+              </a:rPr>
+              <a:t>This geopolitical pressure is materializing through anomalous access patterns on two of AeroGrid's crown jewels: the real-time predictive maintenance algorithms and offshore servicing contract documentation. Signals indicate that a former maintenance contractor retained active system credentials for six months after contract termination, with access events inconsistent with any operational role — </a:t>
+            </a:r>
+          </a:p>
+        </p:txBody>
+      </p:sp>
+      <p:sp>
+        <p:nvSpPr>
+          <p:cNvPr id="19" name="TextBox 18"/>
+          <p:cNvSpPr txBox="1"/>
+          <p:nvPr/>
+        </p:nvSpPr>
+        <p:spPr>
+          <a:xfrm>
+            <a:off x="1737360" y="4617720"/>
+            <a:ext cx="7132320" cy="256032"/>
+          </a:xfrm>
+          <a:prstGeom prst="rect">
+            <a:avLst/>
+          </a:prstGeom>
+          <a:noFill/>
+        </p:spPr>
+        <p:txBody>
+          <a:bodyPr wrap="square">
+            <a:spAutoFit/>
+          </a:bodyPr>
+          <a:lstStyle/>
+          <a:p>
+            <a:pPr algn="l"/>
+            <a:r>
+              <a:rPr sz="800" b="1">
+                <a:solidFill>
+                  <a:srgbClr val="104277"/>
+                </a:solidFill>
+              </a:rPr>
+              <a:t>SO WHAT — BUSINESS IMPACT</a:t>
+            </a:r>
+          </a:p>
+        </p:txBody>
+      </p:sp>
+      <p:sp>
+        <p:nvSpPr>
+          <p:cNvPr id="20" name="TextBox 19"/>
+          <p:cNvSpPr txBox="1"/>
+          <p:nvPr/>
+        </p:nvSpPr>
+        <p:spPr>
+          <a:xfrm>
+            <a:off x="1737360" y="4892040"/>
+            <a:ext cx="7132320" cy="1371600"/>
+          </a:xfrm>
+          <a:prstGeom prst="rect">
+            <a:avLst/>
+          </a:prstGeom>
+          <a:noFill/>
+        </p:spPr>
+        <p:txBody>
+          <a:bodyPr wrap="square">
+            <a:spAutoFit/>
+          </a:bodyPr>
+          <a:lstStyle/>
+          <a:p>
+            <a:pPr algn="l"/>
+            <a:r>
+              <a:rPr sz="900" b="0">
+                <a:solidFill>
+                  <a:srgbClr val="1E293B"/>
+                </a:solidFill>
+              </a:rPr>
+              <a:t>The value at cyber risk for the Mediterranean region stands at $4,200,000. This pattern is consistent with the Insider misuse scenario, ranked #4 globally by financial impact (4.4% of all industry losses) and #5 by event frequency. While Insider misuse incidents occur less frequently than external intrusions, the signals here reflect both a sustained trend of deteriorating workforce financial cond</a:t>
+            </a:r>
+          </a:p>
+        </p:txBody>
+      </p:sp>
+    </p:spTree>
+  </p:cSld>
+  <p:clrMapOvr>
+    <a:masterClrMapping/>
+  </p:clrMapOvr>
+</p:sld>
+</file>
+
+<file path=ppt/slides/slide6.xml><?xml version="1.0" encoding="utf-8"?>
+<p:sld xmlns:a="http://schemas.openxmlformats.org/drawingml/2006/main" xmlns:p="http://schemas.openxmlformats.org/presentationml/2006/main" xmlns:r="http://schemas.openxmlformats.org/officeDocument/2006/relationships">
+  <p:cSld>
+    <p:spTree>
+      <p:nvGrpSpPr>
+        <p:cNvPr id="1" name=""/>
+        <p:cNvGrpSpPr/>
+        <p:nvPr/>
+      </p:nvGrpSpPr>
+      <p:grpSpPr/>
+      <p:sp>
+        <p:nvSpPr>
+          <p:cNvPr id="2" name="Rectangle 1"/>
+          <p:cNvSpPr/>
+          <p:nvPr/>
+        </p:nvSpPr>
+        <p:spPr>
+          <a:xfrm>
+            <a:off x="0" y="0"/>
+            <a:ext cx="9144000" cy="594360"/>
+          </a:xfrm>
+          <a:prstGeom prst="rect">
+            <a:avLst/>
+          </a:prstGeom>
+          <a:solidFill>
+            <a:srgbClr val="104277"/>
+          </a:solidFill>
+          <a:ln>
+            <a:noFill/>
+          </a:ln>
+        </p:spPr>
+        <p:style>
+          <a:lnRef idx="1">
+            <a:schemeClr val="accent1"/>
+          </a:lnRef>
+          <a:fillRef idx="3">
+            <a:schemeClr val="accent1"/>
+          </a:fillRef>
+          <a:effectRef idx="2">
+            <a:schemeClr val="accent1"/>
+          </a:effectRef>
+          <a:fontRef idx="minor">
+            <a:schemeClr val="lt1"/>
+          </a:fontRef>
+        </p:style>
+        <p:txBody>
+          <a:bodyPr rtlCol="0" anchor="ctr"/>
+          <a:lstStyle/>
+          <a:p>
+            <a:pPr algn="ctr"/>
+          </a:p>
+        </p:txBody>
+      </p:sp>
+      <p:sp>
+        <p:nvSpPr>
+          <p:cNvPr id="3" name="TextBox 2"/>
+          <p:cNvSpPr txBox="1"/>
+          <p:nvPr/>
+        </p:nvSpPr>
+        <p:spPr>
+          <a:xfrm>
+            <a:off x="274320" y="91440"/>
+            <a:ext cx="6400800" cy="411480"/>
+          </a:xfrm>
+          <a:prstGeom prst="rect">
+            <a:avLst/>
+          </a:prstGeom>
+          <a:noFill/>
+        </p:spPr>
+        <p:txBody>
+          <a:bodyPr wrap="square">
+            <a:spAutoFit/>
+          </a:bodyPr>
+          <a:lstStyle/>
+          <a:p>
+            <a:pPr algn="l"/>
+            <a:r>
+              <a:rPr sz="1600" b="1">
+                <a:solidFill>
+                  <a:srgbClr val="FFFFFF"/>
+                </a:solidFill>
+              </a:rPr>
+              <a:t>Appendix</a:t>
+            </a:r>
+          </a:p>
+        </p:txBody>
+      </p:sp>
+      <p:sp>
+        <p:nvSpPr>
+          <p:cNvPr id="4" name="TextBox 3"/>
+          <p:cNvSpPr txBox="1"/>
+          <p:nvPr/>
+        </p:nvSpPr>
+        <p:spPr>
+          <a:xfrm>
+            <a:off x="365760" y="777240"/>
+            <a:ext cx="8229600" cy="274320"/>
+          </a:xfrm>
+          <a:prstGeom prst="rect">
+            <a:avLst/>
+          </a:prstGeom>
+          <a:noFill/>
+        </p:spPr>
+        <p:txBody>
+          <a:bodyPr wrap="square">
+            <a:spAutoFit/>
+          </a:bodyPr>
+          <a:lstStyle/>
+          <a:p>
+            <a:pPr algn="l"/>
+            <a:r>
+              <a:rPr sz="900" b="1">
+                <a:solidFill>
+                  <a:srgbClr val="16A34A"/>
+                </a:solidFill>
+              </a:rPr>
+              <a:t>CLEAR REGIONS</a:t>
+            </a:r>
+          </a:p>
+        </p:txBody>
+      </p:sp>
+      <p:sp>
+        <p:nvSpPr>
+          <p:cNvPr id="5" name="TextBox 4"/>
+          <p:cNvSpPr txBox="1"/>
+          <p:nvPr/>
+        </p:nvSpPr>
+        <p:spPr>
+          <a:xfrm>
+            <a:off x="548640" y="1097280"/>
+            <a:ext cx="8229600" cy="320040"/>
+          </a:xfrm>
+          <a:prstGeom prst="rect">
+            <a:avLst/>
+          </a:prstGeom>
+          <a:noFill/>
+        </p:spPr>
+        <p:txBody>
+          <a:bodyPr wrap="square">
+            <a:spAutoFit/>
+          </a:bodyPr>
+          <a:lstStyle/>
+          <a:p>
+            <a:pPr algn="l"/>
+            <a:r>
+              <a:rPr sz="900" b="0">
+                <a:solidFill>
+                  <a:srgbClr val="1E293B"/>
+                </a:solidFill>
+              </a:rPr>
+              <a:t>LATAM  —  No active threat detected this cycle.</a:t>
+            </a:r>
+          </a:p>
+        </p:txBody>
+      </p:sp>
+      <p:sp>
+        <p:nvSpPr>
+          <p:cNvPr id="6" name="TextBox 5"/>
+          <p:cNvSpPr txBox="1"/>
+          <p:nvPr/>
+        </p:nvSpPr>
+        <p:spPr>
+          <a:xfrm>
+            <a:off x="548640" y="1444752"/>
+            <a:ext cx="8229600" cy="320040"/>
+          </a:xfrm>
+          <a:prstGeom prst="rect">
+            <a:avLst/>
+          </a:prstGeom>
+          <a:noFill/>
+        </p:spPr>
+        <p:txBody>
+          <a:bodyPr wrap="square">
+            <a:spAutoFit/>
+          </a:bodyPr>
+          <a:lstStyle/>
+          <a:p>
+            <a:pPr algn="l"/>
+            <a:r>
+              <a:rPr sz="900" b="0">
+                <a:solidFill>
+                  <a:srgbClr val="1E293B"/>
+                </a:solidFill>
+              </a:rPr>
+              <a:t>NCE  —  No active threat detected this cycle.</a:t>
+            </a:r>
+          </a:p>
+        </p:txBody>
+      </p:sp>
+      <p:sp>
+        <p:nvSpPr>
+          <p:cNvPr id="7" name="TextBox 6"/>
+          <p:cNvSpPr txBox="1"/>
+          <p:nvPr/>
+        </p:nvSpPr>
+        <p:spPr>
+          <a:xfrm>
+            <a:off x="365760" y="1975104"/>
+            <a:ext cx="8229600" cy="274320"/>
+          </a:xfrm>
+          <a:prstGeom prst="rect">
+            <a:avLst/>
+          </a:prstGeom>
+          <a:noFill/>
+        </p:spPr>
+        <p:txBody>
+          <a:bodyPr wrap="square">
+            <a:spAutoFit/>
+          </a:bodyPr>
+          <a:lstStyle/>
+          <a:p>
+            <a:pPr algn="l"/>
+            <a:r>
+              <a:rPr sz="900" b="1">
+                <a:solidFill>
+                  <a:srgbClr val="64748B"/>
+                </a:solidFill>
+              </a:rPr>
+              <a:t>RUN METADATA</a:t>
+            </a:r>
+          </a:p>
+        </p:txBody>
+      </p:sp>
+      <p:sp>
+        <p:nvSpPr>
+          <p:cNvPr id="8" name="TextBox 7"/>
+          <p:cNvSpPr txBox="1"/>
+          <p:nvPr/>
+        </p:nvSpPr>
+        <p:spPr>
+          <a:xfrm>
+            <a:off x="548640" y="2295144"/>
+            <a:ext cx="8229600" cy="274320"/>
+          </a:xfrm>
+          <a:prstGeom prst="rect">
+            <a:avLst/>
+          </a:prstGeom>
+          <a:noFill/>
+        </p:spPr>
+        <p:txBody>
+          <a:bodyPr wrap="square">
+            <a:spAutoFit/>
+          </a:bodyPr>
+          <a:lstStyle/>
+          <a:p>
+            <a:pPr algn="l"/>
+            <a:r>
+              <a:rPr sz="900" b="0">
+                <a:solidFill>
+                  <a:srgbClr val="1E293B"/>
+                </a:solidFill>
+              </a:rPr>
+              <a:t>Pipeline ID:  crq-2026-03-12T190254Z</a:t>
+            </a:r>
+          </a:p>
+        </p:txBody>
+      </p:sp>
+      <p:sp>
+        <p:nvSpPr>
+          <p:cNvPr id="9" name="TextBox 8"/>
+          <p:cNvSpPr txBox="1"/>
+          <p:nvPr/>
+        </p:nvSpPr>
+        <p:spPr>
+          <a:xfrm>
+            <a:off x="548640" y="2569464"/>
+            <a:ext cx="8229600" cy="274320"/>
+          </a:xfrm>
+          <a:prstGeom prst="rect">
+            <a:avLst/>
+          </a:prstGeom>
+          <a:noFill/>
+        </p:spPr>
+        <p:txBody>
+          <a:bodyPr wrap="square">
+            <a:spAutoFit/>
+          </a:bodyPr>
+          <a:lstStyle/>
+          <a:p>
+            <a:pPr algn="l"/>
+            <a:r>
+              <a:rPr sz="900" b="0">
+                <a:solidFill>
+                  <a:srgbClr val="1E293B"/>
+                </a:solidFill>
+              </a:rPr>
+              <a:t>Timestamp:  2026-03-12T19:02:54Z</a:t>
+            </a:r>
+          </a:p>
+        </p:txBody>
+      </p:sp>
+      <p:sp>
+        <p:nvSpPr>
+          <p:cNvPr id="10" name="TextBox 9"/>
+          <p:cNvSpPr txBox="1"/>
+          <p:nvPr/>
+        </p:nvSpPr>
+        <p:spPr>
+          <a:xfrm>
+            <a:off x="548640" y="2843784"/>
+            <a:ext cx="8229600" cy="274320"/>
+          </a:xfrm>
+          <a:prstGeom prst="rect">
+            <a:avLst/>
+          </a:prstGeom>
+          <a:noFill/>
+        </p:spPr>
+        <p:txBody>
+          <a:bodyPr wrap="square">
+            <a:spAutoFit/>
+          </a:bodyPr>
+          <a:lstStyle/>
+          <a:p>
+            <a:pPr algn="l"/>
+            <a:r>
+              <a:rPr sz="900" b="0">
+                <a:solidFill>
+                  <a:srgbClr val="1E293B"/>
+                </a:solidFill>
+              </a:rPr>
+              <a:t>Escalated:  3</a:t>
+            </a:r>
+          </a:p>
+        </p:txBody>
+      </p:sp>
+      <p:sp>
+        <p:nvSpPr>
+          <p:cNvPr id="11" name="TextBox 10"/>
+          <p:cNvSpPr txBox="1"/>
+          <p:nvPr/>
+        </p:nvSpPr>
+        <p:spPr>
+          <a:xfrm>
+            <a:off x="548640" y="3118104"/>
+            <a:ext cx="8229600" cy="274320"/>
+          </a:xfrm>
+          <a:prstGeom prst="rect">
+            <a:avLst/>
+          </a:prstGeom>
+          <a:noFill/>
+        </p:spPr>
+        <p:txBody>
+          <a:bodyPr wrap="square">
+            <a:spAutoFit/>
+          </a:bodyPr>
+          <a:lstStyle/>
+          <a:p>
+            <a:pPr algn="l"/>
+            <a:r>
+              <a:rPr sz="900" b="0">
+                <a:solidFill>
+                  <a:srgbClr val="1E293B"/>
+                </a:solidFill>
+              </a:rPr>
+              <a:t>Monitor:  0</a:t>
+            </a:r>
+          </a:p>
+        </p:txBody>
+      </p:sp>
+      <p:sp>
+        <p:nvSpPr>
+          <p:cNvPr id="12" name="TextBox 11"/>
+          <p:cNvSpPr txBox="1"/>
+          <p:nvPr/>
+        </p:nvSpPr>
+        <p:spPr>
+          <a:xfrm>
+            <a:off x="548640" y="3392424"/>
+            <a:ext cx="8229600" cy="274320"/>
+          </a:xfrm>
+          <a:prstGeom prst="rect">
+            <a:avLst/>
+          </a:prstGeom>
+          <a:noFill/>
+        </p:spPr>
+        <p:txBody>
+          <a:bodyPr wrap="square">
+            <a:spAutoFit/>
+          </a:bodyPr>
+          <a:lstStyle/>
+          <a:p>
+            <a:pPr algn="l"/>
+            <a:r>
+              <a:rPr sz="900" b="0">
+                <a:solidFill>
+                  <a:srgbClr val="1E293B"/>
+                </a:solidFill>
+              </a:rPr>
+              <a:t>Clear:  2</a:t>
             </a:r>
           </a:p>
         </p:txBody>

</xml_diff>

<commit_message>
feat(O-5): Phase O complete — CISO Brief Clean Executive PDF + PPTX
Both exporters verified: PDF 80KB, PPTX 39KB, 6 slides.
DRIVER/EXPOSURE/IMPACT/WATCH grid populated with real agent content.
No VaCR dollar figures in any rendered output.

Co-Authored-By: Claude Sonnet 4.6 <noreply@anthropic.com>
</commit_message>
<xml_diff>
--- a/output/board_report.pptx
+++ b/output/board_report.pptx
@@ -3213,69 +3213,368 @@
         </p:nvSpPr>
         <p:spPr>
           <a:xfrm>
+            <a:off x="548640" y="2743200"/>
+            <a:ext cx="8046720" cy="320040"/>
+          </a:xfrm>
+          <a:prstGeom prst="rect">
+            <a:avLst/>
+          </a:prstGeom>
+          <a:noFill/>
+        </p:spPr>
+        <p:txBody>
+          <a:bodyPr wrap="square">
+            <a:spAutoFit/>
+          </a:bodyPr>
+          <a:lstStyle/>
+          <a:p>
+            <a:pPr algn="l"/>
+            <a:r>
+              <a:rPr sz="1400" b="0">
+                <a:solidFill>
+                  <a:srgbClr val="BFDBFF"/>
+                </a:solidFill>
+              </a:rPr>
+              <a:t>CISO Edition</a:t>
+            </a:r>
+          </a:p>
+        </p:txBody>
+      </p:sp>
+      <p:sp>
+        <p:nvSpPr>
+          <p:cNvPr id="6" name="Rectangle 5"/>
+          <p:cNvSpPr/>
+          <p:nvPr/>
+        </p:nvSpPr>
+        <p:spPr>
+          <a:xfrm>
             <a:off x="548640" y="3383280"/>
-            <a:ext cx="4572000" cy="320040"/>
-          </a:xfrm>
-          <a:prstGeom prst="rect">
-            <a:avLst/>
-          </a:prstGeom>
-          <a:noFill/>
-        </p:spPr>
-        <p:txBody>
-          <a:bodyPr wrap="square">
-            <a:spAutoFit/>
-          </a:bodyPr>
-          <a:lstStyle/>
-          <a:p>
-            <a:pPr algn="l"/>
-            <a:r>
-              <a:rPr sz="900" b="0">
-                <a:solidFill>
-                  <a:srgbClr val="64748B"/>
-                </a:solidFill>
-              </a:rPr>
-              <a:t>TOTAL VALUE AT CYBER RISK</a:t>
-            </a:r>
-          </a:p>
-        </p:txBody>
-      </p:sp>
-      <p:sp>
-        <p:nvSpPr>
-          <p:cNvPr id="6" name="TextBox 5"/>
-          <p:cNvSpPr txBox="1"/>
-          <p:nvPr/>
-        </p:nvSpPr>
-        <p:spPr>
-          <a:xfrm>
-            <a:off x="548640" y="3657600"/>
-            <a:ext cx="4572000" cy="822960"/>
-          </a:xfrm>
-          <a:prstGeom prst="rect">
-            <a:avLst/>
-          </a:prstGeom>
-          <a:noFill/>
-        </p:spPr>
-        <p:txBody>
-          <a:bodyPr wrap="square">
-            <a:spAutoFit/>
-          </a:bodyPr>
-          <a:lstStyle/>
-          <a:p>
-            <a:pPr algn="l"/>
-            <a:r>
-              <a:rPr sz="3600" b="1">
-                <a:solidFill>
-                  <a:srgbClr val="104277"/>
-                </a:solidFill>
-              </a:rPr>
-              <a:t>$44.7M</a:t>
-            </a:r>
+            <a:ext cx="1097280" cy="685800"/>
+          </a:xfrm>
+          <a:prstGeom prst="rect">
+            <a:avLst/>
+          </a:prstGeom>
+          <a:solidFill>
+            <a:srgbClr val="DC2626"/>
+          </a:solidFill>
+          <a:ln>
+            <a:noFill/>
+          </a:ln>
+        </p:spPr>
+        <p:style>
+          <a:lnRef idx="1">
+            <a:schemeClr val="accent1"/>
+          </a:lnRef>
+          <a:fillRef idx="3">
+            <a:schemeClr val="accent1"/>
+          </a:fillRef>
+          <a:effectRef idx="2">
+            <a:schemeClr val="accent1"/>
+          </a:effectRef>
+          <a:fontRef idx="minor">
+            <a:schemeClr val="lt1"/>
+          </a:fontRef>
+        </p:style>
+        <p:txBody>
+          <a:bodyPr rtlCol="0" anchor="ctr"/>
+          <a:lstStyle/>
+          <a:p>
+            <a:pPr algn="ctr"/>
           </a:p>
         </p:txBody>
       </p:sp>
       <p:sp>
         <p:nvSpPr>
           <p:cNvPr id="7" name="TextBox 6"/>
+          <p:cNvSpPr txBox="1"/>
+          <p:nvPr/>
+        </p:nvSpPr>
+        <p:spPr>
+          <a:xfrm>
+            <a:off x="548640" y="3410712"/>
+            <a:ext cx="1097280" cy="365760"/>
+          </a:xfrm>
+          <a:prstGeom prst="rect">
+            <a:avLst/>
+          </a:prstGeom>
+          <a:noFill/>
+        </p:spPr>
+        <p:txBody>
+          <a:bodyPr wrap="square">
+            <a:spAutoFit/>
+          </a:bodyPr>
+          <a:lstStyle/>
+          <a:p>
+            <a:pPr algn="ctr"/>
+            <a:r>
+              <a:rPr sz="2000" b="1">
+                <a:solidFill>
+                  <a:srgbClr val="FFFFFF"/>
+                </a:solidFill>
+              </a:rPr>
+              <a:t>3</a:t>
+            </a:r>
+          </a:p>
+        </p:txBody>
+      </p:sp>
+      <p:sp>
+        <p:nvSpPr>
+          <p:cNvPr id="8" name="TextBox 7"/>
+          <p:cNvSpPr txBox="1"/>
+          <p:nvPr/>
+        </p:nvSpPr>
+        <p:spPr>
+          <a:xfrm>
+            <a:off x="548640" y="3749039"/>
+            <a:ext cx="1097280" cy="274320"/>
+          </a:xfrm>
+          <a:prstGeom prst="rect">
+            <a:avLst/>
+          </a:prstGeom>
+          <a:noFill/>
+        </p:spPr>
+        <p:txBody>
+          <a:bodyPr wrap="square">
+            <a:spAutoFit/>
+          </a:bodyPr>
+          <a:lstStyle/>
+          <a:p>
+            <a:pPr algn="ctr"/>
+            <a:r>
+              <a:rPr sz="700" b="0">
+                <a:solidFill>
+                  <a:srgbClr val="FFFFFF"/>
+                </a:solidFill>
+              </a:rPr>
+              <a:t>ESCALATED</a:t>
+            </a:r>
+          </a:p>
+        </p:txBody>
+      </p:sp>
+      <p:sp>
+        <p:nvSpPr>
+          <p:cNvPr id="9" name="Rectangle 8"/>
+          <p:cNvSpPr/>
+          <p:nvPr/>
+        </p:nvSpPr>
+        <p:spPr>
+          <a:xfrm>
+            <a:off x="1920240" y="3383280"/>
+            <a:ext cx="1097280" cy="685800"/>
+          </a:xfrm>
+          <a:prstGeom prst="rect">
+            <a:avLst/>
+          </a:prstGeom>
+          <a:solidFill>
+            <a:srgbClr val="D97706"/>
+          </a:solidFill>
+          <a:ln>
+            <a:noFill/>
+          </a:ln>
+        </p:spPr>
+        <p:style>
+          <a:lnRef idx="1">
+            <a:schemeClr val="accent1"/>
+          </a:lnRef>
+          <a:fillRef idx="3">
+            <a:schemeClr val="accent1"/>
+          </a:fillRef>
+          <a:effectRef idx="2">
+            <a:schemeClr val="accent1"/>
+          </a:effectRef>
+          <a:fontRef idx="minor">
+            <a:schemeClr val="lt1"/>
+          </a:fontRef>
+        </p:style>
+        <p:txBody>
+          <a:bodyPr rtlCol="0" anchor="ctr"/>
+          <a:lstStyle/>
+          <a:p>
+            <a:pPr algn="ctr"/>
+          </a:p>
+        </p:txBody>
+      </p:sp>
+      <p:sp>
+        <p:nvSpPr>
+          <p:cNvPr id="10" name="TextBox 9"/>
+          <p:cNvSpPr txBox="1"/>
+          <p:nvPr/>
+        </p:nvSpPr>
+        <p:spPr>
+          <a:xfrm>
+            <a:off x="1920240" y="3410712"/>
+            <a:ext cx="1097280" cy="365760"/>
+          </a:xfrm>
+          <a:prstGeom prst="rect">
+            <a:avLst/>
+          </a:prstGeom>
+          <a:noFill/>
+        </p:spPr>
+        <p:txBody>
+          <a:bodyPr wrap="square">
+            <a:spAutoFit/>
+          </a:bodyPr>
+          <a:lstStyle/>
+          <a:p>
+            <a:pPr algn="ctr"/>
+            <a:r>
+              <a:rPr sz="2000" b="1">
+                <a:solidFill>
+                  <a:srgbClr val="FFFFFF"/>
+                </a:solidFill>
+              </a:rPr>
+              <a:t>0</a:t>
+            </a:r>
+          </a:p>
+        </p:txBody>
+      </p:sp>
+      <p:sp>
+        <p:nvSpPr>
+          <p:cNvPr id="11" name="TextBox 10"/>
+          <p:cNvSpPr txBox="1"/>
+          <p:nvPr/>
+        </p:nvSpPr>
+        <p:spPr>
+          <a:xfrm>
+            <a:off x="1920240" y="3749039"/>
+            <a:ext cx="1097280" cy="274320"/>
+          </a:xfrm>
+          <a:prstGeom prst="rect">
+            <a:avLst/>
+          </a:prstGeom>
+          <a:noFill/>
+        </p:spPr>
+        <p:txBody>
+          <a:bodyPr wrap="square">
+            <a:spAutoFit/>
+          </a:bodyPr>
+          <a:lstStyle/>
+          <a:p>
+            <a:pPr algn="ctr"/>
+            <a:r>
+              <a:rPr sz="700" b="0">
+                <a:solidFill>
+                  <a:srgbClr val="FFFFFF"/>
+                </a:solidFill>
+              </a:rPr>
+              <a:t>MONITOR</a:t>
+            </a:r>
+          </a:p>
+        </p:txBody>
+      </p:sp>
+      <p:sp>
+        <p:nvSpPr>
+          <p:cNvPr id="12" name="Rectangle 11"/>
+          <p:cNvSpPr/>
+          <p:nvPr/>
+        </p:nvSpPr>
+        <p:spPr>
+          <a:xfrm>
+            <a:off x="3291840" y="3383280"/>
+            <a:ext cx="1097280" cy="685800"/>
+          </a:xfrm>
+          <a:prstGeom prst="rect">
+            <a:avLst/>
+          </a:prstGeom>
+          <a:solidFill>
+            <a:srgbClr val="16A34A"/>
+          </a:solidFill>
+          <a:ln>
+            <a:noFill/>
+          </a:ln>
+        </p:spPr>
+        <p:style>
+          <a:lnRef idx="1">
+            <a:schemeClr val="accent1"/>
+          </a:lnRef>
+          <a:fillRef idx="3">
+            <a:schemeClr val="accent1"/>
+          </a:fillRef>
+          <a:effectRef idx="2">
+            <a:schemeClr val="accent1"/>
+          </a:effectRef>
+          <a:fontRef idx="minor">
+            <a:schemeClr val="lt1"/>
+          </a:fontRef>
+        </p:style>
+        <p:txBody>
+          <a:bodyPr rtlCol="0" anchor="ctr"/>
+          <a:lstStyle/>
+          <a:p>
+            <a:pPr algn="ctr"/>
+          </a:p>
+        </p:txBody>
+      </p:sp>
+      <p:sp>
+        <p:nvSpPr>
+          <p:cNvPr id="13" name="TextBox 12"/>
+          <p:cNvSpPr txBox="1"/>
+          <p:nvPr/>
+        </p:nvSpPr>
+        <p:spPr>
+          <a:xfrm>
+            <a:off x="3291840" y="3410712"/>
+            <a:ext cx="1097280" cy="365760"/>
+          </a:xfrm>
+          <a:prstGeom prst="rect">
+            <a:avLst/>
+          </a:prstGeom>
+          <a:noFill/>
+        </p:spPr>
+        <p:txBody>
+          <a:bodyPr wrap="square">
+            <a:spAutoFit/>
+          </a:bodyPr>
+          <a:lstStyle/>
+          <a:p>
+            <a:pPr algn="ctr"/>
+            <a:r>
+              <a:rPr sz="2000" b="1">
+                <a:solidFill>
+                  <a:srgbClr val="FFFFFF"/>
+                </a:solidFill>
+              </a:rPr>
+              <a:t>2</a:t>
+            </a:r>
+          </a:p>
+        </p:txBody>
+      </p:sp>
+      <p:sp>
+        <p:nvSpPr>
+          <p:cNvPr id="14" name="TextBox 13"/>
+          <p:cNvSpPr txBox="1"/>
+          <p:nvPr/>
+        </p:nvSpPr>
+        <p:spPr>
+          <a:xfrm>
+            <a:off x="3291840" y="3749039"/>
+            <a:ext cx="1097280" cy="274320"/>
+          </a:xfrm>
+          <a:prstGeom prst="rect">
+            <a:avLst/>
+          </a:prstGeom>
+          <a:noFill/>
+        </p:spPr>
+        <p:txBody>
+          <a:bodyPr wrap="square">
+            <a:spAutoFit/>
+          </a:bodyPr>
+          <a:lstStyle/>
+          <a:p>
+            <a:pPr algn="ctr"/>
+            <a:r>
+              <a:rPr sz="700" b="0">
+                <a:solidFill>
+                  <a:srgbClr val="FFFFFF"/>
+                </a:solidFill>
+              </a:rPr>
+              <a:t>CLEAR</a:t>
+            </a:r>
+          </a:p>
+        </p:txBody>
+      </p:sp>
+      <p:sp>
+        <p:nvSpPr>
+          <p:cNvPr id="15" name="TextBox 14"/>
           <p:cNvSpPr txBox="1"/>
           <p:nvPr/>
         </p:nvSpPr>
@@ -3302,14 +3601,14 @@
                   <a:srgbClr val="64748B"/>
                 </a:solidFill>
               </a:rPr>
-              <a:t>Pipeline ID: crq-2026-03-12T190254Z   |   2026-03-12T19:02:54Z</a:t>
-            </a:r>
-          </a:p>
-        </p:txBody>
-      </p:sp>
-      <p:sp>
-        <p:nvSpPr>
-          <p:cNvPr id="8" name="TextBox 7"/>
+              <a:t>Pipeline ID: crq-2026-03-26T164449Z   |   2026-03-26T16:44:49Z</a:t>
+            </a:r>
+          </a:p>
+        </p:txBody>
+      </p:sp>
+      <p:sp>
+        <p:nvSpPr>
+          <p:cNvPr id="16" name="TextBox 15"/>
           <p:cNvSpPr txBox="1"/>
           <p:nvPr/>
         </p:nvSpPr>
@@ -3771,118 +4070,7 @@
       </p:sp>
       <p:sp>
         <p:nvSpPr>
-          <p:cNvPr id="13" name="Rectangle 12"/>
-          <p:cNvSpPr/>
-          <p:nvPr/>
-        </p:nvSpPr>
-        <p:spPr>
-          <a:xfrm>
-            <a:off x="7315200" y="777240"/>
-            <a:ext cx="1554480" cy="685800"/>
-          </a:xfrm>
-          <a:prstGeom prst="rect">
-            <a:avLst/>
-          </a:prstGeom>
-          <a:solidFill>
-            <a:srgbClr val="104277"/>
-          </a:solidFill>
-          <a:ln>
-            <a:noFill/>
-          </a:ln>
-        </p:spPr>
-        <p:style>
-          <a:lnRef idx="1">
-            <a:schemeClr val="accent1"/>
-          </a:lnRef>
-          <a:fillRef idx="3">
-            <a:schemeClr val="accent1"/>
-          </a:fillRef>
-          <a:effectRef idx="2">
-            <a:schemeClr val="accent1"/>
-          </a:effectRef>
-          <a:fontRef idx="minor">
-            <a:schemeClr val="lt1"/>
-          </a:fontRef>
-        </p:style>
-        <p:txBody>
-          <a:bodyPr rtlCol="0" anchor="ctr"/>
-          <a:lstStyle/>
-          <a:p>
-            <a:pPr algn="ctr"/>
-          </a:p>
-        </p:txBody>
-      </p:sp>
-      <p:sp>
-        <p:nvSpPr>
-          <p:cNvPr id="14" name="TextBox 13"/>
-          <p:cNvSpPr txBox="1"/>
-          <p:nvPr/>
-        </p:nvSpPr>
-        <p:spPr>
-          <a:xfrm>
-            <a:off x="7315200" y="804672"/>
-            <a:ext cx="1554480" cy="365760"/>
-          </a:xfrm>
-          <a:prstGeom prst="rect">
-            <a:avLst/>
-          </a:prstGeom>
-          <a:noFill/>
-        </p:spPr>
-        <p:txBody>
-          <a:bodyPr wrap="square">
-            <a:spAutoFit/>
-          </a:bodyPr>
-          <a:lstStyle/>
-          <a:p>
-            <a:pPr algn="ctr"/>
-            <a:r>
-              <a:rPr sz="1600" b="1">
-                <a:solidFill>
-                  <a:srgbClr val="FFFFFF"/>
-                </a:solidFill>
-              </a:rPr>
-              <a:t>$44.7M</a:t>
-            </a:r>
-          </a:p>
-        </p:txBody>
-      </p:sp>
-      <p:sp>
-        <p:nvSpPr>
-          <p:cNvPr id="15" name="TextBox 14"/>
-          <p:cNvSpPr txBox="1"/>
-          <p:nvPr/>
-        </p:nvSpPr>
-        <p:spPr>
-          <a:xfrm>
-            <a:off x="7315200" y="1143000"/>
-            <a:ext cx="1554480" cy="274320"/>
-          </a:xfrm>
-          <a:prstGeom prst="rect">
-            <a:avLst/>
-          </a:prstGeom>
-          <a:noFill/>
-        </p:spPr>
-        <p:txBody>
-          <a:bodyPr wrap="square">
-            <a:spAutoFit/>
-          </a:bodyPr>
-          <a:lstStyle/>
-          <a:p>
-            <a:pPr algn="ctr"/>
-            <a:r>
-              <a:rPr sz="700" b="0">
-                <a:solidFill>
-                  <a:srgbClr val="FFFFFF"/>
-                </a:solidFill>
-              </a:rPr>
-              <a:t>TOTAL VaCR</a:t>
-            </a:r>
-          </a:p>
-        </p:txBody>
-      </p:sp>
-      <p:sp>
-        <p:nvSpPr>
-          <p:cNvPr id="16" name="TextBox 15"/>
+          <p:cNvPr id="13" name="TextBox 12"/>
           <p:cNvSpPr txBox="1"/>
           <p:nvPr/>
         </p:nvSpPr>
@@ -3909,14 +4097,14 @@
                   <a:srgbClr val="1E293B"/>
                 </a:solidFill>
               </a:rPr>
-              <a:t>AeroGrid faces a combined Value at Cyber Risk exposure of $44,700,000 across three of five global regions, with threats concentrated in the scenarios carrying the highest and third-highest financial impact rankings worldwide. The dominant pattern is geopolitically driven: state-sponsored targeting of manufacturing intellectual property in APAC, financially motivated criminal disruption of service delivery in AME, and insider exploitation of workforce financial stress in the Mediterranean all converge on AeroGrid's crown jewels — proprietary turbine designs, OT manufacturing networks, and live predictive maintenance platforms. Velocity signals across all five regions are stable with no region accelerating or improving over the current observation window, indicating the threat landscape is entrenched rather than in flux. If any one of the three active exposures materializes, the direct consequences range from turbine production throughput losses and IP exfiltration in manufacturing to full service delivery disruption and regulatory penalties across the wind farm operations portfolio.</a:t>
-            </a:r>
-          </a:p>
-        </p:txBody>
-      </p:sp>
-      <p:sp>
-        <p:nvSpPr>
-          <p:cNvPr id="17" name="TextBox 16"/>
+              <a:t>Three of five operating regions are simultaneously escalated, and the most important pattern the board needs to understand is that all three active threats carry identical B2 intelligence ratings — each is corroborated by confirmed incidents at peer wind energy operators, not modelled projections — which means the combined exposure picture is grounded in observable, ongoing external events. The compound nature of this posture is the defining risk: AME and APAC together place simultaneous pressure on the two asset classes that cannot be substituted in the near term — the service delivery platforms underpinning AeroGrid's major contracted revenue, and the Kaohsiung manufacturing infrastructure that supplies 60% of global turbine output. All three escalated regions share a Mixed signal classification, meaning each threat reflects a structural trend that has already produced a discrete real-world incident in the same sector; this is not a risk environment approaching materialization but one in which peer losses have already occurred. Velocity across all regions has held stable across seven consecutive pipeline runs, confirming the compound threat posture is persistent rather than transient — it is not deteriorating further, but the underlying structural conditions driving exposure in each region show no signs of self-correction.</a:t>
+            </a:r>
+          </a:p>
+        </p:txBody>
+      </p:sp>
+      <p:sp>
+        <p:nvSpPr>
+          <p:cNvPr id="14" name="TextBox 13"/>
           <p:cNvSpPr txBox="1"/>
           <p:nvPr/>
         </p:nvSpPr>
@@ -3950,7 +4138,7 @@
       </p:sp>
       <p:sp>
         <p:nvSpPr>
-          <p:cNvPr id="18" name="TextBox 17"/>
+          <p:cNvPr id="15" name="TextBox 14"/>
           <p:cNvSpPr txBox="1"/>
           <p:nvPr/>
         </p:nvSpPr>
@@ -3984,143 +4172,109 @@
       </p:sp>
       <p:sp>
         <p:nvSpPr>
+          <p:cNvPr id="16" name="TextBox 15"/>
+          <p:cNvSpPr txBox="1"/>
+          <p:nvPr/>
+        </p:nvSpPr>
+        <p:spPr>
+          <a:xfrm>
+            <a:off x="3474720" y="2743200"/>
+            <a:ext cx="1280160" cy="274320"/>
+          </a:xfrm>
+          <a:prstGeom prst="rect">
+            <a:avLst/>
+          </a:prstGeom>
+          <a:noFill/>
+        </p:spPr>
+        <p:txBody>
+          <a:bodyPr wrap="square">
+            <a:spAutoFit/>
+          </a:bodyPr>
+          <a:lstStyle/>
+          <a:p>
+            <a:pPr algn="l"/>
+            <a:r>
+              <a:rPr sz="800" b="1">
+                <a:solidFill>
+                  <a:srgbClr val="64748B"/>
+                </a:solidFill>
+              </a:rPr>
+              <a:t>Severity</a:t>
+            </a:r>
+          </a:p>
+        </p:txBody>
+      </p:sp>
+      <p:sp>
+        <p:nvSpPr>
+          <p:cNvPr id="17" name="TextBox 16"/>
+          <p:cNvSpPr txBox="1"/>
+          <p:nvPr/>
+        </p:nvSpPr>
+        <p:spPr>
+          <a:xfrm>
+            <a:off x="4754880" y="2743200"/>
+            <a:ext cx="1645920" cy="274320"/>
+          </a:xfrm>
+          <a:prstGeom prst="rect">
+            <a:avLst/>
+          </a:prstGeom>
+          <a:noFill/>
+        </p:spPr>
+        <p:txBody>
+          <a:bodyPr wrap="square">
+            <a:spAutoFit/>
+          </a:bodyPr>
+          <a:lstStyle/>
+          <a:p>
+            <a:pPr algn="l"/>
+            <a:r>
+              <a:rPr sz="800" b="1">
+                <a:solidFill>
+                  <a:srgbClr val="64748B"/>
+                </a:solidFill>
+              </a:rPr>
+              <a:t>Velocity</a:t>
+            </a:r>
+          </a:p>
+        </p:txBody>
+      </p:sp>
+      <p:sp>
+        <p:nvSpPr>
+          <p:cNvPr id="18" name="TextBox 17"/>
+          <p:cNvSpPr txBox="1"/>
+          <p:nvPr/>
+        </p:nvSpPr>
+        <p:spPr>
+          <a:xfrm>
+            <a:off x="6400800" y="2743200"/>
+            <a:ext cx="1280160" cy="274320"/>
+          </a:xfrm>
+          <a:prstGeom prst="rect">
+            <a:avLst/>
+          </a:prstGeom>
+          <a:noFill/>
+        </p:spPr>
+        <p:txBody>
+          <a:bodyPr wrap="square">
+            <a:spAutoFit/>
+          </a:bodyPr>
+          <a:lstStyle/>
+          <a:p>
+            <a:pPr algn="l"/>
+            <a:r>
+              <a:rPr sz="800" b="1">
+                <a:solidFill>
+                  <a:srgbClr val="64748B"/>
+                </a:solidFill>
+              </a:rPr>
+              <a:t>Confidence</a:t>
+            </a:r>
+          </a:p>
+        </p:txBody>
+      </p:sp>
+      <p:sp>
+        <p:nvSpPr>
           <p:cNvPr id="19" name="TextBox 18"/>
-          <p:cNvSpPr txBox="1"/>
-          <p:nvPr/>
-        </p:nvSpPr>
-        <p:spPr>
-          <a:xfrm>
-            <a:off x="3474720" y="2743200"/>
-            <a:ext cx="1097280" cy="274320"/>
-          </a:xfrm>
-          <a:prstGeom prst="rect">
-            <a:avLst/>
-          </a:prstGeom>
-          <a:noFill/>
-        </p:spPr>
-        <p:txBody>
-          <a:bodyPr wrap="square">
-            <a:spAutoFit/>
-          </a:bodyPr>
-          <a:lstStyle/>
-          <a:p>
-            <a:pPr algn="l"/>
-            <a:r>
-              <a:rPr sz="800" b="1">
-                <a:solidFill>
-                  <a:srgbClr val="64748B"/>
-                </a:solidFill>
-              </a:rPr>
-              <a:t>VaCR</a:t>
-            </a:r>
-          </a:p>
-        </p:txBody>
-      </p:sp>
-      <p:sp>
-        <p:nvSpPr>
-          <p:cNvPr id="20" name="TextBox 19"/>
-          <p:cNvSpPr txBox="1"/>
-          <p:nvPr/>
-        </p:nvSpPr>
-        <p:spPr>
-          <a:xfrm>
-            <a:off x="4572000" y="2743200"/>
-            <a:ext cx="1005840" cy="274320"/>
-          </a:xfrm>
-          <a:prstGeom prst="rect">
-            <a:avLst/>
-          </a:prstGeom>
-          <a:noFill/>
-        </p:spPr>
-        <p:txBody>
-          <a:bodyPr wrap="square">
-            <a:spAutoFit/>
-          </a:bodyPr>
-          <a:lstStyle/>
-          <a:p>
-            <a:pPr algn="l"/>
-            <a:r>
-              <a:rPr sz="800" b="1">
-                <a:solidFill>
-                  <a:srgbClr val="64748B"/>
-                </a:solidFill>
-              </a:rPr>
-              <a:t>Admiralty</a:t>
-            </a:r>
-          </a:p>
-        </p:txBody>
-      </p:sp>
-      <p:sp>
-        <p:nvSpPr>
-          <p:cNvPr id="21" name="TextBox 20"/>
-          <p:cNvSpPr txBox="1"/>
-          <p:nvPr/>
-        </p:nvSpPr>
-        <p:spPr>
-          <a:xfrm>
-            <a:off x="5577840" y="2743200"/>
-            <a:ext cx="1645920" cy="274320"/>
-          </a:xfrm>
-          <a:prstGeom prst="rect">
-            <a:avLst/>
-          </a:prstGeom>
-          <a:noFill/>
-        </p:spPr>
-        <p:txBody>
-          <a:bodyPr wrap="square">
-            <a:spAutoFit/>
-          </a:bodyPr>
-          <a:lstStyle/>
-          <a:p>
-            <a:pPr algn="l"/>
-            <a:r>
-              <a:rPr sz="800" b="1">
-                <a:solidFill>
-                  <a:srgbClr val="64748B"/>
-                </a:solidFill>
-              </a:rPr>
-              <a:t>Velocity</a:t>
-            </a:r>
-          </a:p>
-        </p:txBody>
-      </p:sp>
-      <p:sp>
-        <p:nvSpPr>
-          <p:cNvPr id="22" name="TextBox 21"/>
-          <p:cNvSpPr txBox="1"/>
-          <p:nvPr/>
-        </p:nvSpPr>
-        <p:spPr>
-          <a:xfrm>
-            <a:off x="7223760" y="2743200"/>
-            <a:ext cx="1097280" cy="274320"/>
-          </a:xfrm>
-          <a:prstGeom prst="rect">
-            <a:avLst/>
-          </a:prstGeom>
-          <a:noFill/>
-        </p:spPr>
-        <p:txBody>
-          <a:bodyPr wrap="square">
-            <a:spAutoFit/>
-          </a:bodyPr>
-          <a:lstStyle/>
-          <a:p>
-            <a:pPr algn="l"/>
-            <a:r>
-              <a:rPr sz="800" b="1">
-                <a:solidFill>
-                  <a:srgbClr val="64748B"/>
-                </a:solidFill>
-              </a:rPr>
-              <a:t>Severity</a:t>
-            </a:r>
-          </a:p>
-        </p:txBody>
-      </p:sp>
-      <p:sp>
-        <p:nvSpPr>
-          <p:cNvPr id="23" name="TextBox 22"/>
           <p:cNvSpPr txBox="1"/>
           <p:nvPr/>
         </p:nvSpPr>
@@ -4154,7 +4308,7 @@
       </p:sp>
       <p:sp>
         <p:nvSpPr>
-          <p:cNvPr id="24" name="TextBox 23"/>
+          <p:cNvPr id="20" name="TextBox 19"/>
           <p:cNvSpPr txBox="1"/>
           <p:nvPr/>
         </p:nvSpPr>
@@ -4188,14 +4342,14 @@
       </p:sp>
       <p:sp>
         <p:nvSpPr>
-          <p:cNvPr id="25" name="TextBox 24"/>
+          <p:cNvPr id="21" name="TextBox 20"/>
           <p:cNvSpPr txBox="1"/>
           <p:nvPr/>
         </p:nvSpPr>
         <p:spPr>
           <a:xfrm>
             <a:off x="3474720" y="3063240"/>
-            <a:ext cx="1097280" cy="320040"/>
+            <a:ext cx="1280160" cy="320040"/>
           </a:xfrm>
           <a:prstGeom prst="rect">
             <a:avLst/>
@@ -4215,21 +4369,21 @@
                   <a:srgbClr val="1E293B"/>
                 </a:solidFill>
               </a:rPr>
-              <a:t>$18.5M</a:t>
-            </a:r>
-          </a:p>
-        </p:txBody>
-      </p:sp>
-      <p:sp>
-        <p:nvSpPr>
-          <p:cNvPr id="26" name="TextBox 25"/>
-          <p:cNvSpPr txBox="1"/>
-          <p:nvPr/>
-        </p:nvSpPr>
-        <p:spPr>
-          <a:xfrm>
-            <a:off x="4572000" y="3063240"/>
-            <a:ext cx="1005840" cy="320040"/>
+              <a:t>HIGH</a:t>
+            </a:r>
+          </a:p>
+        </p:txBody>
+      </p:sp>
+      <p:sp>
+        <p:nvSpPr>
+          <p:cNvPr id="22" name="TextBox 21"/>
+          <p:cNvSpPr txBox="1"/>
+          <p:nvPr/>
+        </p:nvSpPr>
+        <p:spPr>
+          <a:xfrm>
+            <a:off x="4754880" y="3063240"/>
+            <a:ext cx="1645920" cy="320040"/>
           </a:xfrm>
           <a:prstGeom prst="rect">
             <a:avLst/>
@@ -4249,21 +4403,21 @@
                   <a:srgbClr val="1E293B"/>
                 </a:solidFill>
               </a:rPr>
-              <a:t>B2</a:t>
-            </a:r>
-          </a:p>
-        </p:txBody>
-      </p:sp>
-      <p:sp>
-        <p:nvSpPr>
-          <p:cNvPr id="27" name="TextBox 26"/>
-          <p:cNvSpPr txBox="1"/>
-          <p:nvPr/>
-        </p:nvSpPr>
-        <p:spPr>
-          <a:xfrm>
-            <a:off x="5577840" y="3063240"/>
-            <a:ext cx="1645920" cy="320040"/>
+              <a:t>→ Stable</a:t>
+            </a:r>
+          </a:p>
+        </p:txBody>
+      </p:sp>
+      <p:sp>
+        <p:nvSpPr>
+          <p:cNvPr id="23" name="TextBox 22"/>
+          <p:cNvSpPr txBox="1"/>
+          <p:nvPr/>
+        </p:nvSpPr>
+        <p:spPr>
+          <a:xfrm>
+            <a:off x="6400800" y="3063240"/>
+            <a:ext cx="1280160" cy="320040"/>
           </a:xfrm>
           <a:prstGeom prst="rect">
             <a:avLst/>
@@ -4283,48 +4437,14 @@
                   <a:srgbClr val="1E293B"/>
                 </a:solidFill>
               </a:rPr>
-              <a:t>→ Stable</a:t>
-            </a:r>
-          </a:p>
-        </p:txBody>
-      </p:sp>
-      <p:sp>
-        <p:nvSpPr>
-          <p:cNvPr id="28" name="TextBox 27"/>
-          <p:cNvSpPr txBox="1"/>
-          <p:nvPr/>
-        </p:nvSpPr>
-        <p:spPr>
-          <a:xfrm>
-            <a:off x="7223760" y="3063240"/>
-            <a:ext cx="1097280" cy="320040"/>
-          </a:xfrm>
-          <a:prstGeom prst="rect">
-            <a:avLst/>
-          </a:prstGeom>
-          <a:noFill/>
-        </p:spPr>
-        <p:txBody>
-          <a:bodyPr wrap="square">
-            <a:spAutoFit/>
-          </a:bodyPr>
-          <a:lstStyle/>
-          <a:p>
-            <a:pPr algn="l"/>
-            <a:r>
-              <a:rPr sz="900" b="0">
-                <a:solidFill>
-                  <a:srgbClr val="1E293B"/>
-                </a:solidFill>
-              </a:rPr>
-              <a:t>HIGH</a:t>
-            </a:r>
-          </a:p>
-        </p:txBody>
-      </p:sp>
-      <p:sp>
-        <p:nvSpPr>
-          <p:cNvPr id="29" name="TextBox 28"/>
+              <a:t>High</a:t>
+            </a:r>
+          </a:p>
+        </p:txBody>
+      </p:sp>
+      <p:sp>
+        <p:nvSpPr>
+          <p:cNvPr id="24" name="TextBox 23"/>
           <p:cNvSpPr txBox="1"/>
           <p:nvPr/>
         </p:nvSpPr>
@@ -4358,7 +4478,7 @@
       </p:sp>
       <p:sp>
         <p:nvSpPr>
-          <p:cNvPr id="30" name="TextBox 29"/>
+          <p:cNvPr id="25" name="TextBox 24"/>
           <p:cNvSpPr txBox="1"/>
           <p:nvPr/>
         </p:nvSpPr>
@@ -4392,14 +4512,14 @@
       </p:sp>
       <p:sp>
         <p:nvSpPr>
-          <p:cNvPr id="31" name="TextBox 30"/>
+          <p:cNvPr id="26" name="TextBox 25"/>
           <p:cNvSpPr txBox="1"/>
           <p:nvPr/>
         </p:nvSpPr>
         <p:spPr>
           <a:xfrm>
             <a:off x="3474720" y="3474720"/>
-            <a:ext cx="1097280" cy="320040"/>
+            <a:ext cx="1280160" cy="320040"/>
           </a:xfrm>
           <a:prstGeom prst="rect">
             <a:avLst/>
@@ -4419,21 +4539,21 @@
                   <a:srgbClr val="1E293B"/>
                 </a:solidFill>
               </a:rPr>
-              <a:t>$22.0M</a:t>
-            </a:r>
-          </a:p>
-        </p:txBody>
-      </p:sp>
-      <p:sp>
-        <p:nvSpPr>
-          <p:cNvPr id="32" name="TextBox 31"/>
-          <p:cNvSpPr txBox="1"/>
-          <p:nvPr/>
-        </p:nvSpPr>
-        <p:spPr>
-          <a:xfrm>
-            <a:off x="4572000" y="3474720"/>
-            <a:ext cx="1005840" cy="320040"/>
+              <a:t>CRITICAL</a:t>
+            </a:r>
+          </a:p>
+        </p:txBody>
+      </p:sp>
+      <p:sp>
+        <p:nvSpPr>
+          <p:cNvPr id="27" name="TextBox 26"/>
+          <p:cNvSpPr txBox="1"/>
+          <p:nvPr/>
+        </p:nvSpPr>
+        <p:spPr>
+          <a:xfrm>
+            <a:off x="4754880" y="3474720"/>
+            <a:ext cx="1645920" cy="320040"/>
           </a:xfrm>
           <a:prstGeom prst="rect">
             <a:avLst/>
@@ -4453,21 +4573,21 @@
                   <a:srgbClr val="1E293B"/>
                 </a:solidFill>
               </a:rPr>
-              <a:t>B2</a:t>
-            </a:r>
-          </a:p>
-        </p:txBody>
-      </p:sp>
-      <p:sp>
-        <p:nvSpPr>
-          <p:cNvPr id="33" name="TextBox 32"/>
-          <p:cNvSpPr txBox="1"/>
-          <p:nvPr/>
-        </p:nvSpPr>
-        <p:spPr>
-          <a:xfrm>
-            <a:off x="5577840" y="3474720"/>
-            <a:ext cx="1645920" cy="320040"/>
+              <a:t>→ Stable</a:t>
+            </a:r>
+          </a:p>
+        </p:txBody>
+      </p:sp>
+      <p:sp>
+        <p:nvSpPr>
+          <p:cNvPr id="28" name="TextBox 27"/>
+          <p:cNvSpPr txBox="1"/>
+          <p:nvPr/>
+        </p:nvSpPr>
+        <p:spPr>
+          <a:xfrm>
+            <a:off x="6400800" y="3474720"/>
+            <a:ext cx="1280160" cy="320040"/>
           </a:xfrm>
           <a:prstGeom prst="rect">
             <a:avLst/>
@@ -4487,48 +4607,14 @@
                   <a:srgbClr val="1E293B"/>
                 </a:solidFill>
               </a:rPr>
-              <a:t>→ Stable</a:t>
-            </a:r>
-          </a:p>
-        </p:txBody>
-      </p:sp>
-      <p:sp>
-        <p:nvSpPr>
-          <p:cNvPr id="34" name="TextBox 33"/>
-          <p:cNvSpPr txBox="1"/>
-          <p:nvPr/>
-        </p:nvSpPr>
-        <p:spPr>
-          <a:xfrm>
-            <a:off x="7223760" y="3474720"/>
-            <a:ext cx="1097280" cy="320040"/>
-          </a:xfrm>
-          <a:prstGeom prst="rect">
-            <a:avLst/>
-          </a:prstGeom>
-          <a:noFill/>
-        </p:spPr>
-        <p:txBody>
-          <a:bodyPr wrap="square">
-            <a:spAutoFit/>
-          </a:bodyPr>
-          <a:lstStyle/>
-          <a:p>
-            <a:pPr algn="l"/>
-            <a:r>
-              <a:rPr sz="900" b="0">
-                <a:solidFill>
-                  <a:srgbClr val="1E293B"/>
-                </a:solidFill>
-              </a:rPr>
-              <a:t>CRITICAL</a:t>
-            </a:r>
-          </a:p>
-        </p:txBody>
-      </p:sp>
-      <p:sp>
-        <p:nvSpPr>
-          <p:cNvPr id="35" name="TextBox 34"/>
+              <a:t>High</a:t>
+            </a:r>
+          </a:p>
+        </p:txBody>
+      </p:sp>
+      <p:sp>
+        <p:nvSpPr>
+          <p:cNvPr id="29" name="TextBox 28"/>
           <p:cNvSpPr txBox="1"/>
           <p:nvPr/>
         </p:nvSpPr>
@@ -4562,7 +4648,7 @@
       </p:sp>
       <p:sp>
         <p:nvSpPr>
-          <p:cNvPr id="36" name="TextBox 35"/>
+          <p:cNvPr id="30" name="TextBox 29"/>
           <p:cNvSpPr txBox="1"/>
           <p:nvPr/>
         </p:nvSpPr>
@@ -4596,14 +4682,14 @@
       </p:sp>
       <p:sp>
         <p:nvSpPr>
-          <p:cNvPr id="37" name="TextBox 36"/>
+          <p:cNvPr id="31" name="TextBox 30"/>
           <p:cNvSpPr txBox="1"/>
           <p:nvPr/>
         </p:nvSpPr>
         <p:spPr>
           <a:xfrm>
             <a:off x="3474720" y="3886200"/>
-            <a:ext cx="1097280" cy="320040"/>
+            <a:ext cx="1280160" cy="320040"/>
           </a:xfrm>
           <a:prstGeom prst="rect">
             <a:avLst/>
@@ -4623,21 +4709,21 @@
                   <a:srgbClr val="1E293B"/>
                 </a:solidFill>
               </a:rPr>
-              <a:t>$4.2M</a:t>
-            </a:r>
-          </a:p>
-        </p:txBody>
-      </p:sp>
-      <p:sp>
-        <p:nvSpPr>
-          <p:cNvPr id="38" name="TextBox 37"/>
-          <p:cNvSpPr txBox="1"/>
-          <p:nvPr/>
-        </p:nvSpPr>
-        <p:spPr>
-          <a:xfrm>
-            <a:off x="4572000" y="3886200"/>
-            <a:ext cx="1005840" cy="320040"/>
+              <a:t>MEDIUM</a:t>
+            </a:r>
+          </a:p>
+        </p:txBody>
+      </p:sp>
+      <p:sp>
+        <p:nvSpPr>
+          <p:cNvPr id="32" name="TextBox 31"/>
+          <p:cNvSpPr txBox="1"/>
+          <p:nvPr/>
+        </p:nvSpPr>
+        <p:spPr>
+          <a:xfrm>
+            <a:off x="4754880" y="3886200"/>
+            <a:ext cx="1645920" cy="320040"/>
           </a:xfrm>
           <a:prstGeom prst="rect">
             <a:avLst/>
@@ -4657,21 +4743,21 @@
                   <a:srgbClr val="1E293B"/>
                 </a:solidFill>
               </a:rPr>
-              <a:t>B2</a:t>
-            </a:r>
-          </a:p>
-        </p:txBody>
-      </p:sp>
-      <p:sp>
-        <p:nvSpPr>
-          <p:cNvPr id="39" name="TextBox 38"/>
-          <p:cNvSpPr txBox="1"/>
-          <p:nvPr/>
-        </p:nvSpPr>
-        <p:spPr>
-          <a:xfrm>
-            <a:off x="5577840" y="3886200"/>
-            <a:ext cx="1645920" cy="320040"/>
+              <a:t>→ Stable</a:t>
+            </a:r>
+          </a:p>
+        </p:txBody>
+      </p:sp>
+      <p:sp>
+        <p:nvSpPr>
+          <p:cNvPr id="33" name="TextBox 32"/>
+          <p:cNvSpPr txBox="1"/>
+          <p:nvPr/>
+        </p:nvSpPr>
+        <p:spPr>
+          <a:xfrm>
+            <a:off x="6400800" y="3886200"/>
+            <a:ext cx="1280160" cy="320040"/>
           </a:xfrm>
           <a:prstGeom prst="rect">
             <a:avLst/>
@@ -4691,41 +4777,7 @@
                   <a:srgbClr val="1E293B"/>
                 </a:solidFill>
               </a:rPr>
-              <a:t>→ Stable</a:t>
-            </a:r>
-          </a:p>
-        </p:txBody>
-      </p:sp>
-      <p:sp>
-        <p:nvSpPr>
-          <p:cNvPr id="40" name="TextBox 39"/>
-          <p:cNvSpPr txBox="1"/>
-          <p:nvPr/>
-        </p:nvSpPr>
-        <p:spPr>
-          <a:xfrm>
-            <a:off x="7223760" y="3886200"/>
-            <a:ext cx="1097280" cy="320040"/>
-          </a:xfrm>
-          <a:prstGeom prst="rect">
-            <a:avLst/>
-          </a:prstGeom>
-          <a:noFill/>
-        </p:spPr>
-        <p:txBody>
-          <a:bodyPr wrap="square">
-            <a:spAutoFit/>
-          </a:bodyPr>
-          <a:lstStyle/>
-          <a:p>
-            <a:pPr algn="l"/>
-            <a:r>
-              <a:rPr sz="900" b="0">
-                <a:solidFill>
-                  <a:srgbClr val="1E293B"/>
-                </a:solidFill>
-              </a:rPr>
-              <a:t>MEDIUM</a:t>
+              <a:t>High</a:t>
             </a:r>
           </a:p>
         </p:txBody>
@@ -4874,6 +4926,339 @@
             <a:avLst/>
           </a:prstGeom>
           <a:solidFill>
+            <a:srgbClr val="EA580C"/>
+          </a:solidFill>
+          <a:ln>
+            <a:noFill/>
+          </a:ln>
+        </p:spPr>
+        <p:style>
+          <a:lnRef idx="1">
+            <a:schemeClr val="accent1"/>
+          </a:lnRef>
+          <a:fillRef idx="3">
+            <a:schemeClr val="accent1"/>
+          </a:fillRef>
+          <a:effectRef idx="2">
+            <a:schemeClr val="accent1"/>
+          </a:effectRef>
+          <a:fontRef idx="minor">
+            <a:schemeClr val="lt1"/>
+          </a:fontRef>
+        </p:style>
+        <p:txBody>
+          <a:bodyPr rtlCol="0" anchor="ctr"/>
+          <a:lstStyle/>
+          <a:p>
+            <a:pPr algn="ctr"/>
+          </a:p>
+        </p:txBody>
+      </p:sp>
+      <p:sp>
+        <p:nvSpPr>
+          <p:cNvPr id="6" name="TextBox 5"/>
+          <p:cNvSpPr txBox="1"/>
+          <p:nvPr/>
+        </p:nvSpPr>
+        <p:spPr>
+          <a:xfrm>
+            <a:off x="7680960" y="146304"/>
+            <a:ext cx="1188720" cy="274320"/>
+          </a:xfrm>
+          <a:prstGeom prst="rect">
+            <a:avLst/>
+          </a:prstGeom>
+          <a:noFill/>
+        </p:spPr>
+        <p:txBody>
+          <a:bodyPr wrap="square">
+            <a:spAutoFit/>
+          </a:bodyPr>
+          <a:lstStyle/>
+          <a:p>
+            <a:pPr algn="ctr"/>
+            <a:r>
+              <a:rPr sz="800" b="1">
+                <a:solidFill>
+                  <a:srgbClr val="FFFFFF"/>
+                </a:solidFill>
+              </a:rPr>
+              <a:t>HIGH</a:t>
+            </a:r>
+          </a:p>
+        </p:txBody>
+      </p:sp>
+      <p:sp>
+        <p:nvSpPr>
+          <p:cNvPr id="7" name="TextBox 6"/>
+          <p:cNvSpPr txBox="1"/>
+          <p:nvPr/>
+        </p:nvSpPr>
+        <p:spPr>
+          <a:xfrm>
+            <a:off x="274320" y="685800"/>
+            <a:ext cx="8229600" cy="256032"/>
+          </a:xfrm>
+          <a:prstGeom prst="rect">
+            <a:avLst/>
+          </a:prstGeom>
+          <a:noFill/>
+        </p:spPr>
+        <p:txBody>
+          <a:bodyPr wrap="square">
+            <a:spAutoFit/>
+          </a:bodyPr>
+          <a:lstStyle/>
+          <a:p>
+            <a:pPr algn="l"/>
+            <a:r>
+              <a:rPr sz="900" b="0">
+                <a:solidFill>
+                  <a:srgbClr val="64748B"/>
+                </a:solidFill>
+              </a:rPr>
+              <a:t>System intrusion  ·  Mixed  ·  Confidence: High</a:t>
+            </a:r>
+          </a:p>
+        </p:txBody>
+      </p:sp>
+      <p:sp>
+        <p:nvSpPr>
+          <p:cNvPr id="8" name="Rectangle 7"/>
+          <p:cNvSpPr/>
+          <p:nvPr/>
+        </p:nvSpPr>
+        <p:spPr>
+          <a:xfrm>
+            <a:off x="274320" y="914400"/>
+            <a:ext cx="45720" cy="2377440"/>
+          </a:xfrm>
+          <a:prstGeom prst="rect">
+            <a:avLst/>
+          </a:prstGeom>
+          <a:solidFill>
+            <a:srgbClr val="104277"/>
+          </a:solidFill>
+          <a:ln>
+            <a:noFill/>
+          </a:ln>
+        </p:spPr>
+        <p:style>
+          <a:lnRef idx="1">
+            <a:schemeClr val="accent1"/>
+          </a:lnRef>
+          <a:fillRef idx="3">
+            <a:schemeClr val="accent1"/>
+          </a:fillRef>
+          <a:effectRef idx="2">
+            <a:schemeClr val="accent1"/>
+          </a:effectRef>
+          <a:fontRef idx="minor">
+            <a:schemeClr val="lt1"/>
+          </a:fontRef>
+        </p:style>
+        <p:txBody>
+          <a:bodyPr rtlCol="0" anchor="ctr"/>
+          <a:lstStyle/>
+          <a:p>
+            <a:pPr algn="ctr"/>
+          </a:p>
+        </p:txBody>
+      </p:sp>
+      <p:sp>
+        <p:nvSpPr>
+          <p:cNvPr id="9" name="TextBox 8"/>
+          <p:cNvSpPr txBox="1"/>
+          <p:nvPr/>
+        </p:nvSpPr>
+        <p:spPr>
+          <a:xfrm>
+            <a:off x="365760" y="914400"/>
+            <a:ext cx="4023360" cy="256032"/>
+          </a:xfrm>
+          <a:prstGeom prst="rect">
+            <a:avLst/>
+          </a:prstGeom>
+          <a:noFill/>
+        </p:spPr>
+        <p:txBody>
+          <a:bodyPr wrap="square">
+            <a:spAutoFit/>
+          </a:bodyPr>
+          <a:lstStyle/>
+          <a:p>
+            <a:pPr algn="l"/>
+            <a:r>
+              <a:rPr sz="700" b="1">
+                <a:solidFill>
+                  <a:srgbClr val="64748B"/>
+                </a:solidFill>
+              </a:rPr>
+              <a:t>DRIVER</a:t>
+            </a:r>
+          </a:p>
+        </p:txBody>
+      </p:sp>
+      <p:sp>
+        <p:nvSpPr>
+          <p:cNvPr id="10" name="TextBox 9"/>
+          <p:cNvSpPr txBox="1"/>
+          <p:nvPr/>
+        </p:nvSpPr>
+        <p:spPr>
+          <a:xfrm>
+            <a:off x="365760" y="1170432"/>
+            <a:ext cx="4023360" cy="2121408"/>
+          </a:xfrm>
+          <a:prstGeom prst="rect">
+            <a:avLst/>
+          </a:prstGeom>
+          <a:noFill/>
+        </p:spPr>
+        <p:txBody>
+          <a:bodyPr wrap="square">
+            <a:spAutoFit/>
+          </a:bodyPr>
+          <a:lstStyle/>
+          <a:p>
+            <a:pPr algn="l"/>
+            <a:r>
+              <a:rPr sz="900" b="0">
+                <a:solidFill>
+                  <a:srgbClr val="1E293B"/>
+                </a:solidFill>
+              </a:rPr>
+              <a:t>AeroGrid's ability to fulfil turbine production commitments from Kaohsiung — the source of 60% of global turbine output and the anchor of the TEPCO five-year supply agreement — is being pressured by an intensifying state-directed campaign to extract proprietary wind technology from APAC manufacturing centres.</a:t>
+            </a:r>
+          </a:p>
+        </p:txBody>
+      </p:sp>
+      <p:sp>
+        <p:nvSpPr>
+          <p:cNvPr id="11" name="Rectangle 10"/>
+          <p:cNvSpPr/>
+          <p:nvPr/>
+        </p:nvSpPr>
+        <p:spPr>
+          <a:xfrm>
+            <a:off x="4572000" y="914400"/>
+            <a:ext cx="45720" cy="2377440"/>
+          </a:xfrm>
+          <a:prstGeom prst="rect">
+            <a:avLst/>
+          </a:prstGeom>
+          <a:solidFill>
+            <a:srgbClr val="104277"/>
+          </a:solidFill>
+          <a:ln>
+            <a:noFill/>
+          </a:ln>
+        </p:spPr>
+        <p:style>
+          <a:lnRef idx="1">
+            <a:schemeClr val="accent1"/>
+          </a:lnRef>
+          <a:fillRef idx="3">
+            <a:schemeClr val="accent1"/>
+          </a:fillRef>
+          <a:effectRef idx="2">
+            <a:schemeClr val="accent1"/>
+          </a:effectRef>
+          <a:fontRef idx="minor">
+            <a:schemeClr val="lt1"/>
+          </a:fontRef>
+        </p:style>
+        <p:txBody>
+          <a:bodyPr rtlCol="0" anchor="ctr"/>
+          <a:lstStyle/>
+          <a:p>
+            <a:pPr algn="ctr"/>
+          </a:p>
+        </p:txBody>
+      </p:sp>
+      <p:sp>
+        <p:nvSpPr>
+          <p:cNvPr id="12" name="TextBox 11"/>
+          <p:cNvSpPr txBox="1"/>
+          <p:nvPr/>
+        </p:nvSpPr>
+        <p:spPr>
+          <a:xfrm>
+            <a:off x="4663440" y="914400"/>
+            <a:ext cx="4023360" cy="256032"/>
+          </a:xfrm>
+          <a:prstGeom prst="rect">
+            <a:avLst/>
+          </a:prstGeom>
+          <a:noFill/>
+        </p:spPr>
+        <p:txBody>
+          <a:bodyPr wrap="square">
+            <a:spAutoFit/>
+          </a:bodyPr>
+          <a:lstStyle/>
+          <a:p>
+            <a:pPr algn="l"/>
+            <a:r>
+              <a:rPr sz="700" b="1">
+                <a:solidFill>
+                  <a:srgbClr val="64748B"/>
+                </a:solidFill>
+              </a:rPr>
+              <a:t>EXPOSURE</a:t>
+            </a:r>
+          </a:p>
+        </p:txBody>
+      </p:sp>
+      <p:sp>
+        <p:nvSpPr>
+          <p:cNvPr id="13" name="TextBox 12"/>
+          <p:cNvSpPr txBox="1"/>
+          <p:nvPr/>
+        </p:nvSpPr>
+        <p:spPr>
+          <a:xfrm>
+            <a:off x="4663440" y="1170432"/>
+            <a:ext cx="4023360" cy="2121408"/>
+          </a:xfrm>
+          <a:prstGeom prst="rect">
+            <a:avLst/>
+          </a:prstGeom>
+          <a:noFill/>
+        </p:spPr>
+        <p:txBody>
+          <a:bodyPr wrap="square">
+            <a:spAutoFit/>
+          </a:bodyPr>
+          <a:lstStyle/>
+          <a:p>
+            <a:pPr algn="l"/>
+            <a:r>
+              <a:rPr sz="900" b="0">
+                <a:solidFill>
+                  <a:srgbClr val="1E293B"/>
+                </a:solidFill>
+              </a:rPr>
+              <a:t>The Kaohsiung manufacturing hub's Series 7 production line and SCADA network TW-01 — AeroGrid's most operationally sensitive crown jewels — are the assets most directly exposed by the intrusion pattern evidenced in the signals.</a:t>
+            </a:r>
+          </a:p>
+        </p:txBody>
+      </p:sp>
+      <p:sp>
+        <p:nvSpPr>
+          <p:cNvPr id="14" name="Rectangle 13"/>
+          <p:cNvSpPr/>
+          <p:nvPr/>
+        </p:nvSpPr>
+        <p:spPr>
+          <a:xfrm>
+            <a:off x="274320" y="3383280"/>
+            <a:ext cx="45720" cy="2377440"/>
+          </a:xfrm>
+          <a:prstGeom prst="rect">
+            <a:avLst/>
+          </a:prstGeom>
+          <a:solidFill>
             <a:srgbClr val="DC2626"/>
           </a:solidFill>
           <a:ln>
@@ -4904,48 +5289,125 @@
       </p:sp>
       <p:sp>
         <p:nvSpPr>
-          <p:cNvPr id="6" name="TextBox 5"/>
-          <p:cNvSpPr txBox="1"/>
-          <p:nvPr/>
-        </p:nvSpPr>
-        <p:spPr>
-          <a:xfrm>
-            <a:off x="7680960" y="146304"/>
-            <a:ext cx="1188720" cy="274320"/>
-          </a:xfrm>
-          <a:prstGeom prst="rect">
-            <a:avLst/>
-          </a:prstGeom>
-          <a:noFill/>
-        </p:spPr>
-        <p:txBody>
-          <a:bodyPr wrap="square">
-            <a:spAutoFit/>
-          </a:bodyPr>
+          <p:cNvPr id="15" name="TextBox 14"/>
+          <p:cNvSpPr txBox="1"/>
+          <p:nvPr/>
+        </p:nvSpPr>
+        <p:spPr>
+          <a:xfrm>
+            <a:off x="365760" y="3383280"/>
+            <a:ext cx="4023360" cy="256032"/>
+          </a:xfrm>
+          <a:prstGeom prst="rect">
+            <a:avLst/>
+          </a:prstGeom>
+          <a:noFill/>
+        </p:spPr>
+        <p:txBody>
+          <a:bodyPr wrap="square">
+            <a:spAutoFit/>
+          </a:bodyPr>
+          <a:lstStyle/>
+          <a:p>
+            <a:pPr algn="l"/>
+            <a:r>
+              <a:rPr sz="700" b="1">
+                <a:solidFill>
+                  <a:srgbClr val="64748B"/>
+                </a:solidFill>
+              </a:rPr>
+              <a:t>IMPACT</a:t>
+            </a:r>
+          </a:p>
+        </p:txBody>
+      </p:sp>
+      <p:sp>
+        <p:nvSpPr>
+          <p:cNvPr id="16" name="TextBox 15"/>
+          <p:cNvSpPr txBox="1"/>
+          <p:nvPr/>
+        </p:nvSpPr>
+        <p:spPr>
+          <a:xfrm>
+            <a:off x="365760" y="3639312"/>
+            <a:ext cx="4023360" cy="2121408"/>
+          </a:xfrm>
+          <a:prstGeom prst="rect">
+            <a:avLst/>
+          </a:prstGeom>
+          <a:noFill/>
+        </p:spPr>
+        <p:txBody>
+          <a:bodyPr wrap="square">
+            <a:spAutoFit/>
+          </a:bodyPr>
+          <a:lstStyle/>
+          <a:p>
+            <a:pPr algn="l"/>
+            <a:r>
+              <a:rPr sz="900" b="0">
+                <a:solidFill>
+                  <a:srgbClr val="1E293B"/>
+                </a:solidFill>
+              </a:rPr>
+              <a:t>Undetected persistent access to the Kaohsiung blade production line control systems would directly threaten output on the Series 7 line, which at 60% of global production capacity cannot be compensated by other regions without material breach exposure on the TEPCO agreement.</a:t>
+            </a:r>
+          </a:p>
+        </p:txBody>
+      </p:sp>
+      <p:sp>
+        <p:nvSpPr>
+          <p:cNvPr id="17" name="Rectangle 16"/>
+          <p:cNvSpPr/>
+          <p:nvPr/>
+        </p:nvSpPr>
+        <p:spPr>
+          <a:xfrm>
+            <a:off x="4572000" y="3383280"/>
+            <a:ext cx="45720" cy="2377440"/>
+          </a:xfrm>
+          <a:prstGeom prst="rect">
+            <a:avLst/>
+          </a:prstGeom>
+          <a:solidFill>
+            <a:srgbClr val="D97706"/>
+          </a:solidFill>
+          <a:ln>
+            <a:noFill/>
+          </a:ln>
+        </p:spPr>
+        <p:style>
+          <a:lnRef idx="1">
+            <a:schemeClr val="accent1"/>
+          </a:lnRef>
+          <a:fillRef idx="3">
+            <a:schemeClr val="accent1"/>
+          </a:fillRef>
+          <a:effectRef idx="2">
+            <a:schemeClr val="accent1"/>
+          </a:effectRef>
+          <a:fontRef idx="minor">
+            <a:schemeClr val="lt1"/>
+          </a:fontRef>
+        </p:style>
+        <p:txBody>
+          <a:bodyPr rtlCol="0" anchor="ctr"/>
           <a:lstStyle/>
           <a:p>
             <a:pPr algn="ctr"/>
-            <a:r>
-              <a:rPr sz="800" b="1">
-                <a:solidFill>
-                  <a:srgbClr val="FFFFFF"/>
-                </a:solidFill>
-              </a:rPr>
-              <a:t>ESCALATED</a:t>
-            </a:r>
-          </a:p>
-        </p:txBody>
-      </p:sp>
-      <p:sp>
-        <p:nvSpPr>
-          <p:cNvPr id="7" name="TextBox 6"/>
-          <p:cNvSpPr txBox="1"/>
-          <p:nvPr/>
-        </p:nvSpPr>
-        <p:spPr>
-          <a:xfrm>
-            <a:off x="274320" y="777240"/>
-            <a:ext cx="1280160" cy="274320"/>
+          </a:p>
+        </p:txBody>
+      </p:sp>
+      <p:sp>
+        <p:nvSpPr>
+          <p:cNvPr id="18" name="TextBox 17"/>
+          <p:cNvSpPr txBox="1"/>
+          <p:nvPr/>
+        </p:nvSpPr>
+        <p:spPr>
+          <a:xfrm>
+            <a:off x="4663440" y="3383280"/>
+            <a:ext cx="4023360" cy="256032"/>
           </a:xfrm>
           <a:prstGeom prst="rect">
             <a:avLst/>
@@ -4960,26 +5422,26 @@
           <a:p>
             <a:pPr algn="l"/>
             <a:r>
-              <a:rPr sz="700" b="0">
+              <a:rPr sz="700" b="1">
                 <a:solidFill>
                   <a:srgbClr val="64748B"/>
                 </a:solidFill>
               </a:rPr>
-              <a:t>VaCR Exposure</a:t>
-            </a:r>
-          </a:p>
-        </p:txBody>
-      </p:sp>
-      <p:sp>
-        <p:nvSpPr>
-          <p:cNvPr id="8" name="TextBox 7"/>
-          <p:cNvSpPr txBox="1"/>
-          <p:nvPr/>
-        </p:nvSpPr>
-        <p:spPr>
-          <a:xfrm>
-            <a:off x="274320" y="1069848"/>
-            <a:ext cx="1280160" cy="640080"/>
+              <a:t>WATCH</a:t>
+            </a:r>
+          </a:p>
+        </p:txBody>
+      </p:sp>
+      <p:sp>
+        <p:nvSpPr>
+          <p:cNvPr id="19" name="TextBox 18"/>
+          <p:cNvSpPr txBox="1"/>
+          <p:nvPr/>
+        </p:nvSpPr>
+        <p:spPr>
+          <a:xfrm>
+            <a:off x="4663440" y="3639312"/>
+            <a:ext cx="4023360" cy="2121408"/>
           </a:xfrm>
           <a:prstGeom prst="rect">
             <a:avLst/>
@@ -4994,26 +5456,26 @@
           <a:p>
             <a:pPr algn="l"/>
             <a:r>
-              <a:rPr sz="1600" b="1">
-                <a:solidFill>
-                  <a:srgbClr val="104277"/>
-                </a:solidFill>
-              </a:rPr>
-              <a:t>$18.5M</a:t>
-            </a:r>
-          </a:p>
-        </p:txBody>
-      </p:sp>
-      <p:sp>
-        <p:nvSpPr>
-          <p:cNvPr id="9" name="TextBox 8"/>
-          <p:cNvSpPr txBox="1"/>
-          <p:nvPr/>
-        </p:nvSpPr>
-        <p:spPr>
-          <a:xfrm>
-            <a:off x="274320" y="2194560"/>
-            <a:ext cx="1280160" cy="274320"/>
+              <a:rPr sz="900" b="0">
+                <a:solidFill>
+                  <a:srgbClr val="1E293B"/>
+                </a:solidFill>
+              </a:rPr>
+              <a:t>The priority watch item for this region is confirmation of whether the documented supply chain compromise involves software deployed inside AeroGrid's Kaohsiung production environment — that determination would shift this classification from Mixed to a discrete Event and directly change the operational response required.</a:t>
+            </a:r>
+          </a:p>
+        </p:txBody>
+      </p:sp>
+      <p:sp>
+        <p:nvSpPr>
+          <p:cNvPr id="20" name="TextBox 19"/>
+          <p:cNvSpPr txBox="1"/>
+          <p:nvPr/>
+        </p:nvSpPr>
+        <p:spPr>
+          <a:xfrm>
+            <a:off x="274320" y="5852160"/>
+            <a:ext cx="2286000" cy="274320"/>
           </a:xfrm>
           <a:prstGeom prst="rect">
             <a:avLst/>
@@ -5028,26 +5490,26 @@
           <a:p>
             <a:pPr algn="l"/>
             <a:r>
-              <a:rPr sz="700" b="0">
+              <a:rPr sz="800" b="0">
                 <a:solidFill>
                   <a:srgbClr val="64748B"/>
                 </a:solidFill>
               </a:rPr>
-              <a:t>Admiralty</a:t>
-            </a:r>
-          </a:p>
-        </p:txBody>
-      </p:sp>
-      <p:sp>
-        <p:nvSpPr>
-          <p:cNvPr id="10" name="TextBox 9"/>
-          <p:cNvSpPr txBox="1"/>
-          <p:nvPr/>
-        </p:nvSpPr>
-        <p:spPr>
-          <a:xfrm>
-            <a:off x="274320" y="2487168"/>
-            <a:ext cx="1280160" cy="640080"/>
+              <a:t>→ Stable</a:t>
+            </a:r>
+          </a:p>
+        </p:txBody>
+      </p:sp>
+      <p:sp>
+        <p:nvSpPr>
+          <p:cNvPr id="21" name="TextBox 20"/>
+          <p:cNvSpPr txBox="1"/>
+          <p:nvPr/>
+        </p:nvSpPr>
+        <p:spPr>
+          <a:xfrm>
+            <a:off x="2743200" y="5852160"/>
+            <a:ext cx="5943600" cy="274320"/>
           </a:xfrm>
           <a:prstGeom prst="rect">
             <a:avLst/>
@@ -5062,352 +5524,12 @@
           <a:p>
             <a:pPr algn="l"/>
             <a:r>
-              <a:rPr sz="1600" b="1">
-                <a:solidFill>
-                  <a:srgbClr val="104277"/>
-                </a:solidFill>
-              </a:rPr>
-              <a:t>B2</a:t>
-            </a:r>
-          </a:p>
-        </p:txBody>
-      </p:sp>
-      <p:sp>
-        <p:nvSpPr>
-          <p:cNvPr id="11" name="TextBox 10"/>
-          <p:cNvSpPr txBox="1"/>
-          <p:nvPr/>
-        </p:nvSpPr>
-        <p:spPr>
-          <a:xfrm>
-            <a:off x="274320" y="3611880"/>
-            <a:ext cx="1280160" cy="274320"/>
-          </a:xfrm>
-          <a:prstGeom prst="rect">
-            <a:avLst/>
-          </a:prstGeom>
-          <a:noFill/>
-        </p:spPr>
-        <p:txBody>
-          <a:bodyPr wrap="square">
-            <a:spAutoFit/>
-          </a:bodyPr>
-          <a:lstStyle/>
-          <a:p>
-            <a:pPr algn="l"/>
-            <a:r>
-              <a:rPr sz="700" b="0">
+              <a:rPr sz="800" b="0">
                 <a:solidFill>
                   <a:srgbClr val="64748B"/>
                 </a:solidFill>
               </a:rPr>
-              <a:t>Velocity</a:t>
-            </a:r>
-          </a:p>
-        </p:txBody>
-      </p:sp>
-      <p:sp>
-        <p:nvSpPr>
-          <p:cNvPr id="12" name="TextBox 11"/>
-          <p:cNvSpPr txBox="1"/>
-          <p:nvPr/>
-        </p:nvSpPr>
-        <p:spPr>
-          <a:xfrm>
-            <a:off x="274320" y="3904488"/>
-            <a:ext cx="1280160" cy="640080"/>
-          </a:xfrm>
-          <a:prstGeom prst="rect">
-            <a:avLst/>
-          </a:prstGeom>
-          <a:noFill/>
-        </p:spPr>
-        <p:txBody>
-          <a:bodyPr wrap="square">
-            <a:spAutoFit/>
-          </a:bodyPr>
-          <a:lstStyle/>
-          <a:p>
-            <a:pPr algn="l"/>
-            <a:r>
-              <a:rPr sz="1600" b="1">
-                <a:solidFill>
-                  <a:srgbClr val="64748B"/>
-                </a:solidFill>
-              </a:rPr>
-              <a:t>→ Stable</a:t>
-            </a:r>
-          </a:p>
-        </p:txBody>
-      </p:sp>
-      <p:sp>
-        <p:nvSpPr>
-          <p:cNvPr id="13" name="TextBox 12"/>
-          <p:cNvSpPr txBox="1"/>
-          <p:nvPr/>
-        </p:nvSpPr>
-        <p:spPr>
-          <a:xfrm>
-            <a:off x="274320" y="5029200"/>
-            <a:ext cx="1280160" cy="274320"/>
-          </a:xfrm>
-          <a:prstGeom prst="rect">
-            <a:avLst/>
-          </a:prstGeom>
-          <a:noFill/>
-        </p:spPr>
-        <p:txBody>
-          <a:bodyPr wrap="square">
-            <a:spAutoFit/>
-          </a:bodyPr>
-          <a:lstStyle/>
-          <a:p>
-            <a:pPr algn="l"/>
-            <a:r>
-              <a:rPr sz="700" b="0">
-                <a:solidFill>
-                  <a:srgbClr val="64748B"/>
-                </a:solidFill>
-              </a:rPr>
-              <a:t>Severity</a:t>
-            </a:r>
-          </a:p>
-        </p:txBody>
-      </p:sp>
-      <p:sp>
-        <p:nvSpPr>
-          <p:cNvPr id="14" name="TextBox 13"/>
-          <p:cNvSpPr txBox="1"/>
-          <p:nvPr/>
-        </p:nvSpPr>
-        <p:spPr>
-          <a:xfrm>
-            <a:off x="274320" y="5321808"/>
-            <a:ext cx="1280160" cy="640080"/>
-          </a:xfrm>
-          <a:prstGeom prst="rect">
-            <a:avLst/>
-          </a:prstGeom>
-          <a:noFill/>
-        </p:spPr>
-        <p:txBody>
-          <a:bodyPr wrap="square">
-            <a:spAutoFit/>
-          </a:bodyPr>
-          <a:lstStyle/>
-          <a:p>
-            <a:pPr algn="l"/>
-            <a:r>
-              <a:rPr sz="1600" b="1">
-                <a:solidFill>
-                  <a:srgbClr val="DC2626"/>
-                </a:solidFill>
-              </a:rPr>
-              <a:t>HIGH</a:t>
-            </a:r>
-          </a:p>
-        </p:txBody>
-      </p:sp>
-      <p:sp>
-        <p:nvSpPr>
-          <p:cNvPr id="15" name="TextBox 14"/>
-          <p:cNvSpPr txBox="1"/>
-          <p:nvPr/>
-        </p:nvSpPr>
-        <p:spPr>
-          <a:xfrm>
-            <a:off x="1737360" y="777240"/>
-            <a:ext cx="7132320" cy="256032"/>
-          </a:xfrm>
-          <a:prstGeom prst="rect">
-            <a:avLst/>
-          </a:prstGeom>
-          <a:noFill/>
-        </p:spPr>
-        <p:txBody>
-          <a:bodyPr wrap="square">
-            <a:spAutoFit/>
-          </a:bodyPr>
-          <a:lstStyle/>
-          <a:p>
-            <a:pPr algn="l"/>
-            <a:r>
-              <a:rPr sz="800" b="1">
-                <a:solidFill>
-                  <a:srgbClr val="104277"/>
-                </a:solidFill>
-              </a:rPr>
-              <a:t>WHY — GEOPOLITICAL DRIVER</a:t>
-            </a:r>
-          </a:p>
-        </p:txBody>
-      </p:sp>
-      <p:sp>
-        <p:nvSpPr>
-          <p:cNvPr id="16" name="TextBox 15"/>
-          <p:cNvSpPr txBox="1"/>
-          <p:nvPr/>
-        </p:nvSpPr>
-        <p:spPr>
-          <a:xfrm>
-            <a:off x="1737360" y="1051560"/>
-            <a:ext cx="7132320" cy="1371600"/>
-          </a:xfrm>
-          <a:prstGeom prst="rect">
-            <a:avLst/>
-          </a:prstGeom>
-          <a:noFill/>
-        </p:spPr>
-        <p:txBody>
-          <a:bodyPr wrap="square">
-            <a:spAutoFit/>
-          </a:bodyPr>
-          <a:lstStyle/>
-          <a:p>
-            <a:pPr algn="l"/>
-            <a:r>
-              <a:rPr sz="900" b="0">
-                <a:solidFill>
-                  <a:srgbClr val="1E293B"/>
-                </a:solidFill>
-              </a:rPr>
-              <a:t>AeroGrid's ability to maintain uninterrupted blade manufacturing output across its APAC facilities faces growing pressure from escalating territorial disputes in the South China Sea. State-sponsored industrial espionage campaigns have intensified as multinational manufacturers accelerate supply chain diversification away from single-region dependencies. The convergence of China-Taiwan strait tensi</a:t>
-            </a:r>
-          </a:p>
-        </p:txBody>
-      </p:sp>
-      <p:sp>
-        <p:nvSpPr>
-          <p:cNvPr id="17" name="TextBox 16"/>
-          <p:cNvSpPr txBox="1"/>
-          <p:nvPr/>
-        </p:nvSpPr>
-        <p:spPr>
-          <a:xfrm>
-            <a:off x="1737360" y="2697480"/>
-            <a:ext cx="7132320" cy="256032"/>
-          </a:xfrm>
-          <a:prstGeom prst="rect">
-            <a:avLst/>
-          </a:prstGeom>
-          <a:noFill/>
-        </p:spPr>
-        <p:txBody>
-          <a:bodyPr wrap="square">
-            <a:spAutoFit/>
-          </a:bodyPr>
-          <a:lstStyle/>
-          <a:p>
-            <a:pPr algn="l"/>
-            <a:r>
-              <a:rPr sz="800" b="1">
-                <a:solidFill>
-                  <a:srgbClr val="104277"/>
-                </a:solidFill>
-              </a:rPr>
-              <a:t>HOW — CYBER VECTOR</a:t>
-            </a:r>
-          </a:p>
-        </p:txBody>
-      </p:sp>
-      <p:sp>
-        <p:nvSpPr>
-          <p:cNvPr id="18" name="TextBox 17"/>
-          <p:cNvSpPr txBox="1"/>
-          <p:nvPr/>
-        </p:nvSpPr>
-        <p:spPr>
-          <a:xfrm>
-            <a:off x="1737360" y="2971800"/>
-            <a:ext cx="7132320" cy="1371600"/>
-          </a:xfrm>
-          <a:prstGeom prst="rect">
-            <a:avLst/>
-          </a:prstGeom>
-          <a:noFill/>
-        </p:spPr>
-        <p:txBody>
-          <a:bodyPr wrap="square">
-            <a:spAutoFit/>
-          </a:bodyPr>
-          <a:lstStyle/>
-          <a:p>
-            <a:pPr algn="l"/>
-            <a:r>
-              <a:rPr sz="900" b="0">
-                <a:solidFill>
-                  <a:srgbClr val="1E293B"/>
-                </a:solidFill>
-              </a:rPr>
-              <a:t>This geopolitical pressure is manifesting as documented intrusion campaigns targeting operational technology networks in the Asia-Pacific manufacturing sector. Security researchers have identified a supply chain compromise through third-party industrial automation software updates — a vector that provides persistent access to blade production line control systems. AeroGrid's proprietary turbine ae</a:t>
-            </a:r>
-          </a:p>
-        </p:txBody>
-      </p:sp>
-      <p:sp>
-        <p:nvSpPr>
-          <p:cNvPr id="19" name="TextBox 18"/>
-          <p:cNvSpPr txBox="1"/>
-          <p:nvPr/>
-        </p:nvSpPr>
-        <p:spPr>
-          <a:xfrm>
-            <a:off x="1737360" y="4617720"/>
-            <a:ext cx="7132320" cy="256032"/>
-          </a:xfrm>
-          <a:prstGeom prst="rect">
-            <a:avLst/>
-          </a:prstGeom>
-          <a:noFill/>
-        </p:spPr>
-        <p:txBody>
-          <a:bodyPr wrap="square">
-            <a:spAutoFit/>
-          </a:bodyPr>
-          <a:lstStyle/>
-          <a:p>
-            <a:pPr algn="l"/>
-            <a:r>
-              <a:rPr sz="800" b="1">
-                <a:solidFill>
-                  <a:srgbClr val="104277"/>
-                </a:solidFill>
-              </a:rPr>
-              <a:t>SO WHAT — BUSINESS IMPACT</a:t>
-            </a:r>
-          </a:p>
-        </p:txBody>
-      </p:sp>
-      <p:sp>
-        <p:nvSpPr>
-          <p:cNvPr id="20" name="TextBox 19"/>
-          <p:cNvSpPr txBox="1"/>
-          <p:nvPr/>
-        </p:nvSpPr>
-        <p:spPr>
-          <a:xfrm>
-            <a:off x="1737360" y="4892040"/>
-            <a:ext cx="7132320" cy="1371600"/>
-          </a:xfrm>
-          <a:prstGeom prst="rect">
-            <a:avLst/>
-          </a:prstGeom>
-          <a:noFill/>
-        </p:spPr>
-        <p:txBody>
-          <a:bodyPr wrap="square">
-            <a:spAutoFit/>
-          </a:bodyPr>
-          <a:lstStyle/>
-          <a:p>
-            <a:pPr algn="l"/>
-            <a:r>
-              <a:rPr sz="900" b="0">
-                <a:solidFill>
-                  <a:srgbClr val="1E293B"/>
-                </a:solidFill>
-              </a:rPr>
-              <a:t>The Value at Cyber Risk exposure for APAC stands at $18,500,000. This pattern is consistent with the System intrusion scenario, ranked #3 globally by financial impact (21.4% of all losses) and #1 by event frequency (43.3% of all incidents). The trend trajectory indicates increasing state-sponsored targeting of wind energy manufacturing IP, with no near-term de-escalation signals from the underlyin</a:t>
+              <a:t>State-directed threat</a:t>
             </a:r>
           </a:p>
         </p:txBody>
@@ -5613,7 +5735,7 @@
                   <a:srgbClr val="FFFFFF"/>
                 </a:solidFill>
               </a:rPr>
-              <a:t>ESCALATED</a:t>
+              <a:t>CRITICAL</a:t>
             </a:r>
           </a:p>
         </p:txBody>
@@ -5626,8 +5748,8 @@
         </p:nvSpPr>
         <p:spPr>
           <a:xfrm>
-            <a:off x="274320" y="777240"/>
-            <a:ext cx="1280160" cy="274320"/>
+            <a:off x="274320" y="685800"/>
+            <a:ext cx="8229600" cy="256032"/>
           </a:xfrm>
           <a:prstGeom prst="rect">
             <a:avLst/>
@@ -5642,26 +5764,69 @@
           <a:p>
             <a:pPr algn="l"/>
             <a:r>
-              <a:rPr sz="700" b="0">
+              <a:rPr sz="900" b="0">
                 <a:solidFill>
                   <a:srgbClr val="64748B"/>
                 </a:solidFill>
               </a:rPr>
-              <a:t>VaCR Exposure</a:t>
-            </a:r>
-          </a:p>
-        </p:txBody>
-      </p:sp>
-      <p:sp>
-        <p:nvSpPr>
-          <p:cNvPr id="8" name="TextBox 7"/>
-          <p:cNvSpPr txBox="1"/>
-          <p:nvPr/>
-        </p:nvSpPr>
-        <p:spPr>
-          <a:xfrm>
-            <a:off x="274320" y="1069848"/>
-            <a:ext cx="1280160" cy="640080"/>
+              <a:t>Ransomware  ·  Mixed  ·  Confidence: High</a:t>
+            </a:r>
+          </a:p>
+        </p:txBody>
+      </p:sp>
+      <p:sp>
+        <p:nvSpPr>
+          <p:cNvPr id="8" name="Rectangle 7"/>
+          <p:cNvSpPr/>
+          <p:nvPr/>
+        </p:nvSpPr>
+        <p:spPr>
+          <a:xfrm>
+            <a:off x="274320" y="914400"/>
+            <a:ext cx="45720" cy="2377440"/>
+          </a:xfrm>
+          <a:prstGeom prst="rect">
+            <a:avLst/>
+          </a:prstGeom>
+          <a:solidFill>
+            <a:srgbClr val="104277"/>
+          </a:solidFill>
+          <a:ln>
+            <a:noFill/>
+          </a:ln>
+        </p:spPr>
+        <p:style>
+          <a:lnRef idx="1">
+            <a:schemeClr val="accent1"/>
+          </a:lnRef>
+          <a:fillRef idx="3">
+            <a:schemeClr val="accent1"/>
+          </a:fillRef>
+          <a:effectRef idx="2">
+            <a:schemeClr val="accent1"/>
+          </a:effectRef>
+          <a:fontRef idx="minor">
+            <a:schemeClr val="lt1"/>
+          </a:fontRef>
+        </p:style>
+        <p:txBody>
+          <a:bodyPr rtlCol="0" anchor="ctr"/>
+          <a:lstStyle/>
+          <a:p>
+            <a:pPr algn="ctr"/>
+          </a:p>
+        </p:txBody>
+      </p:sp>
+      <p:sp>
+        <p:nvSpPr>
+          <p:cNvPr id="9" name="TextBox 8"/>
+          <p:cNvSpPr txBox="1"/>
+          <p:nvPr/>
+        </p:nvSpPr>
+        <p:spPr>
+          <a:xfrm>
+            <a:off x="365760" y="914400"/>
+            <a:ext cx="4023360" cy="256032"/>
           </a:xfrm>
           <a:prstGeom prst="rect">
             <a:avLst/>
@@ -5676,26 +5841,26 @@
           <a:p>
             <a:pPr algn="l"/>
             <a:r>
-              <a:rPr sz="1600" b="1">
-                <a:solidFill>
-                  <a:srgbClr val="104277"/>
-                </a:solidFill>
-              </a:rPr>
-              <a:t>$22.0M</a:t>
-            </a:r>
-          </a:p>
-        </p:txBody>
-      </p:sp>
-      <p:sp>
-        <p:nvSpPr>
-          <p:cNvPr id="9" name="TextBox 8"/>
-          <p:cNvSpPr txBox="1"/>
-          <p:nvPr/>
-        </p:nvSpPr>
-        <p:spPr>
-          <a:xfrm>
-            <a:off x="274320" y="2194560"/>
-            <a:ext cx="1280160" cy="274320"/>
+              <a:rPr sz="700" b="1">
+                <a:solidFill>
+                  <a:srgbClr val="64748B"/>
+                </a:solidFill>
+              </a:rPr>
+              <a:t>DRIVER</a:t>
+            </a:r>
+          </a:p>
+        </p:txBody>
+      </p:sp>
+      <p:sp>
+        <p:nvSpPr>
+          <p:cNvPr id="10" name="TextBox 9"/>
+          <p:cNvSpPr txBox="1"/>
+          <p:nvPr/>
+        </p:nvSpPr>
+        <p:spPr>
+          <a:xfrm>
+            <a:off x="365760" y="1170432"/>
+            <a:ext cx="4023360" cy="2121408"/>
           </a:xfrm>
           <a:prstGeom prst="rect">
             <a:avLst/>
@@ -5710,26 +5875,103 @@
           <a:p>
             <a:pPr algn="l"/>
             <a:r>
-              <a:rPr sz="700" b="0">
+              <a:rPr sz="900" b="0">
+                <a:solidFill>
+                  <a:srgbClr val="1E293B"/>
+                </a:solidFill>
+              </a:rPr>
+              <a:t>North American wind energy operators are navigating a structural shift in their regulatory standing: a recent US executive order has formally designated offshore wind operations as critical national infrastructure, raising the political and strategic visibility of the sector at a moment when adversaries treat that visibility as targeting criteria.</a:t>
+            </a:r>
+          </a:p>
+        </p:txBody>
+      </p:sp>
+      <p:sp>
+        <p:nvSpPr>
+          <p:cNvPr id="11" name="Rectangle 10"/>
+          <p:cNvSpPr/>
+          <p:nvPr/>
+        </p:nvSpPr>
+        <p:spPr>
+          <a:xfrm>
+            <a:off x="4572000" y="914400"/>
+            <a:ext cx="45720" cy="2377440"/>
+          </a:xfrm>
+          <a:prstGeom prst="rect">
+            <a:avLst/>
+          </a:prstGeom>
+          <a:solidFill>
+            <a:srgbClr val="104277"/>
+          </a:solidFill>
+          <a:ln>
+            <a:noFill/>
+          </a:ln>
+        </p:spPr>
+        <p:style>
+          <a:lnRef idx="1">
+            <a:schemeClr val="accent1"/>
+          </a:lnRef>
+          <a:fillRef idx="3">
+            <a:schemeClr val="accent1"/>
+          </a:fillRef>
+          <a:effectRef idx="2">
+            <a:schemeClr val="accent1"/>
+          </a:effectRef>
+          <a:fontRef idx="minor">
+            <a:schemeClr val="lt1"/>
+          </a:fontRef>
+        </p:style>
+        <p:txBody>
+          <a:bodyPr rtlCol="0" anchor="ctr"/>
+          <a:lstStyle/>
+          <a:p>
+            <a:pPr algn="ctr"/>
+          </a:p>
+        </p:txBody>
+      </p:sp>
+      <p:sp>
+        <p:nvSpPr>
+          <p:cNvPr id="12" name="TextBox 11"/>
+          <p:cNvSpPr txBox="1"/>
+          <p:nvPr/>
+        </p:nvSpPr>
+        <p:spPr>
+          <a:xfrm>
+            <a:off x="4663440" y="914400"/>
+            <a:ext cx="4023360" cy="256032"/>
+          </a:xfrm>
+          <a:prstGeom prst="rect">
+            <a:avLst/>
+          </a:prstGeom>
+          <a:noFill/>
+        </p:spPr>
+        <p:txBody>
+          <a:bodyPr wrap="square">
+            <a:spAutoFit/>
+          </a:bodyPr>
+          <a:lstStyle/>
+          <a:p>
+            <a:pPr algn="l"/>
+            <a:r>
+              <a:rPr sz="700" b="1">
                 <a:solidFill>
                   <a:srgbClr val="64748B"/>
                 </a:solidFill>
               </a:rPr>
-              <a:t>Admiralty</a:t>
-            </a:r>
-          </a:p>
-        </p:txBody>
-      </p:sp>
-      <p:sp>
-        <p:nvSpPr>
-          <p:cNvPr id="10" name="TextBox 9"/>
-          <p:cNvSpPr txBox="1"/>
-          <p:nvPr/>
-        </p:nvSpPr>
-        <p:spPr>
-          <a:xfrm>
-            <a:off x="274320" y="2487168"/>
-            <a:ext cx="1280160" cy="640080"/>
+              <a:t>EXPOSURE</a:t>
+            </a:r>
+          </a:p>
+        </p:txBody>
+      </p:sp>
+      <p:sp>
+        <p:nvSpPr>
+          <p:cNvPr id="13" name="TextBox 12"/>
+          <p:cNvSpPr txBox="1"/>
+          <p:nvPr/>
+        </p:nvSpPr>
+        <p:spPr>
+          <a:xfrm>
+            <a:off x="4663440" y="1170432"/>
+            <a:ext cx="4023360" cy="2121408"/>
           </a:xfrm>
           <a:prstGeom prst="rect">
             <a:avLst/>
@@ -5744,26 +5986,69 @@
           <a:p>
             <a:pPr algn="l"/>
             <a:r>
-              <a:rPr sz="1600" b="1">
-                <a:solidFill>
-                  <a:srgbClr val="104277"/>
-                </a:solidFill>
-              </a:rPr>
-              <a:t>B2</a:t>
-            </a:r>
-          </a:p>
-        </p:txBody>
-      </p:sp>
-      <p:sp>
-        <p:nvSpPr>
-          <p:cNvPr id="11" name="TextBox 10"/>
-          <p:cNvSpPr txBox="1"/>
-          <p:nvPr/>
-        </p:nvSpPr>
-        <p:spPr>
-          <a:xfrm>
-            <a:off x="274320" y="3611880"/>
-            <a:ext cx="1280160" cy="274320"/>
+              <a:rPr sz="900" b="0">
+                <a:solidFill>
+                  <a:srgbClr val="1E293B"/>
+                </a:solidFill>
+              </a:rPr>
+              <a:t>The cyber signals evidence two confirmed incidents at peer North American energy operators in the current collection window.</a:t>
+            </a:r>
+          </a:p>
+        </p:txBody>
+      </p:sp>
+      <p:sp>
+        <p:nvSpPr>
+          <p:cNvPr id="14" name="Rectangle 13"/>
+          <p:cNvSpPr/>
+          <p:nvPr/>
+        </p:nvSpPr>
+        <p:spPr>
+          <a:xfrm>
+            <a:off x="274320" y="3383280"/>
+            <a:ext cx="45720" cy="2377440"/>
+          </a:xfrm>
+          <a:prstGeom prst="rect">
+            <a:avLst/>
+          </a:prstGeom>
+          <a:solidFill>
+            <a:srgbClr val="DC2626"/>
+          </a:solidFill>
+          <a:ln>
+            <a:noFill/>
+          </a:ln>
+        </p:spPr>
+        <p:style>
+          <a:lnRef idx="1">
+            <a:schemeClr val="accent1"/>
+          </a:lnRef>
+          <a:fillRef idx="3">
+            <a:schemeClr val="accent1"/>
+          </a:fillRef>
+          <a:effectRef idx="2">
+            <a:schemeClr val="accent1"/>
+          </a:effectRef>
+          <a:fontRef idx="minor">
+            <a:schemeClr val="lt1"/>
+          </a:fontRef>
+        </p:style>
+        <p:txBody>
+          <a:bodyPr rtlCol="0" anchor="ctr"/>
+          <a:lstStyle/>
+          <a:p>
+            <a:pPr algn="ctr"/>
+          </a:p>
+        </p:txBody>
+      </p:sp>
+      <p:sp>
+        <p:nvSpPr>
+          <p:cNvPr id="15" name="TextBox 14"/>
+          <p:cNvSpPr txBox="1"/>
+          <p:nvPr/>
+        </p:nvSpPr>
+        <p:spPr>
+          <a:xfrm>
+            <a:off x="365760" y="3383280"/>
+            <a:ext cx="4023360" cy="256032"/>
           </a:xfrm>
           <a:prstGeom prst="rect">
             <a:avLst/>
@@ -5778,26 +6063,26 @@
           <a:p>
             <a:pPr algn="l"/>
             <a:r>
-              <a:rPr sz="700" b="0">
+              <a:rPr sz="700" b="1">
                 <a:solidFill>
                   <a:srgbClr val="64748B"/>
                 </a:solidFill>
               </a:rPr>
-              <a:t>Velocity</a:t>
-            </a:r>
-          </a:p>
-        </p:txBody>
-      </p:sp>
-      <p:sp>
-        <p:nvSpPr>
-          <p:cNvPr id="12" name="TextBox 11"/>
-          <p:cNvSpPr txBox="1"/>
-          <p:nvPr/>
-        </p:nvSpPr>
-        <p:spPr>
-          <a:xfrm>
-            <a:off x="274320" y="3904488"/>
-            <a:ext cx="1280160" cy="640080"/>
+              <a:t>IMPACT</a:t>
+            </a:r>
+          </a:p>
+        </p:txBody>
+      </p:sp>
+      <p:sp>
+        <p:nvSpPr>
+          <p:cNvPr id="16" name="TextBox 15"/>
+          <p:cNvSpPr txBox="1"/>
+          <p:nvPr/>
+        </p:nvSpPr>
+        <p:spPr>
+          <a:xfrm>
+            <a:off x="365760" y="3639312"/>
+            <a:ext cx="4023360" cy="2121408"/>
           </a:xfrm>
           <a:prstGeom prst="rect">
             <a:avLst/>
@@ -5812,11 +6097,156 @@
           <a:p>
             <a:pPr algn="l"/>
             <a:r>
-              <a:rPr sz="1600" b="1">
+              <a:rPr sz="900" b="0">
+                <a:solidFill>
+                  <a:srgbClr val="1E293B"/>
+                </a:solidFill>
+              </a:rPr>
+              <a:t>If the pattern evidenced at peer operators were to reach AeroGrid's AME operations, the immediate consequence would be loss of visibility and control over wind farm telemetry network NA-01 — disabling the predictive maintenance capability that underpins both the NextEra Energy three-year maintenance contract and the Ontario Wind Power service agreement.</a:t>
+            </a:r>
+          </a:p>
+        </p:txBody>
+      </p:sp>
+      <p:sp>
+        <p:nvSpPr>
+          <p:cNvPr id="17" name="Rectangle 16"/>
+          <p:cNvSpPr/>
+          <p:nvPr/>
+        </p:nvSpPr>
+        <p:spPr>
+          <a:xfrm>
+            <a:off x="4572000" y="3383280"/>
+            <a:ext cx="45720" cy="2377440"/>
+          </a:xfrm>
+          <a:prstGeom prst="rect">
+            <a:avLst/>
+          </a:prstGeom>
+          <a:solidFill>
+            <a:srgbClr val="D97706"/>
+          </a:solidFill>
+          <a:ln>
+            <a:noFill/>
+          </a:ln>
+        </p:spPr>
+        <p:style>
+          <a:lnRef idx="1">
+            <a:schemeClr val="accent1"/>
+          </a:lnRef>
+          <a:fillRef idx="3">
+            <a:schemeClr val="accent1"/>
+          </a:fillRef>
+          <a:effectRef idx="2">
+            <a:schemeClr val="accent1"/>
+          </a:effectRef>
+          <a:fontRef idx="minor">
+            <a:schemeClr val="lt1"/>
+          </a:fontRef>
+        </p:style>
+        <p:txBody>
+          <a:bodyPr rtlCol="0" anchor="ctr"/>
+          <a:lstStyle/>
+          <a:p>
+            <a:pPr algn="ctr"/>
+          </a:p>
+        </p:txBody>
+      </p:sp>
+      <p:sp>
+        <p:nvSpPr>
+          <p:cNvPr id="18" name="TextBox 17"/>
+          <p:cNvSpPr txBox="1"/>
+          <p:nvPr/>
+        </p:nvSpPr>
+        <p:spPr>
+          <a:xfrm>
+            <a:off x="4663440" y="3383280"/>
+            <a:ext cx="4023360" cy="256032"/>
+          </a:xfrm>
+          <a:prstGeom prst="rect">
+            <a:avLst/>
+          </a:prstGeom>
+          <a:noFill/>
+        </p:spPr>
+        <p:txBody>
+          <a:bodyPr wrap="square">
+            <a:spAutoFit/>
+          </a:bodyPr>
+          <a:lstStyle/>
+          <a:p>
+            <a:pPr algn="l"/>
+            <a:r>
+              <a:rPr sz="700" b="1">
                 <a:solidFill>
                   <a:srgbClr val="64748B"/>
                 </a:solidFill>
               </a:rPr>
+              <a:t>WATCH</a:t>
+            </a:r>
+          </a:p>
+        </p:txBody>
+      </p:sp>
+      <p:sp>
+        <p:nvSpPr>
+          <p:cNvPr id="19" name="TextBox 18"/>
+          <p:cNvSpPr txBox="1"/>
+          <p:nvPr/>
+        </p:nvSpPr>
+        <p:spPr>
+          <a:xfrm>
+            <a:off x="4663440" y="3639312"/>
+            <a:ext cx="4023360" cy="2121408"/>
+          </a:xfrm>
+          <a:prstGeom prst="rect">
+            <a:avLst/>
+          </a:prstGeom>
+          <a:noFill/>
+        </p:spPr>
+        <p:txBody>
+          <a:bodyPr wrap="square">
+            <a:spAutoFit/>
+          </a:bodyPr>
+          <a:lstStyle/>
+          <a:p>
+            <a:pPr algn="l"/>
+            <a:r>
+              <a:rPr sz="900" b="0">
+                <a:solidFill>
+                  <a:srgbClr val="1E293B"/>
+                </a:solidFill>
+              </a:rPr>
+              <a:t>The forward watch position should track whether any AME-region incident disclosure emerges under the new mandatory reporting requirements — a filing by a wind energy peer would be the earliest indicator that this pattern is accelerating toward direct exposure.</a:t>
+            </a:r>
+          </a:p>
+        </p:txBody>
+      </p:sp>
+      <p:sp>
+        <p:nvSpPr>
+          <p:cNvPr id="20" name="TextBox 19"/>
+          <p:cNvSpPr txBox="1"/>
+          <p:nvPr/>
+        </p:nvSpPr>
+        <p:spPr>
+          <a:xfrm>
+            <a:off x="274320" y="5852160"/>
+            <a:ext cx="2286000" cy="274320"/>
+          </a:xfrm>
+          <a:prstGeom prst="rect">
+            <a:avLst/>
+          </a:prstGeom>
+          <a:noFill/>
+        </p:spPr>
+        <p:txBody>
+          <a:bodyPr wrap="square">
+            <a:spAutoFit/>
+          </a:bodyPr>
+          <a:lstStyle/>
+          <a:p>
+            <a:pPr algn="l"/>
+            <a:r>
+              <a:rPr sz="800" b="0">
+                <a:solidFill>
+                  <a:srgbClr val="64748B"/>
+                </a:solidFill>
+              </a:rPr>
               <a:t>→ Stable</a:t>
             </a:r>
           </a:p>
@@ -5824,14 +6254,14 @@
       </p:sp>
       <p:sp>
         <p:nvSpPr>
-          <p:cNvPr id="13" name="TextBox 12"/>
-          <p:cNvSpPr txBox="1"/>
-          <p:nvPr/>
-        </p:nvSpPr>
-        <p:spPr>
-          <a:xfrm>
-            <a:off x="274320" y="5029200"/>
-            <a:ext cx="1280160" cy="274320"/>
+          <p:cNvPr id="21" name="TextBox 20"/>
+          <p:cNvSpPr txBox="1"/>
+          <p:nvPr/>
+        </p:nvSpPr>
+        <p:spPr>
+          <a:xfrm>
+            <a:off x="2743200" y="5852160"/>
+            <a:ext cx="5943600" cy="274320"/>
           </a:xfrm>
           <a:prstGeom prst="rect">
             <a:avLst/>
@@ -5846,250 +6276,12 @@
           <a:p>
             <a:pPr algn="l"/>
             <a:r>
-              <a:rPr sz="700" b="0">
+              <a:rPr sz="800" b="0">
                 <a:solidFill>
                   <a:srgbClr val="64748B"/>
                 </a:solidFill>
               </a:rPr>
-              <a:t>Severity</a:t>
-            </a:r>
-          </a:p>
-        </p:txBody>
-      </p:sp>
-      <p:sp>
-        <p:nvSpPr>
-          <p:cNvPr id="14" name="TextBox 13"/>
-          <p:cNvSpPr txBox="1"/>
-          <p:nvPr/>
-        </p:nvSpPr>
-        <p:spPr>
-          <a:xfrm>
-            <a:off x="274320" y="5321808"/>
-            <a:ext cx="1280160" cy="640080"/>
-          </a:xfrm>
-          <a:prstGeom prst="rect">
-            <a:avLst/>
-          </a:prstGeom>
-          <a:noFill/>
-        </p:spPr>
-        <p:txBody>
-          <a:bodyPr wrap="square">
-            <a:spAutoFit/>
-          </a:bodyPr>
-          <a:lstStyle/>
-          <a:p>
-            <a:pPr algn="l"/>
-            <a:r>
-              <a:rPr sz="1600" b="1">
-                <a:solidFill>
-                  <a:srgbClr val="DC2626"/>
-                </a:solidFill>
-              </a:rPr>
-              <a:t>CRITICAL</a:t>
-            </a:r>
-          </a:p>
-        </p:txBody>
-      </p:sp>
-      <p:sp>
-        <p:nvSpPr>
-          <p:cNvPr id="15" name="TextBox 14"/>
-          <p:cNvSpPr txBox="1"/>
-          <p:nvPr/>
-        </p:nvSpPr>
-        <p:spPr>
-          <a:xfrm>
-            <a:off x="1737360" y="777240"/>
-            <a:ext cx="7132320" cy="256032"/>
-          </a:xfrm>
-          <a:prstGeom prst="rect">
-            <a:avLst/>
-          </a:prstGeom>
-          <a:noFill/>
-        </p:spPr>
-        <p:txBody>
-          <a:bodyPr wrap="square">
-            <a:spAutoFit/>
-          </a:bodyPr>
-          <a:lstStyle/>
-          <a:p>
-            <a:pPr algn="l"/>
-            <a:r>
-              <a:rPr sz="800" b="1">
-                <a:solidFill>
-                  <a:srgbClr val="104277"/>
-                </a:solidFill>
-              </a:rPr>
-              <a:t>WHY — GEOPOLITICAL DRIVER</a:t>
-            </a:r>
-          </a:p>
-        </p:txBody>
-      </p:sp>
-      <p:sp>
-        <p:nvSpPr>
-          <p:cNvPr id="16" name="TextBox 15"/>
-          <p:cNvSpPr txBox="1"/>
-          <p:nvPr/>
-        </p:nvSpPr>
-        <p:spPr>
-          <a:xfrm>
-            <a:off x="1737360" y="1051560"/>
-            <a:ext cx="7132320" cy="1371600"/>
-          </a:xfrm>
-          <a:prstGeom prst="rect">
-            <a:avLst/>
-          </a:prstGeom>
-          <a:noFill/>
-        </p:spPr>
-        <p:txBody>
-          <a:bodyPr wrap="square">
-            <a:spAutoFit/>
-          </a:bodyPr>
-          <a:lstStyle/>
-          <a:p>
-            <a:pPr algn="l"/>
-            <a:r>
-              <a:rPr sz="900" b="0">
-                <a:solidFill>
-                  <a:srgbClr val="1E293B"/>
-                </a:solidFill>
-              </a:rPr>
-              <a:t>AeroGrid's ability to deliver uninterrupted wind farm service operations across North America faces heightened risk as the regulatory environment undergoes structural change. A US executive order has designated offshore wind farm operations as critical national infrastructure, placing AeroGrid's telemetry and maintenance systems under mandatory cybersecurity reporting obligations. Simultaneously, </a:t>
-            </a:r>
-          </a:p>
-        </p:txBody>
-      </p:sp>
-      <p:sp>
-        <p:nvSpPr>
-          <p:cNvPr id="17" name="TextBox 16"/>
-          <p:cNvSpPr txBox="1"/>
-          <p:nvPr/>
-        </p:nvSpPr>
-        <p:spPr>
-          <a:xfrm>
-            <a:off x="1737360" y="2697480"/>
-            <a:ext cx="7132320" cy="256032"/>
-          </a:xfrm>
-          <a:prstGeom prst="rect">
-            <a:avLst/>
-          </a:prstGeom>
-          <a:noFill/>
-        </p:spPr>
-        <p:txBody>
-          <a:bodyPr wrap="square">
-            <a:spAutoFit/>
-          </a:bodyPr>
-          <a:lstStyle/>
-          <a:p>
-            <a:pPr algn="l"/>
-            <a:r>
-              <a:rPr sz="800" b="1">
-                <a:solidFill>
-                  <a:srgbClr val="104277"/>
-                </a:solidFill>
-              </a:rPr>
-              <a:t>HOW — CYBER VECTOR</a:t>
-            </a:r>
-          </a:p>
-        </p:txBody>
-      </p:sp>
-      <p:sp>
-        <p:nvSpPr>
-          <p:cNvPr id="18" name="TextBox 17"/>
-          <p:cNvSpPr txBox="1"/>
-          <p:nvPr/>
-        </p:nvSpPr>
-        <p:spPr>
-          <a:xfrm>
-            <a:off x="1737360" y="2971800"/>
-            <a:ext cx="7132320" cy="1371600"/>
-          </a:xfrm>
-          <a:prstGeom prst="rect">
-            <a:avLst/>
-          </a:prstGeom>
-          <a:noFill/>
-        </p:spPr>
-        <p:txBody>
-          <a:bodyPr wrap="square">
-            <a:spAutoFit/>
-          </a:bodyPr>
-          <a:lstStyle/>
-          <a:p>
-            <a:pPr algn="l"/>
-            <a:r>
-              <a:rPr sz="900" b="0">
-                <a:solidFill>
-                  <a:srgbClr val="1E293B"/>
-                </a:solidFill>
-              </a:rPr>
-              <a:t>This geopolitical backdrop has materialized into a confirmed operational threat. A financially motivated criminal group has successfully encrypted business systems at a North American energy operator, demanding $22 million and threatening release of proprietary turbine efficiency data. A separate double-extortion campaign targeted a wind energy predictive maintenance platform, resulting in 18 days</a:t>
-            </a:r>
-          </a:p>
-        </p:txBody>
-      </p:sp>
-      <p:sp>
-        <p:nvSpPr>
-          <p:cNvPr id="19" name="TextBox 18"/>
-          <p:cNvSpPr txBox="1"/>
-          <p:nvPr/>
-        </p:nvSpPr>
-        <p:spPr>
-          <a:xfrm>
-            <a:off x="1737360" y="4617720"/>
-            <a:ext cx="7132320" cy="256032"/>
-          </a:xfrm>
-          <a:prstGeom prst="rect">
-            <a:avLst/>
-          </a:prstGeom>
-          <a:noFill/>
-        </p:spPr>
-        <p:txBody>
-          <a:bodyPr wrap="square">
-            <a:spAutoFit/>
-          </a:bodyPr>
-          <a:lstStyle/>
-          <a:p>
-            <a:pPr algn="l"/>
-            <a:r>
-              <a:rPr sz="800" b="1">
-                <a:solidFill>
-                  <a:srgbClr val="104277"/>
-                </a:solidFill>
-              </a:rPr>
-              <a:t>SO WHAT — BUSINESS IMPACT</a:t>
-            </a:r>
-          </a:p>
-        </p:txBody>
-      </p:sp>
-      <p:sp>
-        <p:nvSpPr>
-          <p:cNvPr id="20" name="TextBox 19"/>
-          <p:cNvSpPr txBox="1"/>
-          <p:nvPr/>
-        </p:nvSpPr>
-        <p:spPr>
-          <a:xfrm>
-            <a:off x="1737360" y="4892040"/>
-            <a:ext cx="7132320" cy="1371600"/>
-          </a:xfrm>
-          <a:prstGeom prst="rect">
-            <a:avLst/>
-          </a:prstGeom>
-          <a:noFill/>
-        </p:spPr>
-        <p:txBody>
-          <a:bodyPr wrap="square">
-            <a:spAutoFit/>
-          </a:bodyPr>
-          <a:lstStyle/>
-          <a:p>
-            <a:pPr algn="l"/>
-            <a:r>
-              <a:rPr sz="900" b="0">
-                <a:solidFill>
-                  <a:srgbClr val="1E293B"/>
-                </a:solidFill>
-              </a:rPr>
-              <a:t>The Value at Cyber Risk exposure for AME stands at $22,000,000. This pattern is consistent with the Ransomware scenario, ranked #1 globally by financial impact (37.6% of all cyber losses) and #2 by event frequency (31.7% of all events). The signals reflect a mixed pattern: a sustained trend of financially motivated groups targeting energy sector operational technology has now produced specific inc</a:t>
+              <a:t>Financially motivated threat</a:t>
             </a:r>
           </a:p>
         </p:txBody>
@@ -6238,6 +6430,339 @@
             <a:avLst/>
           </a:prstGeom>
           <a:solidFill>
+            <a:srgbClr val="D97706"/>
+          </a:solidFill>
+          <a:ln>
+            <a:noFill/>
+          </a:ln>
+        </p:spPr>
+        <p:style>
+          <a:lnRef idx="1">
+            <a:schemeClr val="accent1"/>
+          </a:lnRef>
+          <a:fillRef idx="3">
+            <a:schemeClr val="accent1"/>
+          </a:fillRef>
+          <a:effectRef idx="2">
+            <a:schemeClr val="accent1"/>
+          </a:effectRef>
+          <a:fontRef idx="minor">
+            <a:schemeClr val="lt1"/>
+          </a:fontRef>
+        </p:style>
+        <p:txBody>
+          <a:bodyPr rtlCol="0" anchor="ctr"/>
+          <a:lstStyle/>
+          <a:p>
+            <a:pPr algn="ctr"/>
+          </a:p>
+        </p:txBody>
+      </p:sp>
+      <p:sp>
+        <p:nvSpPr>
+          <p:cNvPr id="6" name="TextBox 5"/>
+          <p:cNvSpPr txBox="1"/>
+          <p:nvPr/>
+        </p:nvSpPr>
+        <p:spPr>
+          <a:xfrm>
+            <a:off x="7680960" y="146304"/>
+            <a:ext cx="1188720" cy="274320"/>
+          </a:xfrm>
+          <a:prstGeom prst="rect">
+            <a:avLst/>
+          </a:prstGeom>
+          <a:noFill/>
+        </p:spPr>
+        <p:txBody>
+          <a:bodyPr wrap="square">
+            <a:spAutoFit/>
+          </a:bodyPr>
+          <a:lstStyle/>
+          <a:p>
+            <a:pPr algn="ctr"/>
+            <a:r>
+              <a:rPr sz="800" b="1">
+                <a:solidFill>
+                  <a:srgbClr val="FFFFFF"/>
+                </a:solidFill>
+              </a:rPr>
+              <a:t>MEDIUM</a:t>
+            </a:r>
+          </a:p>
+        </p:txBody>
+      </p:sp>
+      <p:sp>
+        <p:nvSpPr>
+          <p:cNvPr id="7" name="TextBox 6"/>
+          <p:cNvSpPr txBox="1"/>
+          <p:nvPr/>
+        </p:nvSpPr>
+        <p:spPr>
+          <a:xfrm>
+            <a:off x="274320" y="685800"/>
+            <a:ext cx="8229600" cy="256032"/>
+          </a:xfrm>
+          <a:prstGeom prst="rect">
+            <a:avLst/>
+          </a:prstGeom>
+          <a:noFill/>
+        </p:spPr>
+        <p:txBody>
+          <a:bodyPr wrap="square">
+            <a:spAutoFit/>
+          </a:bodyPr>
+          <a:lstStyle/>
+          <a:p>
+            <a:pPr algn="l"/>
+            <a:r>
+              <a:rPr sz="900" b="0">
+                <a:solidFill>
+                  <a:srgbClr val="64748B"/>
+                </a:solidFill>
+              </a:rPr>
+              <a:t>Insider misuse  ·  Mixed  ·  Confidence: High</a:t>
+            </a:r>
+          </a:p>
+        </p:txBody>
+      </p:sp>
+      <p:sp>
+        <p:nvSpPr>
+          <p:cNvPr id="8" name="Rectangle 7"/>
+          <p:cNvSpPr/>
+          <p:nvPr/>
+        </p:nvSpPr>
+        <p:spPr>
+          <a:xfrm>
+            <a:off x="274320" y="914400"/>
+            <a:ext cx="45720" cy="2377440"/>
+          </a:xfrm>
+          <a:prstGeom prst="rect">
+            <a:avLst/>
+          </a:prstGeom>
+          <a:solidFill>
+            <a:srgbClr val="104277"/>
+          </a:solidFill>
+          <a:ln>
+            <a:noFill/>
+          </a:ln>
+        </p:spPr>
+        <p:style>
+          <a:lnRef idx="1">
+            <a:schemeClr val="accent1"/>
+          </a:lnRef>
+          <a:fillRef idx="3">
+            <a:schemeClr val="accent1"/>
+          </a:fillRef>
+          <a:effectRef idx="2">
+            <a:schemeClr val="accent1"/>
+          </a:effectRef>
+          <a:fontRef idx="minor">
+            <a:schemeClr val="lt1"/>
+          </a:fontRef>
+        </p:style>
+        <p:txBody>
+          <a:bodyPr rtlCol="0" anchor="ctr"/>
+          <a:lstStyle/>
+          <a:p>
+            <a:pPr algn="ctr"/>
+          </a:p>
+        </p:txBody>
+      </p:sp>
+      <p:sp>
+        <p:nvSpPr>
+          <p:cNvPr id="9" name="TextBox 8"/>
+          <p:cNvSpPr txBox="1"/>
+          <p:nvPr/>
+        </p:nvSpPr>
+        <p:spPr>
+          <a:xfrm>
+            <a:off x="365760" y="914400"/>
+            <a:ext cx="4023360" cy="256032"/>
+          </a:xfrm>
+          <a:prstGeom prst="rect">
+            <a:avLst/>
+          </a:prstGeom>
+          <a:noFill/>
+        </p:spPr>
+        <p:txBody>
+          <a:bodyPr wrap="square">
+            <a:spAutoFit/>
+          </a:bodyPr>
+          <a:lstStyle/>
+          <a:p>
+            <a:pPr algn="l"/>
+            <a:r>
+              <a:rPr sz="700" b="1">
+                <a:solidFill>
+                  <a:srgbClr val="64748B"/>
+                </a:solidFill>
+              </a:rPr>
+              <a:t>DRIVER</a:t>
+            </a:r>
+          </a:p>
+        </p:txBody>
+      </p:sp>
+      <p:sp>
+        <p:nvSpPr>
+          <p:cNvPr id="10" name="TextBox 9"/>
+          <p:cNvSpPr txBox="1"/>
+          <p:nvPr/>
+        </p:nvSpPr>
+        <p:spPr>
+          <a:xfrm>
+            <a:off x="365760" y="1170432"/>
+            <a:ext cx="4023360" cy="2121408"/>
+          </a:xfrm>
+          <a:prstGeom prst="rect">
+            <a:avLst/>
+          </a:prstGeom>
+          <a:noFill/>
+        </p:spPr>
+        <p:txBody>
+          <a:bodyPr wrap="square">
+            <a:spAutoFit/>
+          </a:bodyPr>
+          <a:lstStyle/>
+          <a:p>
+            <a:pPr algn="l"/>
+            <a:r>
+              <a:rPr sz="900" b="0">
+                <a:solidFill>
+                  <a:srgbClr val="1E293B"/>
+                </a:solidFill>
+              </a:rPr>
+              <a:t>AeroGrid's ability to sustain offshore blade assembly at Palermo and maintain contracted service delivery for Iberdrola and ENEL across the Mediterranean is being undermined by a convergence of structural instabilities that elevate the risk of insider-enabled harm.</a:t>
+            </a:r>
+          </a:p>
+        </p:txBody>
+      </p:sp>
+      <p:sp>
+        <p:nvSpPr>
+          <p:cNvPr id="11" name="Rectangle 10"/>
+          <p:cNvSpPr/>
+          <p:nvPr/>
+        </p:nvSpPr>
+        <p:spPr>
+          <a:xfrm>
+            <a:off x="4572000" y="914400"/>
+            <a:ext cx="45720" cy="2377440"/>
+          </a:xfrm>
+          <a:prstGeom prst="rect">
+            <a:avLst/>
+          </a:prstGeom>
+          <a:solidFill>
+            <a:srgbClr val="104277"/>
+          </a:solidFill>
+          <a:ln>
+            <a:noFill/>
+          </a:ln>
+        </p:spPr>
+        <p:style>
+          <a:lnRef idx="1">
+            <a:schemeClr val="accent1"/>
+          </a:lnRef>
+          <a:fillRef idx="3">
+            <a:schemeClr val="accent1"/>
+          </a:fillRef>
+          <a:effectRef idx="2">
+            <a:schemeClr val="accent1"/>
+          </a:effectRef>
+          <a:fontRef idx="minor">
+            <a:schemeClr val="lt1"/>
+          </a:fontRef>
+        </p:style>
+        <p:txBody>
+          <a:bodyPr rtlCol="0" anchor="ctr"/>
+          <a:lstStyle/>
+          <a:p>
+            <a:pPr algn="ctr"/>
+          </a:p>
+        </p:txBody>
+      </p:sp>
+      <p:sp>
+        <p:nvSpPr>
+          <p:cNvPr id="12" name="TextBox 11"/>
+          <p:cNvSpPr txBox="1"/>
+          <p:nvPr/>
+        </p:nvSpPr>
+        <p:spPr>
+          <a:xfrm>
+            <a:off x="4663440" y="914400"/>
+            <a:ext cx="4023360" cy="256032"/>
+          </a:xfrm>
+          <a:prstGeom prst="rect">
+            <a:avLst/>
+          </a:prstGeom>
+          <a:noFill/>
+        </p:spPr>
+        <p:txBody>
+          <a:bodyPr wrap="square">
+            <a:spAutoFit/>
+          </a:bodyPr>
+          <a:lstStyle/>
+          <a:p>
+            <a:pPr algn="l"/>
+            <a:r>
+              <a:rPr sz="700" b="1">
+                <a:solidFill>
+                  <a:srgbClr val="64748B"/>
+                </a:solidFill>
+              </a:rPr>
+              <a:t>EXPOSURE</a:t>
+            </a:r>
+          </a:p>
+        </p:txBody>
+      </p:sp>
+      <p:sp>
+        <p:nvSpPr>
+          <p:cNvPr id="13" name="TextBox 12"/>
+          <p:cNvSpPr txBox="1"/>
+          <p:nvPr/>
+        </p:nvSpPr>
+        <p:spPr>
+          <a:xfrm>
+            <a:off x="4663440" y="1170432"/>
+            <a:ext cx="4023360" cy="2121408"/>
+          </a:xfrm>
+          <a:prstGeom prst="rect">
+            <a:avLst/>
+          </a:prstGeom>
+          <a:noFill/>
+        </p:spPr>
+        <p:txBody>
+          <a:bodyPr wrap="square">
+            <a:spAutoFit/>
+          </a:bodyPr>
+          <a:lstStyle/>
+          <a:p>
+            <a:pPr algn="l"/>
+            <a:r>
+              <a:rPr sz="900" b="0">
+                <a:solidFill>
+                  <a:srgbClr val="1E293B"/>
+                </a:solidFill>
+              </a:rPr>
+              <a:t>A corroborated insider misuse incident at a peer Mediterranean energy operator provides direct evidence of the threat vector now facing AeroGrid's MED operations.</a:t>
+            </a:r>
+          </a:p>
+        </p:txBody>
+      </p:sp>
+      <p:sp>
+        <p:nvSpPr>
+          <p:cNvPr id="14" name="Rectangle 13"/>
+          <p:cNvSpPr/>
+          <p:nvPr/>
+        </p:nvSpPr>
+        <p:spPr>
+          <a:xfrm>
+            <a:off x="274320" y="3383280"/>
+            <a:ext cx="45720" cy="2377440"/>
+          </a:xfrm>
+          <a:prstGeom prst="rect">
+            <a:avLst/>
+          </a:prstGeom>
+          <a:solidFill>
             <a:srgbClr val="DC2626"/>
           </a:solidFill>
           <a:ln>
@@ -6268,48 +6793,125 @@
       </p:sp>
       <p:sp>
         <p:nvSpPr>
-          <p:cNvPr id="6" name="TextBox 5"/>
-          <p:cNvSpPr txBox="1"/>
-          <p:nvPr/>
-        </p:nvSpPr>
-        <p:spPr>
-          <a:xfrm>
-            <a:off x="7680960" y="146304"/>
-            <a:ext cx="1188720" cy="274320"/>
-          </a:xfrm>
-          <a:prstGeom prst="rect">
-            <a:avLst/>
-          </a:prstGeom>
-          <a:noFill/>
-        </p:spPr>
-        <p:txBody>
-          <a:bodyPr wrap="square">
-            <a:spAutoFit/>
-          </a:bodyPr>
+          <p:cNvPr id="15" name="TextBox 14"/>
+          <p:cNvSpPr txBox="1"/>
+          <p:nvPr/>
+        </p:nvSpPr>
+        <p:spPr>
+          <a:xfrm>
+            <a:off x="365760" y="3383280"/>
+            <a:ext cx="4023360" cy="256032"/>
+          </a:xfrm>
+          <a:prstGeom prst="rect">
+            <a:avLst/>
+          </a:prstGeom>
+          <a:noFill/>
+        </p:spPr>
+        <p:txBody>
+          <a:bodyPr wrap="square">
+            <a:spAutoFit/>
+          </a:bodyPr>
+          <a:lstStyle/>
+          <a:p>
+            <a:pPr algn="l"/>
+            <a:r>
+              <a:rPr sz="700" b="1">
+                <a:solidFill>
+                  <a:srgbClr val="64748B"/>
+                </a:solidFill>
+              </a:rPr>
+              <a:t>IMPACT</a:t>
+            </a:r>
+          </a:p>
+        </p:txBody>
+      </p:sp>
+      <p:sp>
+        <p:nvSpPr>
+          <p:cNvPr id="16" name="TextBox 15"/>
+          <p:cNvSpPr txBox="1"/>
+          <p:nvPr/>
+        </p:nvSpPr>
+        <p:spPr>
+          <a:xfrm>
+            <a:off x="365760" y="3639312"/>
+            <a:ext cx="4023360" cy="2121408"/>
+          </a:xfrm>
+          <a:prstGeom prst="rect">
+            <a:avLst/>
+          </a:prstGeom>
+          <a:noFill/>
+        </p:spPr>
+        <p:txBody>
+          <a:bodyPr wrap="square">
+            <a:spAutoFit/>
+          </a:bodyPr>
+          <a:lstStyle/>
+          <a:p>
+            <a:pPr algn="l"/>
+            <a:r>
+              <a:rPr sz="900" b="0">
+                <a:solidFill>
+                  <a:srgbClr val="1E293B"/>
+                </a:solidFill>
+              </a:rPr>
+              <a:t>If this access pattern extends to AeroGrid's own contractor workforce at Palermo, the primary operational consequence is disruption to or manipulation of the offshore blade assembly process — a high-value manufacturing capability that underpins regional revenue and supports commitments under the four-year Iberdrola offshore maintenance contract and the ENEL MED service agreement.</a:t>
+            </a:r>
+          </a:p>
+        </p:txBody>
+      </p:sp>
+      <p:sp>
+        <p:nvSpPr>
+          <p:cNvPr id="17" name="Rectangle 16"/>
+          <p:cNvSpPr/>
+          <p:nvPr/>
+        </p:nvSpPr>
+        <p:spPr>
+          <a:xfrm>
+            <a:off x="4572000" y="3383280"/>
+            <a:ext cx="45720" cy="2377440"/>
+          </a:xfrm>
+          <a:prstGeom prst="rect">
+            <a:avLst/>
+          </a:prstGeom>
+          <a:solidFill>
+            <a:srgbClr val="D97706"/>
+          </a:solidFill>
+          <a:ln>
+            <a:noFill/>
+          </a:ln>
+        </p:spPr>
+        <p:style>
+          <a:lnRef idx="1">
+            <a:schemeClr val="accent1"/>
+          </a:lnRef>
+          <a:fillRef idx="3">
+            <a:schemeClr val="accent1"/>
+          </a:fillRef>
+          <a:effectRef idx="2">
+            <a:schemeClr val="accent1"/>
+          </a:effectRef>
+          <a:fontRef idx="minor">
+            <a:schemeClr val="lt1"/>
+          </a:fontRef>
+        </p:style>
+        <p:txBody>
+          <a:bodyPr rtlCol="0" anchor="ctr"/>
           <a:lstStyle/>
           <a:p>
             <a:pPr algn="ctr"/>
-            <a:r>
-              <a:rPr sz="800" b="1">
-                <a:solidFill>
-                  <a:srgbClr val="FFFFFF"/>
-                </a:solidFill>
-              </a:rPr>
-              <a:t>ESCALATED</a:t>
-            </a:r>
-          </a:p>
-        </p:txBody>
-      </p:sp>
-      <p:sp>
-        <p:nvSpPr>
-          <p:cNvPr id="7" name="TextBox 6"/>
-          <p:cNvSpPr txBox="1"/>
-          <p:nvPr/>
-        </p:nvSpPr>
-        <p:spPr>
-          <a:xfrm>
-            <a:off x="274320" y="777240"/>
-            <a:ext cx="1280160" cy="274320"/>
+          </a:p>
+        </p:txBody>
+      </p:sp>
+      <p:sp>
+        <p:nvSpPr>
+          <p:cNvPr id="18" name="TextBox 17"/>
+          <p:cNvSpPr txBox="1"/>
+          <p:nvPr/>
+        </p:nvSpPr>
+        <p:spPr>
+          <a:xfrm>
+            <a:off x="4663440" y="3383280"/>
+            <a:ext cx="4023360" cy="256032"/>
           </a:xfrm>
           <a:prstGeom prst="rect">
             <a:avLst/>
@@ -6324,26 +6926,26 @@
           <a:p>
             <a:pPr algn="l"/>
             <a:r>
-              <a:rPr sz="700" b="0">
+              <a:rPr sz="700" b="1">
                 <a:solidFill>
                   <a:srgbClr val="64748B"/>
                 </a:solidFill>
               </a:rPr>
-              <a:t>VaCR Exposure</a:t>
-            </a:r>
-          </a:p>
-        </p:txBody>
-      </p:sp>
-      <p:sp>
-        <p:nvSpPr>
-          <p:cNvPr id="8" name="TextBox 7"/>
-          <p:cNvSpPr txBox="1"/>
-          <p:nvPr/>
-        </p:nvSpPr>
-        <p:spPr>
-          <a:xfrm>
-            <a:off x="274320" y="1069848"/>
-            <a:ext cx="1280160" cy="640080"/>
+              <a:t>WATCH</a:t>
+            </a:r>
+          </a:p>
+        </p:txBody>
+      </p:sp>
+      <p:sp>
+        <p:nvSpPr>
+          <p:cNvPr id="19" name="TextBox 18"/>
+          <p:cNvSpPr txBox="1"/>
+          <p:nvPr/>
+        </p:nvSpPr>
+        <p:spPr>
+          <a:xfrm>
+            <a:off x="4663440" y="3639312"/>
+            <a:ext cx="4023360" cy="2121408"/>
           </a:xfrm>
           <a:prstGeom prst="rect">
             <a:avLst/>
@@ -6358,26 +6960,26 @@
           <a:p>
             <a:pPr algn="l"/>
             <a:r>
-              <a:rPr sz="1600" b="1">
-                <a:solidFill>
-                  <a:srgbClr val="104277"/>
-                </a:solidFill>
-              </a:rPr>
-              <a:t>$4.2M</a:t>
-            </a:r>
-          </a:p>
-        </p:txBody>
-      </p:sp>
-      <p:sp>
-        <p:nvSpPr>
-          <p:cNvPr id="9" name="TextBox 8"/>
-          <p:cNvSpPr txBox="1"/>
-          <p:nvPr/>
-        </p:nvSpPr>
-        <p:spPr>
-          <a:xfrm>
-            <a:off x="274320" y="2194560"/>
-            <a:ext cx="1280160" cy="274320"/>
+              <a:rPr sz="900" b="0">
+                <a:solidFill>
+                  <a:srgbClr val="1E293B"/>
+                </a:solidFill>
+              </a:rPr>
+              <a:t>The forward indicator to watch is contractor access review completion rates at Palermo against the backdrop of any workforce restructuring driven by EU supplier regulation changes; a gap there would confirm that the conditions documented at the peer operator are replicable at AeroGrid's highest-risk MED site.</a:t>
+            </a:r>
+          </a:p>
+        </p:txBody>
+      </p:sp>
+      <p:sp>
+        <p:nvSpPr>
+          <p:cNvPr id="20" name="TextBox 19"/>
+          <p:cNvSpPr txBox="1"/>
+          <p:nvPr/>
+        </p:nvSpPr>
+        <p:spPr>
+          <a:xfrm>
+            <a:off x="274320" y="5852160"/>
+            <a:ext cx="2286000" cy="274320"/>
           </a:xfrm>
           <a:prstGeom prst="rect">
             <a:avLst/>
@@ -6392,26 +6994,26 @@
           <a:p>
             <a:pPr algn="l"/>
             <a:r>
-              <a:rPr sz="700" b="0">
+              <a:rPr sz="800" b="0">
                 <a:solidFill>
                   <a:srgbClr val="64748B"/>
                 </a:solidFill>
               </a:rPr>
-              <a:t>Admiralty</a:t>
-            </a:r>
-          </a:p>
-        </p:txBody>
-      </p:sp>
-      <p:sp>
-        <p:nvSpPr>
-          <p:cNvPr id="10" name="TextBox 9"/>
-          <p:cNvSpPr txBox="1"/>
-          <p:nvPr/>
-        </p:nvSpPr>
-        <p:spPr>
-          <a:xfrm>
-            <a:off x="274320" y="2487168"/>
-            <a:ext cx="1280160" cy="640080"/>
+              <a:t>→ Stable</a:t>
+            </a:r>
+          </a:p>
+        </p:txBody>
+      </p:sp>
+      <p:sp>
+        <p:nvSpPr>
+          <p:cNvPr id="21" name="TextBox 20"/>
+          <p:cNvSpPr txBox="1"/>
+          <p:nvPr/>
+        </p:nvSpPr>
+        <p:spPr>
+          <a:xfrm>
+            <a:off x="2743200" y="5852160"/>
+            <a:ext cx="5943600" cy="274320"/>
           </a:xfrm>
           <a:prstGeom prst="rect">
             <a:avLst/>
@@ -6426,352 +7028,12 @@
           <a:p>
             <a:pPr algn="l"/>
             <a:r>
-              <a:rPr sz="1600" b="1">
-                <a:solidFill>
-                  <a:srgbClr val="104277"/>
-                </a:solidFill>
-              </a:rPr>
-              <a:t>B2</a:t>
-            </a:r>
-          </a:p>
-        </p:txBody>
-      </p:sp>
-      <p:sp>
-        <p:nvSpPr>
-          <p:cNvPr id="11" name="TextBox 10"/>
-          <p:cNvSpPr txBox="1"/>
-          <p:nvPr/>
-        </p:nvSpPr>
-        <p:spPr>
-          <a:xfrm>
-            <a:off x="274320" y="3611880"/>
-            <a:ext cx="1280160" cy="274320"/>
-          </a:xfrm>
-          <a:prstGeom prst="rect">
-            <a:avLst/>
-          </a:prstGeom>
-          <a:noFill/>
-        </p:spPr>
-        <p:txBody>
-          <a:bodyPr wrap="square">
-            <a:spAutoFit/>
-          </a:bodyPr>
-          <a:lstStyle/>
-          <a:p>
-            <a:pPr algn="l"/>
-            <a:r>
-              <a:rPr sz="700" b="0">
+              <a:rPr sz="800" b="0">
                 <a:solidFill>
                   <a:srgbClr val="64748B"/>
                 </a:solidFill>
               </a:rPr>
-              <a:t>Velocity</a:t>
-            </a:r>
-          </a:p>
-        </p:txBody>
-      </p:sp>
-      <p:sp>
-        <p:nvSpPr>
-          <p:cNvPr id="12" name="TextBox 11"/>
-          <p:cNvSpPr txBox="1"/>
-          <p:nvPr/>
-        </p:nvSpPr>
-        <p:spPr>
-          <a:xfrm>
-            <a:off x="274320" y="3904488"/>
-            <a:ext cx="1280160" cy="640080"/>
-          </a:xfrm>
-          <a:prstGeom prst="rect">
-            <a:avLst/>
-          </a:prstGeom>
-          <a:noFill/>
-        </p:spPr>
-        <p:txBody>
-          <a:bodyPr wrap="square">
-            <a:spAutoFit/>
-          </a:bodyPr>
-          <a:lstStyle/>
-          <a:p>
-            <a:pPr algn="l"/>
-            <a:r>
-              <a:rPr sz="1600" b="1">
-                <a:solidFill>
-                  <a:srgbClr val="64748B"/>
-                </a:solidFill>
-              </a:rPr>
-              <a:t>→ Stable</a:t>
-            </a:r>
-          </a:p>
-        </p:txBody>
-      </p:sp>
-      <p:sp>
-        <p:nvSpPr>
-          <p:cNvPr id="13" name="TextBox 12"/>
-          <p:cNvSpPr txBox="1"/>
-          <p:nvPr/>
-        </p:nvSpPr>
-        <p:spPr>
-          <a:xfrm>
-            <a:off x="274320" y="5029200"/>
-            <a:ext cx="1280160" cy="274320"/>
-          </a:xfrm>
-          <a:prstGeom prst="rect">
-            <a:avLst/>
-          </a:prstGeom>
-          <a:noFill/>
-        </p:spPr>
-        <p:txBody>
-          <a:bodyPr wrap="square">
-            <a:spAutoFit/>
-          </a:bodyPr>
-          <a:lstStyle/>
-          <a:p>
-            <a:pPr algn="l"/>
-            <a:r>
-              <a:rPr sz="700" b="0">
-                <a:solidFill>
-                  <a:srgbClr val="64748B"/>
-                </a:solidFill>
-              </a:rPr>
-              <a:t>Severity</a:t>
-            </a:r>
-          </a:p>
-        </p:txBody>
-      </p:sp>
-      <p:sp>
-        <p:nvSpPr>
-          <p:cNvPr id="14" name="TextBox 13"/>
-          <p:cNvSpPr txBox="1"/>
-          <p:nvPr/>
-        </p:nvSpPr>
-        <p:spPr>
-          <a:xfrm>
-            <a:off x="274320" y="5321808"/>
-            <a:ext cx="1280160" cy="640080"/>
-          </a:xfrm>
-          <a:prstGeom prst="rect">
-            <a:avLst/>
-          </a:prstGeom>
-          <a:noFill/>
-        </p:spPr>
-        <p:txBody>
-          <a:bodyPr wrap="square">
-            <a:spAutoFit/>
-          </a:bodyPr>
-          <a:lstStyle/>
-          <a:p>
-            <a:pPr algn="l"/>
-            <a:r>
-              <a:rPr sz="1600" b="1">
-                <a:solidFill>
-                  <a:srgbClr val="D97706"/>
-                </a:solidFill>
-              </a:rPr>
-              <a:t>MEDIUM</a:t>
-            </a:r>
-          </a:p>
-        </p:txBody>
-      </p:sp>
-      <p:sp>
-        <p:nvSpPr>
-          <p:cNvPr id="15" name="TextBox 14"/>
-          <p:cNvSpPr txBox="1"/>
-          <p:nvPr/>
-        </p:nvSpPr>
-        <p:spPr>
-          <a:xfrm>
-            <a:off x="1737360" y="777240"/>
-            <a:ext cx="7132320" cy="256032"/>
-          </a:xfrm>
-          <a:prstGeom prst="rect">
-            <a:avLst/>
-          </a:prstGeom>
-          <a:noFill/>
-        </p:spPr>
-        <p:txBody>
-          <a:bodyPr wrap="square">
-            <a:spAutoFit/>
-          </a:bodyPr>
-          <a:lstStyle/>
-          <a:p>
-            <a:pPr algn="l"/>
-            <a:r>
-              <a:rPr sz="800" b="1">
-                <a:solidFill>
-                  <a:srgbClr val="104277"/>
-                </a:solidFill>
-              </a:rPr>
-              <a:t>WHY — GEOPOLITICAL DRIVER</a:t>
-            </a:r>
-          </a:p>
-        </p:txBody>
-      </p:sp>
-      <p:sp>
-        <p:nvSpPr>
-          <p:cNvPr id="16" name="TextBox 15"/>
-          <p:cNvSpPr txBox="1"/>
-          <p:nvPr/>
-        </p:nvSpPr>
-        <p:spPr>
-          <a:xfrm>
-            <a:off x="1737360" y="1051560"/>
-            <a:ext cx="7132320" cy="1371600"/>
-          </a:xfrm>
-          <a:prstGeom prst="rect">
-            <a:avLst/>
-          </a:prstGeom>
-          <a:noFill/>
-        </p:spPr>
-        <p:txBody>
-          <a:bodyPr wrap="square">
-            <a:spAutoFit/>
-          </a:bodyPr>
-          <a:lstStyle/>
-          <a:p>
-            <a:pPr algn="l"/>
-            <a:r>
-              <a:rPr sz="900" b="0">
-                <a:solidFill>
-                  <a:srgbClr val="1E293B"/>
-                </a:solidFill>
-              </a:rPr>
-              <a:t>Prolonged economic instability across southern Europe is undermining the reliability of AeroGrid's service and maintenance workforce in the Mediterranean region. Austerity measures and persistently high unemployment in key operating markets are creating financial stress conditions that elevate the risk of personnel seeking unauthorized income from proprietary company data. Simultaneously, the Euro</a:t>
-            </a:r>
-          </a:p>
-        </p:txBody>
-      </p:sp>
-      <p:sp>
-        <p:nvSpPr>
-          <p:cNvPr id="17" name="TextBox 16"/>
-          <p:cNvSpPr txBox="1"/>
-          <p:nvPr/>
-        </p:nvSpPr>
-        <p:spPr>
-          <a:xfrm>
-            <a:off x="1737360" y="2697480"/>
-            <a:ext cx="7132320" cy="256032"/>
-          </a:xfrm>
-          <a:prstGeom prst="rect">
-            <a:avLst/>
-          </a:prstGeom>
-          <a:noFill/>
-        </p:spPr>
-        <p:txBody>
-          <a:bodyPr wrap="square">
-            <a:spAutoFit/>
-          </a:bodyPr>
-          <a:lstStyle/>
-          <a:p>
-            <a:pPr algn="l"/>
-            <a:r>
-              <a:rPr sz="800" b="1">
-                <a:solidFill>
-                  <a:srgbClr val="104277"/>
-                </a:solidFill>
-              </a:rPr>
-              <a:t>HOW — CYBER VECTOR</a:t>
-            </a:r>
-          </a:p>
-        </p:txBody>
-      </p:sp>
-      <p:sp>
-        <p:nvSpPr>
-          <p:cNvPr id="18" name="TextBox 17"/>
-          <p:cNvSpPr txBox="1"/>
-          <p:nvPr/>
-        </p:nvSpPr>
-        <p:spPr>
-          <a:xfrm>
-            <a:off x="1737360" y="2971800"/>
-            <a:ext cx="7132320" cy="1371600"/>
-          </a:xfrm>
-          <a:prstGeom prst="rect">
-            <a:avLst/>
-          </a:prstGeom>
-          <a:noFill/>
-        </p:spPr>
-        <p:txBody>
-          <a:bodyPr wrap="square">
-            <a:spAutoFit/>
-          </a:bodyPr>
-          <a:lstStyle/>
-          <a:p>
-            <a:pPr algn="l"/>
-            <a:r>
-              <a:rPr sz="900" b="0">
-                <a:solidFill>
-                  <a:srgbClr val="1E293B"/>
-                </a:solidFill>
-              </a:rPr>
-              <a:t>This geopolitical pressure is materializing through anomalous access patterns on two of AeroGrid's crown jewels: the real-time predictive maintenance algorithms and offshore servicing contract documentation. Signals indicate that a former maintenance contractor retained active system credentials for six months after contract termination, with access events inconsistent with any operational role — </a:t>
-            </a:r>
-          </a:p>
-        </p:txBody>
-      </p:sp>
-      <p:sp>
-        <p:nvSpPr>
-          <p:cNvPr id="19" name="TextBox 18"/>
-          <p:cNvSpPr txBox="1"/>
-          <p:nvPr/>
-        </p:nvSpPr>
-        <p:spPr>
-          <a:xfrm>
-            <a:off x="1737360" y="4617720"/>
-            <a:ext cx="7132320" cy="256032"/>
-          </a:xfrm>
-          <a:prstGeom prst="rect">
-            <a:avLst/>
-          </a:prstGeom>
-          <a:noFill/>
-        </p:spPr>
-        <p:txBody>
-          <a:bodyPr wrap="square">
-            <a:spAutoFit/>
-          </a:bodyPr>
-          <a:lstStyle/>
-          <a:p>
-            <a:pPr algn="l"/>
-            <a:r>
-              <a:rPr sz="800" b="1">
-                <a:solidFill>
-                  <a:srgbClr val="104277"/>
-                </a:solidFill>
-              </a:rPr>
-              <a:t>SO WHAT — BUSINESS IMPACT</a:t>
-            </a:r>
-          </a:p>
-        </p:txBody>
-      </p:sp>
-      <p:sp>
-        <p:nvSpPr>
-          <p:cNvPr id="20" name="TextBox 19"/>
-          <p:cNvSpPr txBox="1"/>
-          <p:nvPr/>
-        </p:nvSpPr>
-        <p:spPr>
-          <a:xfrm>
-            <a:off x="1737360" y="4892040"/>
-            <a:ext cx="7132320" cy="1371600"/>
-          </a:xfrm>
-          <a:prstGeom prst="rect">
-            <a:avLst/>
-          </a:prstGeom>
-          <a:noFill/>
-        </p:spPr>
-        <p:txBody>
-          <a:bodyPr wrap="square">
-            <a:spAutoFit/>
-          </a:bodyPr>
-          <a:lstStyle/>
-          <a:p>
-            <a:pPr algn="l"/>
-            <a:r>
-              <a:rPr sz="900" b="0">
-                <a:solidFill>
-                  <a:srgbClr val="1E293B"/>
-                </a:solidFill>
-              </a:rPr>
-              <a:t>The value at cyber risk for the Mediterranean region stands at $4,200,000. This pattern is consistent with the Insider misuse scenario, ranked #4 globally by financial impact (4.4% of all industry losses) and #5 by event frequency. While Insider misuse incidents occur less frequently than external intrusions, the signals here reflect both a sustained trend of deteriorating workforce financial cond</a:t>
+              <a:t>State-directed threat</a:t>
             </a:r>
           </a:p>
         </p:txBody>
@@ -7036,7 +7298,7 @@
                   <a:srgbClr val="1E293B"/>
                 </a:solidFill>
               </a:rPr>
-              <a:t>Pipeline ID:  crq-2026-03-12T190254Z</a:t>
+              <a:t>Pipeline ID:  crq-2026-03-26T164449Z</a:t>
             </a:r>
           </a:p>
         </p:txBody>
@@ -7070,7 +7332,7 @@
                   <a:srgbClr val="1E293B"/>
                 </a:solidFill>
               </a:rPr>
-              <a:t>Timestamp:  2026-03-12T19:02:54Z</a:t>
+              <a:t>Timestamp:  2026-03-26T16:44:49Z</a:t>
             </a:r>
           </a:p>
         </p:txBody>

</xml_diff>